<commit_message>
Seminar v3: apply review fixes (accounted size wording, references, adaptive P<=6 wording, epsilon, slide 6 table)
Co-Authored-By: Claude Sonnet 5.5 <noreply@anthropic.com>
Claude-Session: https://claude.ai/code/session_01T6gEewJ8YaCdmnsfS34RJd
</commit_message>
<xml_diff>
--- a/results/seminar/figs/Seminar_Ibtihal_v3.pptx
+++ b/results/seminar/figs/Seminar_Ibtihal_v3.pptx
@@ -5378,7 +5378,7 @@
                 <a:ea typeface="Calibri" pitchFamily="34" charset="-122"/>
                 <a:cs typeface="Calibri" pitchFamily="34" charset="-120"/>
               </a:rPr>
-              <a:t>3. Compressed data</a:t>
+              <a:t>3. Compressed size</a:t>
             </a:r>
             <a:endParaRPr lang="en-US" sz="1600" dirty="0"/>
           </a:p>
@@ -5395,7 +5395,7 @@
                 <a:ea typeface="Calibri" pitchFamily="34" charset="-122"/>
                 <a:cs typeface="Calibri" pitchFamily="34" charset="-120"/>
               </a:rPr>
-              <a:t>codebook + Huffman</a:t>
+              <a:t>codebook + Huffman table</a:t>
             </a:r>
             <a:endParaRPr lang="en-US" sz="1600" dirty="0"/>
           </a:p>
@@ -5412,7 +5412,7 @@
                 <a:ea typeface="Calibri" pitchFamily="34" charset="-122"/>
                 <a:cs typeface="Calibri" pitchFamily="34" charset="-120"/>
               </a:rPr>
-              <a:t>table + coded indices</a:t>
+              <a:t>+ coded indices</a:t>
             </a:r>
             <a:endParaRPr lang="en-US" sz="1600" dirty="0"/>
           </a:p>
@@ -5451,7 +5451,7 @@
                 <a:ea typeface="Calibri" pitchFamily="34" charset="-122"/>
                 <a:cs typeface="Calibri" pitchFamily="34" charset="-120"/>
               </a:rPr>
-              <a:t>compressed data: codebook + Huffman table + coded indices</a:t>
+              <a:t>accounted size: codebook + Huffman table + coded indices</a:t>
             </a:r>
             <a:endParaRPr lang="en-US" sz="1300" dirty="0"/>
           </a:p>
@@ -8201,7 +8201,7 @@
                 <a:ea typeface="Calibri" pitchFamily="34" charset="-122"/>
                 <a:cs typeface="Calibri" pitchFamily="34" charset="-120"/>
               </a:rPr>
-              <a:t>Output: Huffman table (header) and the encoded bitstream.</a:t>
+              <a:t>Output: the Huffman codes and the encoded bitstream.</a:t>
             </a:r>
             <a:endParaRPr lang="en-US" sz="1900" dirty="0"/>
           </a:p>
@@ -8222,7 +8222,7 @@
                 <a:ea typeface="Calibri" pitchFamily="34" charset="-122"/>
                 <a:cs typeface="Calibri" pitchFamily="34" charset="-120"/>
               </a:rPr>
-              <a:t>Compressed size = codebook (K × 16 bytes) + Huffman table + Huffman-coded data.</a:t>
+              <a:t>Accounted compressed size = codebook (K × 16 bytes, one byte per codeword element) + Huffman table + Huffman-coded data.</a:t>
             </a:r>
             <a:endParaRPr lang="en-US" sz="1900" dirty="0"/>
           </a:p>
@@ -8243,7 +8243,7 @@
                 <a:ea typeface="Calibri" pitchFamily="34" charset="-122"/>
                 <a:cs typeface="Calibri" pitchFamily="34" charset="-120"/>
               </a:rPr>
-              <a:t>The table is accounted as 5 bytes per used symbol (1 byte symbol + 4 bytes frequency) plus 10 bytes of fixed metadata.</a:t>
+              <a:t>The table is accounted as 5 bytes per used symbol (1 byte symbol + 4 bytes frequency) plus 10 bytes of fixed metadata. The program accounts this size; it does not write a stand-alone compressed file.</a:t>
             </a:r>
             <a:endParaRPr lang="en-US" sz="1900" dirty="0"/>
           </a:p>
@@ -9774,7 +9774,7 @@
                 <a:ea typeface="Calibri" pitchFamily="34" charset="-122"/>
                 <a:cs typeface="Calibri" pitchFamily="34" charset="-120"/>
               </a:rPr>
-              <a:t>4 × 4 blocks, K = 64 codewords, δ = 0.01, convergence threshold ε, at most 100 iterations per level.</a:t>
+              <a:t>4 × 4 blocks, K = 64 codewords, δ = 0.01, ε = 10⁻⁴ (relative improvement in distortion), at most 100 iterations per level.</a:t>
             </a:r>
             <a:endParaRPr lang="en-US" sz="2000" dirty="0"/>
           </a:p>
@@ -11765,7 +11765,7 @@
                 <a:ea typeface="Calibri" pitchFamily="34" charset="-122"/>
                 <a:cs typeface="Calibri" pitchFamily="34" charset="-120"/>
               </a:rPr>
-              <a:t>S_comp = codebook (K × 16 bytes) + Huffman table + Huffman-coded data. The table is accounted as 5 bytes per used symbol (1 byte symbol + 4 bytes frequency) plus 10 bytes of fixed metadata. For color images, MSE and PSNR are computed over RGB and SSIM is the mean of the channels.</a:t>
+              <a:t>S_comp = accounted compressed size = codebook (K × 16 bytes, one byte per element) + Huffman table + Huffman-coded data. The table is accounted as 5 bytes per used symbol (1 byte symbol + 4 bytes frequency) plus 10 bytes of fixed metadata. For color images, MSE and PSNR are computed over RGB and SSIM is the mean of the channels.</a:t>
             </a:r>
             <a:endParaRPr lang="en-US" sz="1300" dirty="0"/>
           </a:p>
@@ -22523,7 +22523,7 @@
                 <a:ea typeface="Calibri" pitchFamily="34" charset="-122"/>
                 <a:cs typeface="Calibri" pitchFamily="34" charset="-120"/>
               </a:rPr>
-              <a:t>For P ≤ 6 (P-cores only) the two strategies are equivalent.</a:t>
+              <a:t>No adaptive-distribution benefit was observed when only P-cores were used (P ≤ 6).</a:t>
             </a:r>
             <a:endParaRPr lang="en-US" sz="1500" dirty="0"/>
           </a:p>
@@ -26646,7 +26646,7 @@
                 <a:ea typeface="Calibri" pitchFamily="34" charset="-122"/>
                 <a:cs typeface="Calibri" pitchFamily="34" charset="-120"/>
               </a:rPr>
-              <a:t>Implement a complete container file format with a stored Huffman header and a stand-alone decoder.</a:t>
+              <a:t>Implement a complete container file format (stored Huffman table and header) with a stand-alone decoder; the current program only accounts the compressed size.</a:t>
             </a:r>
             <a:endParaRPr lang="en-US" sz="2100" dirty="0"/>
           </a:p>
@@ -27434,7 +27434,7 @@
               <a:buChar char="■"/>
             </a:pPr>
             <a:r>
-              <a:rPr lang="en-US" sz="1900" dirty="0">
+              <a:rPr lang="en-US" sz="1600" dirty="0">
                 <a:solidFill>
                   <a:srgbClr val="1F1A33"/>
                 </a:solidFill>
@@ -27442,9 +27442,9 @@
                 <a:ea typeface="Calibri" pitchFamily="34" charset="-122"/>
                 <a:cs typeface="Calibri" pitchFamily="34" charset="-120"/>
               </a:rPr>
-              <a:t>Linde, Buzo and Gray (1980): the LBG algorithm.</a:t>
-            </a:r>
-            <a:endParaRPr lang="en-US" sz="1900" dirty="0"/>
+              <a:t>[6] Thomas, S., Krishna, A., Govind, S., Sahu, A.K. (2025). A novel image compression method using wavelet coefficients and Huffman coding. J. Eng. Res., 13(1): 361-370.</a:t>
+            </a:r>
+            <a:endParaRPr lang="en-US" sz="1600" dirty="0"/>
           </a:p>
           <a:p>
             <a:pPr marL="342900" indent="-342900">
@@ -27455,7 +27455,7 @@
               <a:buChar char="■"/>
             </a:pPr>
             <a:r>
-              <a:rPr lang="en-US" sz="1900" dirty="0">
+              <a:rPr lang="en-US" sz="1600" dirty="0">
                 <a:solidFill>
                   <a:srgbClr val="1F1A33"/>
                 </a:solidFill>
@@ -27463,9 +27463,9 @@
                 <a:ea typeface="Calibri" pitchFamily="34" charset="-122"/>
                 <a:cs typeface="Calibri" pitchFamily="34" charset="-120"/>
               </a:rPr>
-              <a:t>Thomas et al. (2025);  Ranjan and Kumar (2023);  Bilal et al. (2024);  Paul et al. (2024).</a:t>
-            </a:r>
-            <a:endParaRPr lang="en-US" sz="1900" dirty="0"/>
+              <a:t>[16] Ranjan, R., Kumar, P. (2023). An improved image compression algorithm using 2D DWT and PCA with canonical Huffman encoding. Entropy, 25(10): 1382.</a:t>
+            </a:r>
+            <a:endParaRPr lang="en-US" sz="1600" dirty="0"/>
           </a:p>
           <a:p>
             <a:pPr marL="342900" indent="-342900">
@@ -27476,7 +27476,7 @@
               <a:buChar char="■"/>
             </a:pPr>
             <a:r>
-              <a:rPr lang="en-US" sz="1900" dirty="0">
+              <a:rPr lang="en-US" sz="1600" dirty="0">
                 <a:solidFill>
                   <a:srgbClr val="1F1A33"/>
                 </a:solidFill>
@@ -27484,9 +27484,9 @@
                 <a:ea typeface="Calibri" pitchFamily="34" charset="-122"/>
                 <a:cs typeface="Calibri" pitchFamily="34" charset="-120"/>
               </a:rPr>
-              <a:t>Tanović et al. (2024);  Papakyriakou et al. (2025);  Bystrov et al. (2023);  Zangana (2025).</a:t>
-            </a:r>
-            <a:endParaRPr lang="en-US" sz="1900" dirty="0"/>
+              <a:t>[17] Bilal, M., Ullah, Z., Mujahid, O., Fouzder, T. (2024). Fast Linde–Buzo–Gray (FLBG) algorithm for image compression through rescaling using bilinear interpolation. J. Imaging, 10(5): 124.</a:t>
+            </a:r>
+            <a:endParaRPr lang="en-US" sz="1600" dirty="0"/>
           </a:p>
           <a:p>
             <a:pPr marL="342900" indent="-342900">
@@ -27497,7 +27497,7 @@
               <a:buChar char="■"/>
             </a:pPr>
             <a:r>
-              <a:rPr lang="en-US" sz="1900" dirty="0">
+              <a:rPr lang="en-US" sz="1600" dirty="0">
                 <a:solidFill>
                   <a:srgbClr val="1F1A33"/>
                 </a:solidFill>
@@ -27505,9 +27505,30 @@
                 <a:ea typeface="Calibri" pitchFamily="34" charset="-122"/>
                 <a:cs typeface="Calibri" pitchFamily="34" charset="-120"/>
               </a:rPr>
-              <a:t>(Replace this slide with the full reference list from the thesis, in the same numbering.)</a:t>
-            </a:r>
-            <a:endParaRPr lang="en-US" sz="1900" dirty="0"/>
+              <a:t>Linde, Y., Buzo, A., Gray, R.M. (1980). An algorithm for vector quantizer design. IEEE Trans. Commun., 28(1): 84-95.</a:t>
+            </a:r>
+            <a:endParaRPr lang="en-US" sz="1600" dirty="0"/>
+          </a:p>
+          <a:p>
+            <a:pPr marL="342900" indent="-342900">
+              <a:spcAft>
+                <a:spcPts val="1000"/>
+              </a:spcAft>
+              <a:buSzPct val="100000"/>
+              <a:buChar char="■"/>
+            </a:pPr>
+            <a:r>
+              <a:rPr lang="en-US" sz="1600" dirty="0">
+                <a:solidFill>
+                  <a:srgbClr val="1F1A33"/>
+                </a:solidFill>
+                <a:latin typeface="Calibri" pitchFamily="34" charset="0"/>
+                <a:ea typeface="Calibri" pitchFamily="34" charset="-122"/>
+                <a:cs typeface="Calibri" pitchFamily="34" charset="-120"/>
+              </a:rPr>
+              <a:t>Tanović, A. et al. (2024). ZINC 2024.  Papakyriakou, D. et al. (2025). Int. J. Comput. Appl.  Bystrov, O. et al. (2023). Proc. 7th Int. Conf. on Parallel, Distributed, GPU and Cloud Computing for Engineering.  Paul, R.K. et al. (2024).  Zangana, H.M. (2025).</a:t>
+            </a:r>
+            <a:endParaRPr lang="en-US" sz="1600" dirty="0"/>
           </a:p>
         </p:txBody>
       </p:sp>
@@ -28709,12 +28730,11 @@
             <a:tbl>
               <a:tblPr/>
               <a:tblGrid>
-                <a:gridCol w="914400"/>
-                <a:gridCol w="1645920"/>
-                <a:gridCol w="3108960"/>
-                <a:gridCol w="1371600"/>
+                <a:gridCol w="1097280"/>
                 <a:gridCol w="2011680"/>
+                <a:gridCol w="3840480"/>
                 <a:gridCol w="1828800"/>
+                <a:gridCol w="2103120"/>
               </a:tblGrid>
               <a:tr h="457200">
                 <a:tc>
@@ -29007,74 +29027,6 @@
                           <a:cs typeface="Calibri" pitchFamily="34" charset="-120"/>
                         </a:rPr>
                         <a:t>PSNR (dB)</a:t>
-                      </a:r>
-                      <a:endParaRPr lang="en-US" sz="1400" dirty="0">
-                        <a:latin typeface="Calibri" charset="0"/>
-                        <a:ea typeface="Calibri" charset="0"/>
-                        <a:cs typeface="Calibri" charset="0"/>
-                      </a:endParaRPr>
-                    </a:p>
-                  </a:txBody>
-                  <a:tcPr marL="91440" marR="91440" marT="45720" marB="45720" anchor="ctr">
-                    <a:lnL w="12700" cap="flat" cmpd="sng" algn="ctr">
-                      <a:solidFill>
-                        <a:srgbClr val="E2D9F3"/>
-                      </a:solidFill>
-                      <a:prstDash val="solid"/>
-                      <a:round/>
-                      <a:headEnd type="none" w="med" len="med"/>
-                      <a:tailEnd type="none" w="med" len="med"/>
-                    </a:lnL>
-                    <a:lnR w="12700" cap="flat" cmpd="sng" algn="ctr">
-                      <a:solidFill>
-                        <a:srgbClr val="E2D9F3"/>
-                      </a:solidFill>
-                      <a:prstDash val="solid"/>
-                      <a:round/>
-                      <a:headEnd type="none" w="med" len="med"/>
-                      <a:tailEnd type="none" w="med" len="med"/>
-                    </a:lnR>
-                    <a:lnT w="12700" cap="flat" cmpd="sng" algn="ctr">
-                      <a:solidFill>
-                        <a:srgbClr val="E2D9F3"/>
-                      </a:solidFill>
-                      <a:prstDash val="solid"/>
-                      <a:round/>
-                      <a:headEnd type="none" w="med" len="med"/>
-                      <a:tailEnd type="none" w="med" len="med"/>
-                    </a:lnT>
-                    <a:lnB w="12700" cap="flat" cmpd="sng" algn="ctr">
-                      <a:solidFill>
-                        <a:srgbClr val="E2D9F3"/>
-                      </a:solidFill>
-                      <a:prstDash val="solid"/>
-                      <a:round/>
-                      <a:headEnd type="none" w="med" len="med"/>
-                      <a:tailEnd type="none" w="med" len="med"/>
-                    </a:lnB>
-                    <a:solidFill>
-                      <a:srgbClr val="6B4FA3"/>
-                    </a:solidFill>
-                  </a:tcPr>
-                </a:tc>
-                <a:tc>
-                  <a:txBody>
-                    <a:bodyPr/>
-                    <a:lstStyle/>
-                    <a:p>
-                      <a:pPr algn="ctr" indent="0" marL="0">
-                        <a:buNone/>
-                      </a:pPr>
-                      <a:r>
-                        <a:rPr lang="en-US" sz="1400" b="1" dirty="0">
-                          <a:solidFill>
-                            <a:srgbClr val="FFFFFF"/>
-                          </a:solidFill>
-                          <a:latin typeface="Calibri" pitchFamily="34" charset="0"/>
-                          <a:ea typeface="Calibri" pitchFamily="34" charset="-122"/>
-                          <a:cs typeface="Calibri" pitchFamily="34" charset="-120"/>
-                        </a:rPr>
-                        <a:t>Time ratio</a:t>
                       </a:r>
                       <a:endParaRPr lang="en-US" sz="1400" dirty="0">
                         <a:latin typeface="Calibri" charset="0"/>
@@ -29467,74 +29419,6 @@
                     </a:solidFill>
                   </a:tcPr>
                 </a:tc>
-                <a:tc>
-                  <a:txBody>
-                    <a:bodyPr/>
-                    <a:lstStyle/>
-                    <a:p>
-                      <a:pPr algn="ctr" indent="0" marL="0">
-                        <a:buNone/>
-                      </a:pPr>
-                      <a:r>
-                        <a:rPr lang="en-US" sz="1300" dirty="0">
-                          <a:solidFill>
-                            <a:srgbClr val="1F1A33"/>
-                          </a:solidFill>
-                          <a:latin typeface="Calibri" pitchFamily="34" charset="0"/>
-                          <a:ea typeface="Calibri" pitchFamily="34" charset="-122"/>
-                          <a:cs typeface="Calibri" pitchFamily="34" charset="-120"/>
-                        </a:rPr>
-                        <a:t>–</a:t>
-                      </a:r>
-                      <a:endParaRPr lang="en-US" sz="1300" dirty="0">
-                        <a:latin typeface="Calibri" charset="0"/>
-                        <a:ea typeface="Calibri" charset="0"/>
-                        <a:cs typeface="Calibri" charset="0"/>
-                      </a:endParaRPr>
-                    </a:p>
-                  </a:txBody>
-                  <a:tcPr marL="91440" marR="91440" marT="45720" marB="45720" anchor="ctr">
-                    <a:lnL w="12700" cap="flat" cmpd="sng" algn="ctr">
-                      <a:solidFill>
-                        <a:srgbClr val="E2D9F3"/>
-                      </a:solidFill>
-                      <a:prstDash val="solid"/>
-                      <a:round/>
-                      <a:headEnd type="none" w="med" len="med"/>
-                      <a:tailEnd type="none" w="med" len="med"/>
-                    </a:lnL>
-                    <a:lnR w="12700" cap="flat" cmpd="sng" algn="ctr">
-                      <a:solidFill>
-                        <a:srgbClr val="E2D9F3"/>
-                      </a:solidFill>
-                      <a:prstDash val="solid"/>
-                      <a:round/>
-                      <a:headEnd type="none" w="med" len="med"/>
-                      <a:tailEnd type="none" w="med" len="med"/>
-                    </a:lnR>
-                    <a:lnT w="12700" cap="flat" cmpd="sng" algn="ctr">
-                      <a:solidFill>
-                        <a:srgbClr val="E2D9F3"/>
-                      </a:solidFill>
-                      <a:prstDash val="solid"/>
-                      <a:round/>
-                      <a:headEnd type="none" w="med" len="med"/>
-                      <a:tailEnd type="none" w="med" len="med"/>
-                    </a:lnT>
-                    <a:lnB w="12700" cap="flat" cmpd="sng" algn="ctr">
-                      <a:solidFill>
-                        <a:srgbClr val="E2D9F3"/>
-                      </a:solidFill>
-                      <a:prstDash val="solid"/>
-                      <a:round/>
-                      <a:headEnd type="none" w="med" len="med"/>
-                      <a:tailEnd type="none" w="med" len="med"/>
-                    </a:lnB>
-                    <a:solidFill>
-                      <a:srgbClr val="FFFFFF"/>
-                    </a:solidFill>
-                  </a:tcPr>
-                </a:tc>
               </a:tr>
               <a:tr h="457200">
                 <a:tc>
@@ -29866,74 +29750,6 @@
                     </a:solidFill>
                   </a:tcPr>
                 </a:tc>
-                <a:tc>
-                  <a:txBody>
-                    <a:bodyPr/>
-                    <a:lstStyle/>
-                    <a:p>
-                      <a:pPr algn="ctr" indent="0" marL="0">
-                        <a:buNone/>
-                      </a:pPr>
-                      <a:r>
-                        <a:rPr lang="en-US" sz="1300" dirty="0">
-                          <a:solidFill>
-                            <a:srgbClr val="1F1A33"/>
-                          </a:solidFill>
-                          <a:latin typeface="Calibri" pitchFamily="34" charset="0"/>
-                          <a:ea typeface="Calibri" pitchFamily="34" charset="-122"/>
-                          <a:cs typeface="Calibri" pitchFamily="34" charset="-120"/>
-                        </a:rPr>
-                        <a:t>–</a:t>
-                      </a:r>
-                      <a:endParaRPr lang="en-US" sz="1300" dirty="0">
-                        <a:latin typeface="Calibri" charset="0"/>
-                        <a:ea typeface="Calibri" charset="0"/>
-                        <a:cs typeface="Calibri" charset="0"/>
-                      </a:endParaRPr>
-                    </a:p>
-                  </a:txBody>
-                  <a:tcPr marL="91440" marR="91440" marT="45720" marB="45720" anchor="ctr">
-                    <a:lnL w="12700" cap="flat" cmpd="sng" algn="ctr">
-                      <a:solidFill>
-                        <a:srgbClr val="E2D9F3"/>
-                      </a:solidFill>
-                      <a:prstDash val="solid"/>
-                      <a:round/>
-                      <a:headEnd type="none" w="med" len="med"/>
-                      <a:tailEnd type="none" w="med" len="med"/>
-                    </a:lnL>
-                    <a:lnR w="12700" cap="flat" cmpd="sng" algn="ctr">
-                      <a:solidFill>
-                        <a:srgbClr val="E2D9F3"/>
-                      </a:solidFill>
-                      <a:prstDash val="solid"/>
-                      <a:round/>
-                      <a:headEnd type="none" w="med" len="med"/>
-                      <a:tailEnd type="none" w="med" len="med"/>
-                    </a:lnR>
-                    <a:lnT w="12700" cap="flat" cmpd="sng" algn="ctr">
-                      <a:solidFill>
-                        <a:srgbClr val="E2D9F3"/>
-                      </a:solidFill>
-                      <a:prstDash val="solid"/>
-                      <a:round/>
-                      <a:headEnd type="none" w="med" len="med"/>
-                      <a:tailEnd type="none" w="med" len="med"/>
-                    </a:lnT>
-                    <a:lnB w="12700" cap="flat" cmpd="sng" algn="ctr">
-                      <a:solidFill>
-                        <a:srgbClr val="E2D9F3"/>
-                      </a:solidFill>
-                      <a:prstDash val="solid"/>
-                      <a:round/>
-                      <a:headEnd type="none" w="med" len="med"/>
-                      <a:tailEnd type="none" w="med" len="med"/>
-                    </a:lnB>
-                    <a:solidFill>
-                      <a:srgbClr val="FFFFFF"/>
-                    </a:solidFill>
-                  </a:tcPr>
-                </a:tc>
               </a:tr>
               <a:tr h="457200">
                 <a:tc>
@@ -30204,74 +30020,6 @@
                           <a:cs typeface="Calibri" pitchFamily="34" charset="-120"/>
                         </a:rPr>
                         <a:t>29.67</a:t>
-                      </a:r>
-                      <a:endParaRPr lang="en-US" sz="1300" dirty="0">
-                        <a:latin typeface="Calibri" charset="0"/>
-                        <a:ea typeface="Calibri" charset="0"/>
-                        <a:cs typeface="Calibri" charset="0"/>
-                      </a:endParaRPr>
-                    </a:p>
-                  </a:txBody>
-                  <a:tcPr marL="91440" marR="91440" marT="45720" marB="45720" anchor="ctr">
-                    <a:lnL w="12700" cap="flat" cmpd="sng" algn="ctr">
-                      <a:solidFill>
-                        <a:srgbClr val="E2D9F3"/>
-                      </a:solidFill>
-                      <a:prstDash val="solid"/>
-                      <a:round/>
-                      <a:headEnd type="none" w="med" len="med"/>
-                      <a:tailEnd type="none" w="med" len="med"/>
-                    </a:lnL>
-                    <a:lnR w="12700" cap="flat" cmpd="sng" algn="ctr">
-                      <a:solidFill>
-                        <a:srgbClr val="E2D9F3"/>
-                      </a:solidFill>
-                      <a:prstDash val="solid"/>
-                      <a:round/>
-                      <a:headEnd type="none" w="med" len="med"/>
-                      <a:tailEnd type="none" w="med" len="med"/>
-                    </a:lnR>
-                    <a:lnT w="12700" cap="flat" cmpd="sng" algn="ctr">
-                      <a:solidFill>
-                        <a:srgbClr val="E2D9F3"/>
-                      </a:solidFill>
-                      <a:prstDash val="solid"/>
-                      <a:round/>
-                      <a:headEnd type="none" w="med" len="med"/>
-                      <a:tailEnd type="none" w="med" len="med"/>
-                    </a:lnT>
-                    <a:lnB w="12700" cap="flat" cmpd="sng" algn="ctr">
-                      <a:solidFill>
-                        <a:srgbClr val="E2D9F3"/>
-                      </a:solidFill>
-                      <a:prstDash val="solid"/>
-                      <a:round/>
-                      <a:headEnd type="none" w="med" len="med"/>
-                      <a:tailEnd type="none" w="med" len="med"/>
-                    </a:lnB>
-                    <a:solidFill>
-                      <a:srgbClr val="F1ECF9"/>
-                    </a:solidFill>
-                  </a:tcPr>
-                </a:tc>
-                <a:tc>
-                  <a:txBody>
-                    <a:bodyPr/>
-                    <a:lstStyle/>
-                    <a:p>
-                      <a:pPr algn="ctr" indent="0" marL="0">
-                        <a:buNone/>
-                      </a:pPr>
-                      <a:r>
-                        <a:rPr lang="en-US" sz="1300" dirty="0">
-                          <a:solidFill>
-                            <a:srgbClr val="1F1A33"/>
-                          </a:solidFill>
-                          <a:latin typeface="Calibri" pitchFamily="34" charset="0"/>
-                          <a:ea typeface="Calibri" pitchFamily="34" charset="-122"/>
-                          <a:cs typeface="Calibri" pitchFamily="34" charset="-120"/>
-                        </a:rPr>
-                        <a:t>9.21×</a:t>
                       </a:r>
                       <a:endParaRPr lang="en-US" sz="1300" dirty="0">
                         <a:latin typeface="Calibri" charset="0"/>
@@ -30664,74 +30412,6 @@
                     </a:solidFill>
                   </a:tcPr>
                 </a:tc>
-                <a:tc>
-                  <a:txBody>
-                    <a:bodyPr/>
-                    <a:lstStyle/>
-                    <a:p>
-                      <a:pPr algn="ctr" indent="0" marL="0">
-                        <a:buNone/>
-                      </a:pPr>
-                      <a:r>
-                        <a:rPr lang="en-US" sz="1300" dirty="0">
-                          <a:solidFill>
-                            <a:srgbClr val="1F1A33"/>
-                          </a:solidFill>
-                          <a:latin typeface="Calibri" pitchFamily="34" charset="0"/>
-                          <a:ea typeface="Calibri" pitchFamily="34" charset="-122"/>
-                          <a:cs typeface="Calibri" pitchFamily="34" charset="-120"/>
-                        </a:rPr>
-                        <a:t>–</a:t>
-                      </a:r>
-                      <a:endParaRPr lang="en-US" sz="1300" dirty="0">
-                        <a:latin typeface="Calibri" charset="0"/>
-                        <a:ea typeface="Calibri" charset="0"/>
-                        <a:cs typeface="Calibri" charset="0"/>
-                      </a:endParaRPr>
-                    </a:p>
-                  </a:txBody>
-                  <a:tcPr marL="91440" marR="91440" marT="45720" marB="45720" anchor="ctr">
-                    <a:lnL w="12700" cap="flat" cmpd="sng" algn="ctr">
-                      <a:solidFill>
-                        <a:srgbClr val="E2D9F3"/>
-                      </a:solidFill>
-                      <a:prstDash val="solid"/>
-                      <a:round/>
-                      <a:headEnd type="none" w="med" len="med"/>
-                      <a:tailEnd type="none" w="med" len="med"/>
-                    </a:lnL>
-                    <a:lnR w="12700" cap="flat" cmpd="sng" algn="ctr">
-                      <a:solidFill>
-                        <a:srgbClr val="E2D9F3"/>
-                      </a:solidFill>
-                      <a:prstDash val="solid"/>
-                      <a:round/>
-                      <a:headEnd type="none" w="med" len="med"/>
-                      <a:tailEnd type="none" w="med" len="med"/>
-                    </a:lnR>
-                    <a:lnT w="12700" cap="flat" cmpd="sng" algn="ctr">
-                      <a:solidFill>
-                        <a:srgbClr val="E2D9F3"/>
-                      </a:solidFill>
-                      <a:prstDash val="solid"/>
-                      <a:round/>
-                      <a:headEnd type="none" w="med" len="med"/>
-                      <a:tailEnd type="none" w="med" len="med"/>
-                    </a:lnT>
-                    <a:lnB w="12700" cap="flat" cmpd="sng" algn="ctr">
-                      <a:solidFill>
-                        <a:srgbClr val="E2D9F3"/>
-                      </a:solidFill>
-                      <a:prstDash val="solid"/>
-                      <a:round/>
-                      <a:headEnd type="none" w="med" len="med"/>
-                      <a:tailEnd type="none" w="med" len="med"/>
-                    </a:lnB>
-                    <a:solidFill>
-                      <a:srgbClr val="FFFFFF"/>
-                    </a:solidFill>
-                  </a:tcPr>
-                </a:tc>
               </a:tr>
               <a:tr h="457200">
                 <a:tc>
@@ -31002,74 +30682,6 @@
                           <a:cs typeface="Calibri" pitchFamily="34" charset="-120"/>
                         </a:rPr>
                         <a:t>29.11</a:t>
-                      </a:r>
-                      <a:endParaRPr lang="en-US" sz="1300" dirty="0">
-                        <a:latin typeface="Calibri" charset="0"/>
-                        <a:ea typeface="Calibri" charset="0"/>
-                        <a:cs typeface="Calibri" charset="0"/>
-                      </a:endParaRPr>
-                    </a:p>
-                  </a:txBody>
-                  <a:tcPr marL="91440" marR="91440" marT="45720" marB="45720" anchor="ctr">
-                    <a:lnL w="12700" cap="flat" cmpd="sng" algn="ctr">
-                      <a:solidFill>
-                        <a:srgbClr val="E2D9F3"/>
-                      </a:solidFill>
-                      <a:prstDash val="solid"/>
-                      <a:round/>
-                      <a:headEnd type="none" w="med" len="med"/>
-                      <a:tailEnd type="none" w="med" len="med"/>
-                    </a:lnL>
-                    <a:lnR w="12700" cap="flat" cmpd="sng" algn="ctr">
-                      <a:solidFill>
-                        <a:srgbClr val="E2D9F3"/>
-                      </a:solidFill>
-                      <a:prstDash val="solid"/>
-                      <a:round/>
-                      <a:headEnd type="none" w="med" len="med"/>
-                      <a:tailEnd type="none" w="med" len="med"/>
-                    </a:lnR>
-                    <a:lnT w="12700" cap="flat" cmpd="sng" algn="ctr">
-                      <a:solidFill>
-                        <a:srgbClr val="E2D9F3"/>
-                      </a:solidFill>
-                      <a:prstDash val="solid"/>
-                      <a:round/>
-                      <a:headEnd type="none" w="med" len="med"/>
-                      <a:tailEnd type="none" w="med" len="med"/>
-                    </a:lnT>
-                    <a:lnB w="12700" cap="flat" cmpd="sng" algn="ctr">
-                      <a:solidFill>
-                        <a:srgbClr val="E2D9F3"/>
-                      </a:solidFill>
-                      <a:prstDash val="solid"/>
-                      <a:round/>
-                      <a:headEnd type="none" w="med" len="med"/>
-                      <a:tailEnd type="none" w="med" len="med"/>
-                    </a:lnB>
-                    <a:solidFill>
-                      <a:srgbClr val="F1ECF9"/>
-                    </a:solidFill>
-                  </a:tcPr>
-                </a:tc>
-                <a:tc>
-                  <a:txBody>
-                    <a:bodyPr/>
-                    <a:lstStyle/>
-                    <a:p>
-                      <a:pPr algn="ctr" indent="0" marL="0">
-                        <a:buNone/>
-                      </a:pPr>
-                      <a:r>
-                        <a:rPr lang="en-US" sz="1300" dirty="0">
-                          <a:solidFill>
-                            <a:srgbClr val="1F1A33"/>
-                          </a:solidFill>
-                          <a:latin typeface="Calibri" pitchFamily="34" charset="0"/>
-                          <a:ea typeface="Calibri" pitchFamily="34" charset="-122"/>
-                          <a:cs typeface="Calibri" pitchFamily="34" charset="-120"/>
-                        </a:rPr>
-                        <a:t>9.22×</a:t>
                       </a:r>
                       <a:endParaRPr lang="en-US" sz="1300" dirty="0">
                         <a:latin typeface="Calibri" charset="0"/>
@@ -31462,74 +31074,6 @@
                     </a:solidFill>
                   </a:tcPr>
                 </a:tc>
-                <a:tc>
-                  <a:txBody>
-                    <a:bodyPr/>
-                    <a:lstStyle/>
-                    <a:p>
-                      <a:pPr algn="ctr" indent="0" marL="0">
-                        <a:buNone/>
-                      </a:pPr>
-                      <a:r>
-                        <a:rPr lang="en-US" sz="1300" dirty="0">
-                          <a:solidFill>
-                            <a:srgbClr val="1F1A33"/>
-                          </a:solidFill>
-                          <a:latin typeface="Calibri" pitchFamily="34" charset="0"/>
-                          <a:ea typeface="Calibri" pitchFamily="34" charset="-122"/>
-                          <a:cs typeface="Calibri" pitchFamily="34" charset="-120"/>
-                        </a:rPr>
-                        <a:t>2.61×</a:t>
-                      </a:r>
-                      <a:endParaRPr lang="en-US" sz="1300" dirty="0">
-                        <a:latin typeface="Calibri" charset="0"/>
-                        <a:ea typeface="Calibri" charset="0"/>
-                        <a:cs typeface="Calibri" charset="0"/>
-                      </a:endParaRPr>
-                    </a:p>
-                  </a:txBody>
-                  <a:tcPr marL="91440" marR="91440" marT="45720" marB="45720" anchor="ctr">
-                    <a:lnL w="12700" cap="flat" cmpd="sng" algn="ctr">
-                      <a:solidFill>
-                        <a:srgbClr val="E2D9F3"/>
-                      </a:solidFill>
-                      <a:prstDash val="solid"/>
-                      <a:round/>
-                      <a:headEnd type="none" w="med" len="med"/>
-                      <a:tailEnd type="none" w="med" len="med"/>
-                    </a:lnL>
-                    <a:lnR w="12700" cap="flat" cmpd="sng" algn="ctr">
-                      <a:solidFill>
-                        <a:srgbClr val="E2D9F3"/>
-                      </a:solidFill>
-                      <a:prstDash val="solid"/>
-                      <a:round/>
-                      <a:headEnd type="none" w="med" len="med"/>
-                      <a:tailEnd type="none" w="med" len="med"/>
-                    </a:lnR>
-                    <a:lnT w="12700" cap="flat" cmpd="sng" algn="ctr">
-                      <a:solidFill>
-                        <a:srgbClr val="E2D9F3"/>
-                      </a:solidFill>
-                      <a:prstDash val="solid"/>
-                      <a:round/>
-                      <a:headEnd type="none" w="med" len="med"/>
-                      <a:tailEnd type="none" w="med" len="med"/>
-                    </a:lnT>
-                    <a:lnB w="12700" cap="flat" cmpd="sng" algn="ctr">
-                      <a:solidFill>
-                        <a:srgbClr val="E2D9F3"/>
-                      </a:solidFill>
-                      <a:prstDash val="solid"/>
-                      <a:round/>
-                      <a:headEnd type="none" w="med" len="med"/>
-                      <a:tailEnd type="none" w="med" len="med"/>
-                    </a:lnB>
-                    <a:solidFill>
-                      <a:srgbClr val="FFFFFF"/>
-                    </a:solidFill>
-                  </a:tcPr>
-                </a:tc>
               </a:tr>
               <a:tr h="457200">
                 <a:tc>
@@ -31850,74 +31394,6 @@
                     </a:solidFill>
                   </a:tcPr>
                 </a:tc>
-                <a:tc>
-                  <a:txBody>
-                    <a:bodyPr/>
-                    <a:lstStyle/>
-                    <a:p>
-                      <a:pPr algn="ctr" indent="0" marL="0">
-                        <a:buNone/>
-                      </a:pPr>
-                      <a:r>
-                        <a:rPr lang="en-US" sz="1300" dirty="0">
-                          <a:solidFill>
-                            <a:srgbClr val="1F1A33"/>
-                          </a:solidFill>
-                          <a:latin typeface="Calibri" pitchFamily="34" charset="0"/>
-                          <a:ea typeface="Calibri" pitchFamily="34" charset="-122"/>
-                          <a:cs typeface="Calibri" pitchFamily="34" charset="-120"/>
-                        </a:rPr>
-                        <a:t>9.10×</a:t>
-                      </a:r>
-                      <a:endParaRPr lang="en-US" sz="1300" dirty="0">
-                        <a:latin typeface="Calibri" charset="0"/>
-                        <a:ea typeface="Calibri" charset="0"/>
-                        <a:cs typeface="Calibri" charset="0"/>
-                      </a:endParaRPr>
-                    </a:p>
-                  </a:txBody>
-                  <a:tcPr marL="91440" marR="91440" marT="45720" marB="45720" anchor="ctr">
-                    <a:lnL w="12700" cap="flat" cmpd="sng" algn="ctr">
-                      <a:solidFill>
-                        <a:srgbClr val="E2D9F3"/>
-                      </a:solidFill>
-                      <a:prstDash val="solid"/>
-                      <a:round/>
-                      <a:headEnd type="none" w="med" len="med"/>
-                      <a:tailEnd type="none" w="med" len="med"/>
-                    </a:lnL>
-                    <a:lnR w="12700" cap="flat" cmpd="sng" algn="ctr">
-                      <a:solidFill>
-                        <a:srgbClr val="E2D9F3"/>
-                      </a:solidFill>
-                      <a:prstDash val="solid"/>
-                      <a:round/>
-                      <a:headEnd type="none" w="med" len="med"/>
-                      <a:tailEnd type="none" w="med" len="med"/>
-                    </a:lnR>
-                    <a:lnT w="12700" cap="flat" cmpd="sng" algn="ctr">
-                      <a:solidFill>
-                        <a:srgbClr val="E2D9F3"/>
-                      </a:solidFill>
-                      <a:prstDash val="solid"/>
-                      <a:round/>
-                      <a:headEnd type="none" w="med" len="med"/>
-                      <a:tailEnd type="none" w="med" len="med"/>
-                    </a:lnT>
-                    <a:lnB w="12700" cap="flat" cmpd="sng" algn="ctr">
-                      <a:solidFill>
-                        <a:srgbClr val="E2D9F3"/>
-                      </a:solidFill>
-                      <a:prstDash val="solid"/>
-                      <a:round/>
-                      <a:headEnd type="none" w="med" len="med"/>
-                      <a:tailEnd type="none" w="med" len="med"/>
-                    </a:lnB>
-                    <a:solidFill>
-                      <a:srgbClr val="F1ECF9"/>
-                    </a:solidFill>
-                  </a:tcPr>
-                </a:tc>
               </a:tr>
             </a:tbl>
           </a:graphicData>
@@ -31956,7 +31432,7 @@
                 <a:ea typeface="Calibri" pitchFamily="34" charset="-122"/>
                 <a:cs typeface="Calibri" pitchFamily="34" charset="-120"/>
               </a:rPr>
-              <a:t>* Bilal et al.: PSNR range at bit rates up to 0.625 bpp; time ratio = LBG / FLBG training time (single core). This work: time ratio = sequential / parallel LBG time at P = 14. Thomas et al. is near-lossless (CR ≈ 1.5).</a:t>
+              <a:t>* Bilal et al.: PSNR range at bit rates up to 0.625 bpp (CR not reported). Thomas et al. is a near-lossless scheme (CR ≈ 1.5).</a:t>
             </a:r>
             <a:endParaRPr lang="en-US" sz="1200" dirty="0"/>
           </a:p>
@@ -31995,7 +31471,7 @@
                 <a:ea typeface="Cambria" pitchFamily="34" charset="-122"/>
                 <a:cs typeface="Cambria" pitchFamily="34" charset="-120"/>
               </a:rPr>
-              <a:t>Higher compression ratio at an acceptable PSNR, with a faster training stage.</a:t>
+              <a:t>The proposed method provides substantially higher compression than the near-lossless method, with lower reconstruction fidelity.</a:t>
             </a:r>
             <a:endParaRPr lang="en-US" sz="1800" dirty="0"/>
           </a:p>

</xml_diff>

<commit_message>
Add entropy and delta-Huffman efficiency slide to seminar deck
Co-Authored-By: Claude Sonnet 5.5 <noreply@anthropic.com>
Claude-Session: https://claude.ai/code/session_01T6gEewJ8YaCdmnsfS34RJd
</commit_message>
<xml_diff>
--- a/results/seminar/figs/Seminar_Ibtihal_v3.pptx
+++ b/results/seminar/figs/Seminar_Ibtihal_v3.pptx
@@ -35,9 +35,10 @@
     <p:sldId id="283" r:id="rId29"/>
     <p:sldId id="284" r:id="rId30"/>
     <p:sldId id="285" r:id="rId31"/>
+    <p:sldId id="286" r:id="rId32"/>
   </p:sldIdLst>
   <p:notesMasterIdLst>
-    <p:notesMasterId r:id="rId32"/>
+    <p:notesMasterId r:id="rId33"/>
   </p:notesMasterIdLst>
   <p:sldSz cx="12192000" cy="6858000"/>
   <p:notesSz cx="6858000" cy="12192000"/>
@@ -2579,6 +2580,94 @@
             <a:fld id="{F7021451-1387-4CA6-816F-3879F97B5CBC}" type="slidenum">
               <a:rPr lang="en-US"/>
               <a:t>30</a:t>
+            </a:fld>
+            <a:endParaRPr lang="en-US"/>
+          </a:p>
+        </p:txBody>
+      </p:sp>
+    </p:spTree>
+    <p:extLst>
+      <p:ext uri="{BB962C8B-B14F-4D97-AF65-F5344CB8AC3E}">
+        <p14:creationId xmlns:p14="http://schemas.microsoft.com/office/powerpoint/2010/main" val="1024086991"/>
+      </p:ext>
+    </p:extLst>
+  </p:cSld>
+  <p:clrMapOvr>
+    <a:masterClrMapping/>
+  </p:clrMapOvr>
+</p:notes>
+</file>
+
+<file path=ppt/notesSlides/notesSlide31.xml><?xml version="1.0" encoding="utf-8"?>
+<p:notes xmlns:a="http://schemas.openxmlformats.org/drawingml/2006/main" xmlns:r="http://schemas.openxmlformats.org/officeDocument/2006/relationships" xmlns:p="http://schemas.openxmlformats.org/presentationml/2006/main">
+  <p:cSld>
+    <p:spTree>
+      <p:nvGrpSpPr>
+        <p:cNvPr id="1" name=""/>
+        <p:cNvGrpSpPr/>
+        <p:nvPr/>
+      </p:nvGrpSpPr>
+      <p:grpSpPr>
+        <a:xfrm>
+          <a:off x="0" y="0"/>
+          <a:ext cx="0" cy="0"/>
+          <a:chOff x="0" y="0"/>
+          <a:chExt cx="0" cy="0"/>
+        </a:xfrm>
+      </p:grpSpPr>
+      <p:sp>
+        <p:nvSpPr>
+          <p:cNvPr id="2" name="Slide Image Placeholder 1"/>
+          <p:cNvSpPr>
+            <a:spLocks noGrp="1" noRot="1" noChangeAspect="1"/>
+          </p:cNvSpPr>
+          <p:nvPr>
+            <p:ph type="sldImg"/>
+          </p:nvPr>
+        </p:nvSpPr>
+        <p:spPr/>
+      </p:sp>
+      <p:sp>
+        <p:nvSpPr>
+          <p:cNvPr id="3" name="Notes Placeholder 2"/>
+          <p:cNvSpPr>
+            <a:spLocks noGrp="1"/>
+          </p:cNvSpPr>
+          <p:nvPr>
+            <p:ph type="body" idx="1"/>
+          </p:nvPr>
+        </p:nvSpPr>
+        <p:spPr/>
+        <p:txBody>
+          <a:bodyPr/>
+          <a:lstStyle/>
+          <a:p>
+            <a:r>
+              <a:rPr lang="en-US" dirty="0"/>
+              <a:t/>
+            </a:r>
+            <a:endParaRPr lang="en-US" dirty="0"/>
+          </a:p>
+        </p:txBody>
+      </p:sp>
+      <p:sp>
+        <p:nvSpPr>
+          <p:cNvPr id="4" name="Slide Number Placeholder 3"/>
+          <p:cNvSpPr>
+            <a:spLocks noGrp="1"/>
+          </p:cNvSpPr>
+          <p:nvPr>
+            <p:ph type="sldNum" sz="quarter" idx="10"/>
+          </p:nvPr>
+        </p:nvSpPr>
+        <p:spPr/>
+        <p:txBody>
+          <a:bodyPr/>
+          <a:lstStyle/>
+          <a:p>
+            <a:fld id="{F7021451-1387-4CA6-816F-3879F97B5CBC}" type="slidenum">
+              <a:rPr lang="en-US"/>
+              <a:t>31</a:t>
             </a:fld>
             <a:endParaRPr lang="en-US"/>
           </a:p>
@@ -21926,7 +22015,7 @@
                 <a:ea typeface="Cambria" pitchFamily="34" charset="-122"/>
                 <a:cs typeface="Cambria" pitchFamily="34" charset="-120"/>
               </a:rPr>
-              <a:t>Speedup and Efficiency of LBG Training</a:t>
+              <a:t>Entropy and Delta–Huffman Coding Efficiency</a:t>
             </a:r>
             <a:endParaRPr lang="en-US" sz="2800" dirty="0"/>
           </a:p>
@@ -21986,7 +22075,7 @@
       </p:sp>
       <p:pic>
         <p:nvPicPr>
-          <p:cNvPr id="7" name="Image 0" descr="assets/speedup_chart.png">    </p:cNvPr>
+          <p:cNvPr id="7" name="Image 0" descr="assets/entropy_chart.png">    </p:cNvPr>
           <p:cNvPicPr>
             <a:picLocks noChangeAspect="1"/>
           </p:cNvPicPr>
@@ -22064,7 +22153,7 @@
               <a:buChar char="■"/>
             </a:pPr>
             <a:r>
-              <a:rPr lang="en-US" sz="1600" dirty="0">
+              <a:rPr lang="en-US" sz="1500" dirty="0">
                 <a:solidFill>
                   <a:srgbClr val="1F1A33"/>
                 </a:solidFill>
@@ -22072,9 +22161,9 @@
                 <a:ea typeface="Calibri" pitchFamily="34" charset="-122"/>
                 <a:cs typeface="Calibri" pitchFamily="34" charset="-120"/>
               </a:rPr>
-              <a:t>LBG speedup reaches 9.19× on 14 processes (efficiency ≈ 66%).</a:t>
-            </a:r>
-            <a:endParaRPr lang="en-US" sz="1600" dirty="0"/>
+              <a:t>Delta coding lowers the entropy of the index sequence from 5.30 to 4.19 bits on average (−1.10 bits).</a:t>
+            </a:r>
+            <a:endParaRPr lang="en-US" sz="1500" dirty="0"/>
           </a:p>
           <a:p>
             <a:pPr marL="342900" indent="-342900">
@@ -22085,7 +22174,7 @@
               <a:buChar char="■"/>
             </a:pPr>
             <a:r>
-              <a:rPr lang="en-US" sz="1600" dirty="0">
+              <a:rPr lang="en-US" sz="1500" dirty="0">
                 <a:solidFill>
                   <a:srgbClr val="1F1A33"/>
                 </a:solidFill>
@@ -22093,9 +22182,9 @@
                 <a:ea typeface="Calibri" pitchFamily="34" charset="-122"/>
                 <a:cs typeface="Calibri" pitchFamily="34" charset="-120"/>
               </a:rPr>
-              <a:t>Near-linear for P ≤ 6, where only P-cores are used.</a:t>
-            </a:r>
-            <a:endParaRPr lang="en-US" sz="1600" dirty="0"/>
+              <a:t>The reduction depends on the spatial correlation of the image: 0.73 bits (Lena) to 1.48 bits (Cameraman).</a:t>
+            </a:r>
+            <a:endParaRPr lang="en-US" sz="1500" dirty="0"/>
           </a:p>
           <a:p>
             <a:pPr marL="342900" indent="-342900">
@@ -22106,7 +22195,7 @@
               <a:buChar char="■"/>
             </a:pPr>
             <a:r>
-              <a:rPr lang="en-US" sz="1600" dirty="0">
+              <a:rPr lang="en-US" sz="1500" dirty="0">
                 <a:solidFill>
                   <a:srgbClr val="1F1A33"/>
                 </a:solidFill>
@@ -22114,9 +22203,9 @@
                 <a:ea typeface="Calibri" pitchFamily="34" charset="-122"/>
                 <a:cs typeface="Calibri" pitchFamily="34" charset="-120"/>
               </a:rPr>
-              <a:t>The slope drops once the slower E-cores join.</a:t>
-            </a:r>
-            <a:endParaRPr lang="en-US" sz="1600" dirty="0"/>
+              <a:t>The Huffman average code length (4.23 bits) is within 0.04 bits of the entropy after delta coding.</a:t>
+            </a:r>
+            <a:endParaRPr lang="en-US" sz="1500" dirty="0"/>
           </a:p>
           <a:p>
             <a:pPr marL="342900" indent="-342900">
@@ -22127,7 +22216,7 @@
               <a:buChar char="■"/>
             </a:pPr>
             <a:r>
-              <a:rPr lang="en-US" sz="1600" dirty="0">
+              <a:rPr lang="en-US" sz="1500" dirty="0">
                 <a:solidFill>
                   <a:srgbClr val="1F1A33"/>
                 </a:solidFill>
@@ -22135,9 +22224,9 @@
                 <a:ea typeface="Calibri" pitchFamily="34" charset="-122"/>
                 <a:cs typeface="Calibri" pitchFamily="34" charset="-120"/>
               </a:rPr>
-              <a:t>Karp–Flatt ≈ 0.04 for P ≥ 8: the serial fraction of LBG stays small.</a:t>
-            </a:r>
-            <a:endParaRPr lang="en-US" sz="1600" dirty="0"/>
+              <a:t>Compared with 6-bit fixed-length indices, the index data is 21.5% to 38.3% smaller (mean 29.5%).</a:t>
+            </a:r>
+            <a:endParaRPr lang="en-US" sz="1500" dirty="0"/>
           </a:p>
           <a:p>
             <a:pPr marL="342900" indent="-342900">
@@ -22148,7 +22237,7 @@
               <a:buChar char="■"/>
             </a:pPr>
             <a:r>
-              <a:rPr lang="en-US" sz="1600" dirty="0">
+              <a:rPr lang="en-US" sz="1500" dirty="0">
                 <a:solidFill>
                   <a:srgbClr val="1F1A33"/>
                 </a:solidFill>
@@ -22156,9 +22245,9 @@
                 <a:ea typeface="Calibri" pitchFamily="34" charset="-122"/>
                 <a:cs typeface="Calibri" pitchFamily="34" charset="-120"/>
               </a:rPr>
-              <a:t>Total time: 5.00× (gray) and 6.84× (color), because coding and reconstruction remain sequential.</a:t>
-            </a:r>
-            <a:endParaRPr lang="en-US" sz="1600" dirty="0"/>
+              <a:t>Grayscale images, K = 64.</a:t>
+            </a:r>
+            <a:endParaRPr lang="en-US" sz="1500" dirty="0"/>
           </a:p>
         </p:txBody>
       </p:sp>
@@ -22293,7 +22382,7 @@
                 <a:ea typeface="Cambria" pitchFamily="34" charset="-122"/>
                 <a:cs typeface="Cambria" pitchFamily="34" charset="-120"/>
               </a:rPr>
-              <a:t>Equal vs Adaptive Workload Distribution</a:t>
+              <a:t>Speedup and Efficiency of LBG Training</a:t>
             </a:r>
             <a:endParaRPr lang="en-US" sz="2800" dirty="0"/>
           </a:p>
@@ -22353,7 +22442,7 @@
       </p:sp>
       <p:pic>
         <p:nvPicPr>
-          <p:cNvPr id="7" name="Image 0" descr="assets/eqad_chart.png">    </p:cNvPr>
+          <p:cNvPr id="7" name="Image 0" descr="assets/speedup_chart.png">    </p:cNvPr>
           <p:cNvPicPr>
             <a:picLocks noChangeAspect="1"/>
           </p:cNvPicPr>
@@ -22425,13 +22514,13 @@
           <a:p>
             <a:pPr marL="342900" indent="-342900">
               <a:spcAft>
-                <a:spcPts val="800"/>
+                <a:spcPts val="900"/>
               </a:spcAft>
               <a:buSzPct val="100000"/>
               <a:buChar char="■"/>
             </a:pPr>
             <a:r>
-              <a:rPr lang="en-US" sz="1500" dirty="0">
+              <a:rPr lang="en-US" sz="1600" dirty="0">
                 <a:solidFill>
                   <a:srgbClr val="1F1A33"/>
                 </a:solidFill>
@@ -22439,20 +22528,20 @@
                 <a:ea typeface="Calibri" pitchFamily="34" charset="-122"/>
                 <a:cs typeface="Calibri" pitchFamily="34" charset="-120"/>
               </a:rPr>
-              <a:t>With Equal distribution, the faster P-cores finish early and wait for the E-cores: 7.61× at P = 14.</a:t>
-            </a:r>
-            <a:endParaRPr lang="en-US" sz="1500" dirty="0"/>
+              <a:t>LBG speedup reaches 9.19× on 14 processes (efficiency ≈ 66%).</a:t>
+            </a:r>
+            <a:endParaRPr lang="en-US" sz="1600" dirty="0"/>
           </a:p>
           <a:p>
             <a:pPr marL="342900" indent="-342900">
               <a:spcAft>
-                <a:spcPts val="800"/>
+                <a:spcPts val="900"/>
               </a:spcAft>
               <a:buSzPct val="100000"/>
               <a:buChar char="■"/>
             </a:pPr>
             <a:r>
-              <a:rPr lang="en-US" sz="1500" dirty="0">
+              <a:rPr lang="en-US" sz="1600" dirty="0">
                 <a:solidFill>
                   <a:srgbClr val="1F1A33"/>
                 </a:solidFill>
@@ -22460,20 +22549,20 @@
                 <a:ea typeface="Calibri" pitchFamily="34" charset="-122"/>
                 <a:cs typeface="Calibri" pitchFamily="34" charset="-120"/>
               </a:rPr>
-              <a:t>Adaptive distribution reaches 9.19× at P = 14.</a:t>
-            </a:r>
-            <a:endParaRPr lang="en-US" sz="1500" dirty="0"/>
+              <a:t>Near-linear for P ≤ 6, where only P-cores are used.</a:t>
+            </a:r>
+            <a:endParaRPr lang="en-US" sz="1600" dirty="0"/>
           </a:p>
           <a:p>
             <a:pPr marL="342900" indent="-342900">
               <a:spcAft>
-                <a:spcPts val="800"/>
+                <a:spcPts val="900"/>
               </a:spcAft>
               <a:buSzPct val="100000"/>
               <a:buChar char="■"/>
             </a:pPr>
             <a:r>
-              <a:rPr lang="en-US" sz="1500" dirty="0">
+              <a:rPr lang="en-US" sz="1600" dirty="0">
                 <a:solidFill>
                   <a:srgbClr val="1F1A33"/>
                 </a:solidFill>
@@ -22481,20 +22570,20 @@
                 <a:ea typeface="Calibri" pitchFamily="34" charset="-122"/>
                 <a:cs typeface="Calibri" pitchFamily="34" charset="-120"/>
               </a:rPr>
-              <a:t>LBG time is reduced by 28.3%, 23.6%, 19.8% and 17.2% at P = 8, 10, 12 and 14.</a:t>
-            </a:r>
-            <a:endParaRPr lang="en-US" sz="1500" dirty="0"/>
+              <a:t>The slope drops once the slower E-cores join.</a:t>
+            </a:r>
+            <a:endParaRPr lang="en-US" sz="1600" dirty="0"/>
           </a:p>
           <a:p>
             <a:pPr marL="342900" indent="-342900">
               <a:spcAft>
-                <a:spcPts val="800"/>
+                <a:spcPts val="900"/>
               </a:spcAft>
               <a:buSzPct val="100000"/>
               <a:buChar char="■"/>
             </a:pPr>
             <a:r>
-              <a:rPr lang="en-US" sz="1500" dirty="0">
+              <a:rPr lang="en-US" sz="1600" dirty="0">
                 <a:solidFill>
                   <a:srgbClr val="1F1A33"/>
                 </a:solidFill>
@@ -22502,20 +22591,20 @@
                 <a:ea typeface="Calibri" pitchFamily="34" charset="-122"/>
                 <a:cs typeface="Calibri" pitchFamily="34" charset="-120"/>
               </a:rPr>
-              <a:t>Total time is reduced by 17.9% to 8.8%.</a:t>
-            </a:r>
-            <a:endParaRPr lang="en-US" sz="1500" dirty="0"/>
+              <a:t>Karp–Flatt ≈ 0.04 for P ≥ 8: the serial fraction of LBG stays small.</a:t>
+            </a:r>
+            <a:endParaRPr lang="en-US" sz="1600" dirty="0"/>
           </a:p>
           <a:p>
             <a:pPr marL="342900" indent="-342900">
               <a:spcAft>
-                <a:spcPts val="800"/>
+                <a:spcPts val="900"/>
               </a:spcAft>
               <a:buSzPct val="100000"/>
               <a:buChar char="■"/>
             </a:pPr>
             <a:r>
-              <a:rPr lang="en-US" sz="1500" dirty="0">
+              <a:rPr lang="en-US" sz="1600" dirty="0">
                 <a:solidFill>
                   <a:srgbClr val="1F1A33"/>
                 </a:solidFill>
@@ -22523,30 +22612,9 @@
                 <a:ea typeface="Calibri" pitchFamily="34" charset="-122"/>
                 <a:cs typeface="Calibri" pitchFamily="34" charset="-120"/>
               </a:rPr>
-              <a:t>No adaptive-distribution benefit was observed when only P-cores were used (P ≤ 6).</a:t>
-            </a:r>
-            <a:endParaRPr lang="en-US" sz="1500" dirty="0"/>
-          </a:p>
-          <a:p>
-            <a:pPr marL="342900" indent="-342900">
-              <a:spcAft>
-                <a:spcPts val="800"/>
-              </a:spcAft>
-              <a:buSzPct val="100000"/>
-              <a:buChar char="■"/>
-            </a:pPr>
-            <a:r>
-              <a:rPr lang="en-US" sz="1500" dirty="0">
-                <a:solidFill>
-                  <a:srgbClr val="1F1A33"/>
-                </a:solidFill>
-                <a:latin typeface="Calibri" pitchFamily="34" charset="0"/>
-                <a:ea typeface="Calibri" pitchFamily="34" charset="-122"/>
-                <a:cs typeface="Calibri" pitchFamily="34" charset="-120"/>
-              </a:rPr>
-              <a:t>The reconstructed images are identical in both cases.</a:t>
-            </a:r>
-            <a:endParaRPr lang="en-US" sz="1500" dirty="0"/>
+              <a:t>Total time: 5.00× (gray) and 6.84× (color), because coding and reconstruction remain sequential.</a:t>
+            </a:r>
+            <a:endParaRPr lang="en-US" sz="1600" dirty="0"/>
           </a:p>
         </p:txBody>
       </p:sp>
@@ -22681,7 +22749,7 @@
                 <a:ea typeface="Cambria" pitchFamily="34" charset="-122"/>
                 <a:cs typeface="Cambria" pitchFamily="34" charset="-120"/>
               </a:rPr>
-              <a:t>Throughput</a:t>
+              <a:t>Equal vs Adaptive Workload Distribution</a:t>
             </a:r>
             <a:endParaRPr lang="en-US" sz="2800" dirty="0"/>
           </a:p>
@@ -22741,7 +22809,7 @@
       </p:sp>
       <p:pic>
         <p:nvPicPr>
-          <p:cNvPr id="7" name="Image 0" descr="assets/throughput_ch4.png">    </p:cNvPr>
+          <p:cNvPr id="7" name="Image 0" descr="assets/eqad_chart.png">    </p:cNvPr>
           <p:cNvPicPr>
             <a:picLocks noChangeAspect="1"/>
           </p:cNvPicPr>
@@ -22755,8 +22823,8 @@
         </p:blipFill>
         <p:spPr>
           <a:xfrm>
-            <a:off x="457200" y="1269906"/>
-            <a:ext cx="7498080" cy="4958268"/>
+            <a:off x="457200" y="1467016"/>
+            <a:ext cx="7498080" cy="4564049"/>
           </a:xfrm>
           <a:prstGeom prst="rect">
             <a:avLst/>
@@ -22813,7 +22881,7 @@
           <a:p>
             <a:pPr marL="342900" indent="-342900">
               <a:spcAft>
-                <a:spcPts val="900"/>
+                <a:spcPts val="800"/>
               </a:spcAft>
               <a:buSzPct val="100000"/>
               <a:buChar char="■"/>
@@ -22827,14 +22895,14 @@
                 <a:ea typeface="Calibri" pitchFamily="34" charset="-122"/>
                 <a:cs typeface="Calibri" pitchFamily="34" charset="-120"/>
               </a:rPr>
-              <a:t>Throughput = original image size / total execution time (MiB/s).</a:t>
+              <a:t>With Equal distribution, the faster P-cores finish early and wait for the E-cores: 7.61× at P = 14.</a:t>
             </a:r>
             <a:endParaRPr lang="en-US" sz="1500" dirty="0"/>
           </a:p>
           <a:p>
             <a:pPr marL="342900" indent="-342900">
               <a:spcAft>
-                <a:spcPts val="900"/>
+                <a:spcPts val="800"/>
               </a:spcAft>
               <a:buSzPct val="100000"/>
               <a:buChar char="■"/>
@@ -22848,14 +22916,14 @@
                 <a:ea typeface="Calibri" pitchFamily="34" charset="-122"/>
                 <a:cs typeface="Calibri" pitchFamily="34" charset="-120"/>
               </a:rPr>
-              <a:t>Grayscale: 1.30 → 3.35 MiB/s from P = 2 to P = 14.</a:t>
+              <a:t>Adaptive distribution reaches 9.19× at P = 14.</a:t>
             </a:r>
             <a:endParaRPr lang="en-US" sz="1500" dirty="0"/>
           </a:p>
           <a:p>
             <a:pPr marL="342900" indent="-342900">
               <a:spcAft>
-                <a:spcPts val="900"/>
+                <a:spcPts val="800"/>
               </a:spcAft>
               <a:buSzPct val="100000"/>
               <a:buChar char="■"/>
@@ -22869,14 +22937,14 @@
                 <a:ea typeface="Calibri" pitchFamily="34" charset="-122"/>
                 <a:cs typeface="Calibri" pitchFamily="34" charset="-120"/>
               </a:rPr>
-              <a:t>Color: 1.42 → 4.54 MiB/s.</a:t>
+              <a:t>LBG time is reduced by 28.3%, 23.6%, 19.8% and 17.2% at P = 8, 10, 12 and 14.</a:t>
             </a:r>
             <a:endParaRPr lang="en-US" sz="1500" dirty="0"/>
           </a:p>
           <a:p>
             <a:pPr marL="342900" indent="-342900">
               <a:spcAft>
-                <a:spcPts val="900"/>
+                <a:spcPts val="800"/>
               </a:spcAft>
               <a:buSzPct val="100000"/>
               <a:buChar char="■"/>
@@ -22890,14 +22958,14 @@
                 <a:ea typeface="Calibri" pitchFamily="34" charset="-122"/>
                 <a:cs typeface="Calibri" pitchFamily="34" charset="-120"/>
               </a:rPr>
-              <a:t>Color images hold three times more data, but their total time grows by only about 2.2× at P = 14, so their throughput is higher.</a:t>
+              <a:t>Total time is reduced by 17.9% to 8.8%.</a:t>
             </a:r>
             <a:endParaRPr lang="en-US" sz="1500" dirty="0"/>
           </a:p>
           <a:p>
             <a:pPr marL="342900" indent="-342900">
               <a:spcAft>
-                <a:spcPts val="900"/>
+                <a:spcPts val="800"/>
               </a:spcAft>
               <a:buSzPct val="100000"/>
               <a:buChar char="■"/>
@@ -22911,7 +22979,28 @@
                 <a:ea typeface="Calibri" pitchFamily="34" charset="-122"/>
                 <a:cs typeface="Calibri" pitchFamily="34" charset="-120"/>
               </a:rPr>
-              <a:t>Shaded bands: minimum to maximum over the images.</a:t>
+              <a:t>No adaptive-distribution benefit was observed when only P-cores were used (P ≤ 6).</a:t>
+            </a:r>
+            <a:endParaRPr lang="en-US" sz="1500" dirty="0"/>
+          </a:p>
+          <a:p>
+            <a:pPr marL="342900" indent="-342900">
+              <a:spcAft>
+                <a:spcPts val="800"/>
+              </a:spcAft>
+              <a:buSzPct val="100000"/>
+              <a:buChar char="■"/>
+            </a:pPr>
+            <a:r>
+              <a:rPr lang="en-US" sz="1500" dirty="0">
+                <a:solidFill>
+                  <a:srgbClr val="1F1A33"/>
+                </a:solidFill>
+                <a:latin typeface="Calibri" pitchFamily="34" charset="0"/>
+                <a:ea typeface="Calibri" pitchFamily="34" charset="-122"/>
+                <a:cs typeface="Calibri" pitchFamily="34" charset="-120"/>
+              </a:rPr>
+              <a:t>The reconstructed images are identical in both cases.</a:t>
             </a:r>
             <a:endParaRPr lang="en-US" sz="1500" dirty="0"/>
           </a:p>
@@ -23048,7 +23137,7 @@
                 <a:ea typeface="Cambria" pitchFamily="34" charset="-122"/>
                 <a:cs typeface="Cambria" pitchFamily="34" charset="-120"/>
               </a:rPr>
-              <a:t>Karp–Flatt Metric</a:t>
+              <a:t>Throughput</a:t>
             </a:r>
             <a:endParaRPr lang="en-US" sz="2800" dirty="0"/>
           </a:p>
@@ -23079,9 +23168,376 @@
           </a:ln>
         </p:spPr>
       </p:sp>
+      <p:sp>
+        <p:nvSpPr>
+          <p:cNvPr id="6" name="Shape 4"/>
+          <p:cNvSpPr/>
+          <p:nvPr/>
+        </p:nvSpPr>
+        <p:spPr>
+          <a:xfrm>
+            <a:off x="457200" y="1234440"/>
+            <a:ext cx="7498080" cy="5029200"/>
+          </a:xfrm>
+          <a:prstGeom prst="roundRect">
+            <a:avLst>
+              <a:gd name="adj" fmla="val 1455"/>
+            </a:avLst>
+          </a:prstGeom>
+          <a:solidFill>
+            <a:srgbClr val="FFFFFF"/>
+          </a:solidFill>
+          <a:ln w="15875">
+            <a:solidFill>
+              <a:srgbClr val="2A9D8F"/>
+            </a:solidFill>
+            <a:prstDash val="solid"/>
+          </a:ln>
+        </p:spPr>
+      </p:sp>
+      <p:pic>
+        <p:nvPicPr>
+          <p:cNvPr id="7" name="Image 0" descr="assets/throughput_ch4.png">    </p:cNvPr>
+          <p:cNvPicPr>
+            <a:picLocks noChangeAspect="1"/>
+          </p:cNvPicPr>
+          <p:nvPr/>
+        </p:nvPicPr>
+        <p:blipFill>
+          <a:blip r:embed="rId1"/>
+          <a:stretch>
+            <a:fillRect/>
+          </a:stretch>
+        </p:blipFill>
+        <p:spPr>
+          <a:xfrm>
+            <a:off x="457200" y="1269906"/>
+            <a:ext cx="7498080" cy="4958268"/>
+          </a:xfrm>
+          <a:prstGeom prst="rect">
+            <a:avLst/>
+          </a:prstGeom>
+        </p:spPr>
+      </p:pic>
+      <p:sp>
+        <p:nvSpPr>
+          <p:cNvPr id="8" name="Shape 5"/>
+          <p:cNvSpPr/>
+          <p:nvPr/>
+        </p:nvSpPr>
+        <p:spPr>
+          <a:xfrm>
+            <a:off x="8183880" y="1234440"/>
+            <a:ext cx="3566160" cy="5029200"/>
+          </a:xfrm>
+          <a:prstGeom prst="roundRect">
+            <a:avLst>
+              <a:gd name="adj" fmla="val 2051"/>
+            </a:avLst>
+          </a:prstGeom>
+          <a:solidFill>
+            <a:srgbClr val="F5F1FB"/>
+          </a:solidFill>
+          <a:ln w="12700">
+            <a:solidFill>
+              <a:srgbClr val="F5F1FB"/>
+            </a:solidFill>
+            <a:prstDash val="solid"/>
+          </a:ln>
+        </p:spPr>
+      </p:sp>
+      <p:sp>
+        <p:nvSpPr>
+          <p:cNvPr id="9" name="Text 6"/>
+          <p:cNvSpPr/>
+          <p:nvPr/>
+        </p:nvSpPr>
+        <p:spPr>
+          <a:xfrm>
+            <a:off x="8275320" y="1325880"/>
+            <a:ext cx="3383280" cy="4846320"/>
+          </a:xfrm>
+          <a:prstGeom prst="rect">
+            <a:avLst/>
+          </a:prstGeom>
+          <a:noFill/>
+          <a:ln/>
+        </p:spPr>
+        <p:txBody>
+          <a:bodyPr wrap="square" lIns="1016" tIns="1016" rIns="1016" bIns="1016" rtlCol="0" anchor="t"/>
+          <a:lstStyle/>
+          <a:p>
+            <a:pPr marL="342900" indent="-342900">
+              <a:spcAft>
+                <a:spcPts val="900"/>
+              </a:spcAft>
+              <a:buSzPct val="100000"/>
+              <a:buChar char="■"/>
+            </a:pPr>
+            <a:r>
+              <a:rPr lang="en-US" sz="1500" dirty="0">
+                <a:solidFill>
+                  <a:srgbClr val="1F1A33"/>
+                </a:solidFill>
+                <a:latin typeface="Calibri" pitchFamily="34" charset="0"/>
+                <a:ea typeface="Calibri" pitchFamily="34" charset="-122"/>
+                <a:cs typeface="Calibri" pitchFamily="34" charset="-120"/>
+              </a:rPr>
+              <a:t>Throughput = original image size / total execution time (MiB/s).</a:t>
+            </a:r>
+            <a:endParaRPr lang="en-US" sz="1500" dirty="0"/>
+          </a:p>
+          <a:p>
+            <a:pPr marL="342900" indent="-342900">
+              <a:spcAft>
+                <a:spcPts val="900"/>
+              </a:spcAft>
+              <a:buSzPct val="100000"/>
+              <a:buChar char="■"/>
+            </a:pPr>
+            <a:r>
+              <a:rPr lang="en-US" sz="1500" dirty="0">
+                <a:solidFill>
+                  <a:srgbClr val="1F1A33"/>
+                </a:solidFill>
+                <a:latin typeface="Calibri" pitchFamily="34" charset="0"/>
+                <a:ea typeface="Calibri" pitchFamily="34" charset="-122"/>
+                <a:cs typeface="Calibri" pitchFamily="34" charset="-120"/>
+              </a:rPr>
+              <a:t>Grayscale: 1.30 → 3.35 MiB/s from P = 2 to P = 14.</a:t>
+            </a:r>
+            <a:endParaRPr lang="en-US" sz="1500" dirty="0"/>
+          </a:p>
+          <a:p>
+            <a:pPr marL="342900" indent="-342900">
+              <a:spcAft>
+                <a:spcPts val="900"/>
+              </a:spcAft>
+              <a:buSzPct val="100000"/>
+              <a:buChar char="■"/>
+            </a:pPr>
+            <a:r>
+              <a:rPr lang="en-US" sz="1500" dirty="0">
+                <a:solidFill>
+                  <a:srgbClr val="1F1A33"/>
+                </a:solidFill>
+                <a:latin typeface="Calibri" pitchFamily="34" charset="0"/>
+                <a:ea typeface="Calibri" pitchFamily="34" charset="-122"/>
+                <a:cs typeface="Calibri" pitchFamily="34" charset="-120"/>
+              </a:rPr>
+              <a:t>Color: 1.42 → 4.54 MiB/s.</a:t>
+            </a:r>
+            <a:endParaRPr lang="en-US" sz="1500" dirty="0"/>
+          </a:p>
+          <a:p>
+            <a:pPr marL="342900" indent="-342900">
+              <a:spcAft>
+                <a:spcPts val="900"/>
+              </a:spcAft>
+              <a:buSzPct val="100000"/>
+              <a:buChar char="■"/>
+            </a:pPr>
+            <a:r>
+              <a:rPr lang="en-US" sz="1500" dirty="0">
+                <a:solidFill>
+                  <a:srgbClr val="1F1A33"/>
+                </a:solidFill>
+                <a:latin typeface="Calibri" pitchFamily="34" charset="0"/>
+                <a:ea typeface="Calibri" pitchFamily="34" charset="-122"/>
+                <a:cs typeface="Calibri" pitchFamily="34" charset="-120"/>
+              </a:rPr>
+              <a:t>Color images hold three times more data, but their total time grows by only about 2.2× at P = 14, so their throughput is higher.</a:t>
+            </a:r>
+            <a:endParaRPr lang="en-US" sz="1500" dirty="0"/>
+          </a:p>
+          <a:p>
+            <a:pPr marL="342900" indent="-342900">
+              <a:spcAft>
+                <a:spcPts val="900"/>
+              </a:spcAft>
+              <a:buSzPct val="100000"/>
+              <a:buChar char="■"/>
+            </a:pPr>
+            <a:r>
+              <a:rPr lang="en-US" sz="1500" dirty="0">
+                <a:solidFill>
+                  <a:srgbClr val="1F1A33"/>
+                </a:solidFill>
+                <a:latin typeface="Calibri" pitchFamily="34" charset="0"/>
+                <a:ea typeface="Calibri" pitchFamily="34" charset="-122"/>
+                <a:cs typeface="Calibri" pitchFamily="34" charset="-120"/>
+              </a:rPr>
+              <a:t>Shaded bands: minimum to maximum over the images.</a:t>
+            </a:r>
+            <a:endParaRPr lang="en-US" sz="1500" dirty="0"/>
+          </a:p>
+        </p:txBody>
+      </p:sp>
+    </p:spTree>
+  </p:cSld>
+  <p:clrMapOvr>
+    <a:masterClrMapping/>
+  </p:clrMapOvr>
+</p:sld>
+</file>
+
+<file path=ppt/slides/slide28.xml><?xml version="1.0" encoding="utf-8"?>
+<p:sld xmlns:a="http://schemas.openxmlformats.org/drawingml/2006/main" xmlns:r="http://schemas.openxmlformats.org/officeDocument/2006/relationships" xmlns:p="http://schemas.openxmlformats.org/presentationml/2006/main">
+  <p:cSld name="Slide 28">
+    <p:bg>
+      <p:bgPr>
+        <a:solidFill>
+          <a:srgbClr val="FFFFFF"/>
+        </a:solidFill>
+      </p:bgPr>
+    </p:bg>
+    <p:spTree>
+      <p:nvGrpSpPr>
+        <p:cNvPr id="1" name=""/>
+        <p:cNvGrpSpPr/>
+        <p:nvPr/>
+      </p:nvGrpSpPr>
+      <p:grpSpPr>
+        <a:xfrm>
+          <a:off x="0" y="0"/>
+          <a:ext cx="0" cy="0"/>
+          <a:chOff x="0" y="0"/>
+          <a:chExt cx="0" cy="0"/>
+        </a:xfrm>
+      </p:grpSpPr>
+      <p:sp>
+        <p:nvSpPr>
+          <p:cNvPr id="2" name="Shape 0"/>
+          <p:cNvSpPr/>
+          <p:nvPr/>
+        </p:nvSpPr>
+        <p:spPr>
+          <a:xfrm>
+            <a:off x="457200" y="320040"/>
+            <a:ext cx="1737360" cy="502920"/>
+          </a:xfrm>
+          <a:prstGeom prst="roundRect">
+            <a:avLst>
+              <a:gd name="adj" fmla="val 18182"/>
+            </a:avLst>
+          </a:prstGeom>
+          <a:solidFill>
+            <a:srgbClr val="2A9D8F"/>
+          </a:solidFill>
+          <a:ln w="12700">
+            <a:solidFill>
+              <a:srgbClr val="2A9D8F"/>
+            </a:solidFill>
+            <a:prstDash val="solid"/>
+          </a:ln>
+        </p:spPr>
+      </p:sp>
+      <p:sp>
+        <p:nvSpPr>
+          <p:cNvPr id="3" name="Text 1"/>
+          <p:cNvSpPr/>
+          <p:nvPr/>
+        </p:nvSpPr>
+        <p:spPr>
+          <a:xfrm>
+            <a:off x="457200" y="320040"/>
+            <a:ext cx="1737360" cy="502920"/>
+          </a:xfrm>
+          <a:prstGeom prst="rect">
+            <a:avLst/>
+          </a:prstGeom>
+          <a:noFill/>
+          <a:ln/>
+        </p:spPr>
+        <p:txBody>
+          <a:bodyPr wrap="square" lIns="0" tIns="0" rIns="0" bIns="0" rtlCol="0" anchor="ctr"/>
+          <a:lstStyle/>
+          <a:p>
+            <a:pPr algn="ctr" indent="0" marL="0">
+              <a:buNone/>
+            </a:pPr>
+            <a:r>
+              <a:rPr lang="en-US" sz="1800" b="1" dirty="0">
+                <a:solidFill>
+                  <a:srgbClr val="FFFFFF"/>
+                </a:solidFill>
+                <a:latin typeface="Calibri" pitchFamily="34" charset="0"/>
+                <a:ea typeface="Calibri" pitchFamily="34" charset="-122"/>
+                <a:cs typeface="Calibri" pitchFamily="34" charset="-120"/>
+              </a:rPr>
+              <a:t>Results</a:t>
+            </a:r>
+            <a:endParaRPr lang="en-US" sz="1800" dirty="0"/>
+          </a:p>
+        </p:txBody>
+      </p:sp>
+      <p:sp>
+        <p:nvSpPr>
+          <p:cNvPr id="4" name="Text 2"/>
+          <p:cNvSpPr/>
+          <p:nvPr/>
+        </p:nvSpPr>
+        <p:spPr>
+          <a:xfrm>
+            <a:off x="2377440" y="274320"/>
+            <a:ext cx="9326880" cy="594360"/>
+          </a:xfrm>
+          <a:prstGeom prst="rect">
+            <a:avLst/>
+          </a:prstGeom>
+          <a:noFill/>
+          <a:ln/>
+        </p:spPr>
+        <p:txBody>
+          <a:bodyPr wrap="square" lIns="0" tIns="0" rIns="0" bIns="0" rtlCol="0" anchor="ctr"/>
+          <a:lstStyle/>
+          <a:p>
+            <a:pPr indent="0" marL="0">
+              <a:buNone/>
+            </a:pPr>
+            <a:r>
+              <a:rPr lang="en-US" sz="2800" b="1" dirty="0">
+                <a:solidFill>
+                  <a:srgbClr val="2E2055"/>
+                </a:solidFill>
+                <a:latin typeface="Cambria" pitchFamily="34" charset="0"/>
+                <a:ea typeface="Cambria" pitchFamily="34" charset="-122"/>
+                <a:cs typeface="Cambria" pitchFamily="34" charset="-120"/>
+              </a:rPr>
+              <a:t>Karp–Flatt Metric</a:t>
+            </a:r>
+            <a:endParaRPr lang="en-US" sz="2800" dirty="0"/>
+          </a:p>
+        </p:txBody>
+      </p:sp>
+      <p:sp>
+        <p:nvSpPr>
+          <p:cNvPr id="5" name="Shape 3"/>
+          <p:cNvSpPr/>
+          <p:nvPr/>
+        </p:nvSpPr>
+        <p:spPr>
+          <a:xfrm>
+            <a:off x="457200" y="960120"/>
+            <a:ext cx="11274552" cy="36576"/>
+          </a:xfrm>
+          <a:prstGeom prst="rect">
+            <a:avLst/>
+          </a:prstGeom>
+          <a:solidFill>
+            <a:srgbClr val="2A9D8F"/>
+          </a:solidFill>
+          <a:ln w="12700">
+            <a:solidFill>
+              <a:srgbClr val="2A9D8F"/>
+            </a:solidFill>
+            <a:prstDash val="solid"/>
+          </a:ln>
+        </p:spPr>
+      </p:sp>
       <p:graphicFrame>
         <p:nvGraphicFramePr>
-          <p:cNvPr id="28" name="Table 0"/>
+          <p:cNvPr id="29" name="Table 0"/>
           <p:cNvGraphicFramePr>
             <a:graphicFrameLocks noGrp="1"/>
           </p:cNvGraphicFramePr>
@@ -26028,343 +26484,6 @@
 </p:sld>
 </file>
 
-<file path=ppt/slides/slide28.xml><?xml version="1.0" encoding="utf-8"?>
-<p:sld xmlns:a="http://schemas.openxmlformats.org/drawingml/2006/main" xmlns:r="http://schemas.openxmlformats.org/officeDocument/2006/relationships" xmlns:p="http://schemas.openxmlformats.org/presentationml/2006/main">
-  <p:cSld name="Slide 28">
-    <p:bg>
-      <p:bgPr>
-        <a:solidFill>
-          <a:srgbClr val="FFFFFF"/>
-        </a:solidFill>
-      </p:bgPr>
-    </p:bg>
-    <p:spTree>
-      <p:nvGrpSpPr>
-        <p:cNvPr id="1" name=""/>
-        <p:cNvGrpSpPr/>
-        <p:nvPr/>
-      </p:nvGrpSpPr>
-      <p:grpSpPr>
-        <a:xfrm>
-          <a:off x="0" y="0"/>
-          <a:ext cx="0" cy="0"/>
-          <a:chOff x="0" y="0"/>
-          <a:chExt cx="0" cy="0"/>
-        </a:xfrm>
-      </p:grpSpPr>
-      <p:sp>
-        <p:nvSpPr>
-          <p:cNvPr id="2" name="Shape 0"/>
-          <p:cNvSpPr/>
-          <p:nvPr/>
-        </p:nvSpPr>
-        <p:spPr>
-          <a:xfrm>
-            <a:off x="457200" y="320040"/>
-            <a:ext cx="2103120" cy="502920"/>
-          </a:xfrm>
-          <a:prstGeom prst="roundRect">
-            <a:avLst>
-              <a:gd name="adj" fmla="val 18182"/>
-            </a:avLst>
-          </a:prstGeom>
-          <a:solidFill>
-            <a:srgbClr val="2E2055"/>
-          </a:solidFill>
-          <a:ln w="12700">
-            <a:solidFill>
-              <a:srgbClr val="2E2055"/>
-            </a:solidFill>
-            <a:prstDash val="solid"/>
-          </a:ln>
-        </p:spPr>
-      </p:sp>
-      <p:sp>
-        <p:nvSpPr>
-          <p:cNvPr id="3" name="Text 1"/>
-          <p:cNvSpPr/>
-          <p:nvPr/>
-        </p:nvSpPr>
-        <p:spPr>
-          <a:xfrm>
-            <a:off x="457200" y="320040"/>
-            <a:ext cx="2103120" cy="502920"/>
-          </a:xfrm>
-          <a:prstGeom prst="rect">
-            <a:avLst/>
-          </a:prstGeom>
-          <a:noFill/>
-          <a:ln/>
-        </p:spPr>
-        <p:txBody>
-          <a:bodyPr wrap="square" lIns="0" tIns="0" rIns="0" bIns="0" rtlCol="0" anchor="ctr"/>
-          <a:lstStyle/>
-          <a:p>
-            <a:pPr algn="ctr" indent="0" marL="0">
-              <a:buNone/>
-            </a:pPr>
-            <a:r>
-              <a:rPr lang="en-US" sz="1600" b="1" dirty="0">
-                <a:solidFill>
-                  <a:srgbClr val="FFFFFF"/>
-                </a:solidFill>
-                <a:latin typeface="Calibri" pitchFamily="34" charset="0"/>
-                <a:ea typeface="Calibri" pitchFamily="34" charset="-122"/>
-                <a:cs typeface="Calibri" pitchFamily="34" charset="-120"/>
-              </a:rPr>
-              <a:t>Conclusion</a:t>
-            </a:r>
-            <a:endParaRPr lang="en-US" sz="1600" dirty="0"/>
-          </a:p>
-        </p:txBody>
-      </p:sp>
-      <p:sp>
-        <p:nvSpPr>
-          <p:cNvPr id="4" name="Text 2"/>
-          <p:cNvSpPr/>
-          <p:nvPr/>
-        </p:nvSpPr>
-        <p:spPr>
-          <a:xfrm>
-            <a:off x="2743200" y="274320"/>
-            <a:ext cx="9418320" cy="594360"/>
-          </a:xfrm>
-          <a:prstGeom prst="rect">
-            <a:avLst/>
-          </a:prstGeom>
-          <a:noFill/>
-          <a:ln/>
-        </p:spPr>
-        <p:txBody>
-          <a:bodyPr wrap="square" lIns="0" tIns="0" rIns="0" bIns="0" rtlCol="0" anchor="ctr"/>
-          <a:lstStyle/>
-          <a:p>
-            <a:pPr indent="0" marL="0">
-              <a:buNone/>
-            </a:pPr>
-            <a:r>
-              <a:rPr lang="en-US" sz="2800" b="1" dirty="0">
-                <a:solidFill>
-                  <a:srgbClr val="2E2055"/>
-                </a:solidFill>
-                <a:latin typeface="Cambria" pitchFamily="34" charset="0"/>
-                <a:ea typeface="Cambria" pitchFamily="34" charset="-122"/>
-                <a:cs typeface="Cambria" pitchFamily="34" charset="-120"/>
-              </a:rPr>
-              <a:t>Conclusion</a:t>
-            </a:r>
-            <a:endParaRPr lang="en-US" sz="2800" dirty="0"/>
-          </a:p>
-        </p:txBody>
-      </p:sp>
-      <p:sp>
-        <p:nvSpPr>
-          <p:cNvPr id="5" name="Shape 3"/>
-          <p:cNvSpPr/>
-          <p:nvPr/>
-        </p:nvSpPr>
-        <p:spPr>
-          <a:xfrm>
-            <a:off x="457200" y="960120"/>
-            <a:ext cx="11274552" cy="36576"/>
-          </a:xfrm>
-          <a:prstGeom prst="rect">
-            <a:avLst/>
-          </a:prstGeom>
-          <a:solidFill>
-            <a:srgbClr val="2E2055"/>
-          </a:solidFill>
-          <a:ln w="12700">
-            <a:solidFill>
-              <a:srgbClr val="2E2055"/>
-            </a:solidFill>
-            <a:prstDash val="solid"/>
-          </a:ln>
-        </p:spPr>
-      </p:sp>
-      <p:sp>
-        <p:nvSpPr>
-          <p:cNvPr id="6" name="Shape 4"/>
-          <p:cNvSpPr/>
-          <p:nvPr/>
-        </p:nvSpPr>
-        <p:spPr>
-          <a:xfrm>
-            <a:off x="640080" y="1280160"/>
-            <a:ext cx="10927080" cy="5029200"/>
-          </a:xfrm>
-          <a:prstGeom prst="roundRect">
-            <a:avLst>
-              <a:gd name="adj" fmla="val 1455"/>
-            </a:avLst>
-          </a:prstGeom>
-          <a:solidFill>
-            <a:srgbClr val="F5F1FB"/>
-          </a:solidFill>
-          <a:ln w="12700">
-            <a:solidFill>
-              <a:srgbClr val="F5F1FB"/>
-            </a:solidFill>
-            <a:prstDash val="solid"/>
-          </a:ln>
-        </p:spPr>
-      </p:sp>
-      <p:sp>
-        <p:nvSpPr>
-          <p:cNvPr id="7" name="Text 5"/>
-          <p:cNvSpPr/>
-          <p:nvPr/>
-        </p:nvSpPr>
-        <p:spPr>
-          <a:xfrm>
-            <a:off x="777240" y="1371600"/>
-            <a:ext cx="10652760" cy="4846320"/>
-          </a:xfrm>
-          <a:prstGeom prst="rect">
-            <a:avLst/>
-          </a:prstGeom>
-          <a:noFill/>
-          <a:ln/>
-        </p:spPr>
-        <p:txBody>
-          <a:bodyPr wrap="square" lIns="1016" tIns="1016" rIns="1016" bIns="1016" rtlCol="0" anchor="t"/>
-          <a:lstStyle/>
-          <a:p>
-            <a:pPr marL="342900" indent="-342900">
-              <a:spcAft>
-                <a:spcPts val="1000"/>
-              </a:spcAft>
-              <a:buSzPct val="100000"/>
-              <a:buChar char="■"/>
-            </a:pPr>
-            <a:r>
-              <a:rPr lang="en-US" sz="1900" dirty="0">
-                <a:solidFill>
-                  <a:srgbClr val="1F1A33"/>
-                </a:solidFill>
-                <a:latin typeface="Calibri" pitchFamily="34" charset="0"/>
-                <a:ea typeface="Calibri" pitchFamily="34" charset="-122"/>
-                <a:cs typeface="Calibri" pitchFamily="34" charset="-120"/>
-              </a:rPr>
-              <a:t>A hybrid image compression framework was implemented: LBG vector quantization, delta coding and Huffman coding.</a:t>
-            </a:r>
-            <a:endParaRPr lang="en-US" sz="1900" dirty="0"/>
-          </a:p>
-          <a:p>
-            <a:pPr marL="342900" indent="-342900">
-              <a:spcAft>
-                <a:spcPts val="1000"/>
-              </a:spcAft>
-              <a:buSzPct val="100000"/>
-              <a:buChar char="■"/>
-            </a:pPr>
-            <a:r>
-              <a:rPr lang="en-US" sz="1900" dirty="0">
-                <a:solidFill>
-                  <a:srgbClr val="1F1A33"/>
-                </a:solidFill>
-                <a:latin typeface="Calibri" pitchFamily="34" charset="0"/>
-                <a:ea typeface="Calibri" pitchFamily="34" charset="-122"/>
-                <a:cs typeface="Calibri" pitchFamily="34" charset="-120"/>
-              </a:rPr>
-              <a:t>LBG training was parallelized with MPI: 9.19× speedup on 14 processes (efficiency ≈ 66%); total speedup 5.00× (gray) and 6.84× (color).</a:t>
-            </a:r>
-            <a:endParaRPr lang="en-US" sz="1900" dirty="0"/>
-          </a:p>
-          <a:p>
-            <a:pPr marL="342900" indent="-342900">
-              <a:spcAft>
-                <a:spcPts val="1000"/>
-              </a:spcAft>
-              <a:buSzPct val="100000"/>
-              <a:buChar char="■"/>
-            </a:pPr>
-            <a:r>
-              <a:rPr lang="en-US" sz="1900" dirty="0">
-                <a:solidFill>
-                  <a:srgbClr val="1F1A33"/>
-                </a:solidFill>
-                <a:latin typeface="Calibri" pitchFamily="34" charset="0"/>
-                <a:ea typeface="Calibri" pitchFamily="34" charset="-122"/>
-                <a:cs typeface="Calibri" pitchFamily="34" charset="-120"/>
-              </a:rPr>
-              <a:t>The speed-aware (Adaptive) distribution reduced LBG time by 17.2–28.3% compared with Equal distribution (P = 8 to 14).</a:t>
-            </a:r>
-            <a:endParaRPr lang="en-US" sz="1900" dirty="0"/>
-          </a:p>
-          <a:p>
-            <a:pPr marL="342900" indent="-342900">
-              <a:spcAft>
-                <a:spcPts val="1000"/>
-              </a:spcAft>
-              <a:buSzPct val="100000"/>
-              <a:buChar char="■"/>
-            </a:pPr>
-            <a:r>
-              <a:rPr lang="en-US" sz="1900" dirty="0">
-                <a:solidFill>
-                  <a:srgbClr val="1F1A33"/>
-                </a:solidFill>
-                <a:latin typeface="Calibri" pitchFamily="34" charset="0"/>
-                <a:ea typeface="Calibri" pitchFamily="34" charset="-122"/>
-                <a:cs typeface="Calibri" pitchFamily="34" charset="-120"/>
-              </a:rPr>
-              <a:t>The parallel results were identical to the sequential ones: same reconstructed images and quality metrics.</a:t>
-            </a:r>
-            <a:endParaRPr lang="en-US" sz="1900" dirty="0"/>
-          </a:p>
-          <a:p>
-            <a:pPr marL="342900" indent="-342900">
-              <a:spcAft>
-                <a:spcPts val="1000"/>
-              </a:spcAft>
-              <a:buSzPct val="100000"/>
-              <a:buChar char="■"/>
-            </a:pPr>
-            <a:r>
-              <a:rPr lang="en-US" sz="1900" dirty="0">
-                <a:solidFill>
-                  <a:srgbClr val="1F1A33"/>
-                </a:solidFill>
-                <a:latin typeface="Calibri" pitchFamily="34" charset="0"/>
-                <a:ea typeface="Calibri" pitchFamily="34" charset="-122"/>
-                <a:cs typeface="Calibri" pitchFamily="34" charset="-120"/>
-              </a:rPr>
-              <a:t>Quality: mean PSNR 29.49 dB and SSIM 0.8266 (gray); 28.80 dB and 0.7654 (color), at a compression ratio of ___ (gray) and ___ (color).</a:t>
-            </a:r>
-            <a:endParaRPr lang="en-US" sz="1900" dirty="0"/>
-          </a:p>
-          <a:p>
-            <a:pPr marL="342900" indent="-342900">
-              <a:spcAft>
-                <a:spcPts val="1000"/>
-              </a:spcAft>
-              <a:buSzPct val="100000"/>
-              <a:buChar char="■"/>
-            </a:pPr>
-            <a:r>
-              <a:rPr lang="en-US" sz="1900" dirty="0">
-                <a:solidFill>
-                  <a:srgbClr val="1F1A33"/>
-                </a:solidFill>
-                <a:latin typeface="Calibri" pitchFamily="34" charset="0"/>
-                <a:ea typeface="Calibri" pitchFamily="34" charset="-122"/>
-                <a:cs typeface="Calibri" pitchFamily="34" charset="-120"/>
-              </a:rPr>
-              <a:t>The total speedup is limited by the sequential coding and reconstruction stages.</a:t>
-            </a:r>
-            <a:endParaRPr lang="en-US" sz="1900" dirty="0"/>
-          </a:p>
-        </p:txBody>
-      </p:sp>
-    </p:spTree>
-  </p:cSld>
-  <p:clrMapOvr>
-    <a:masterClrMapping/>
-  </p:clrMapOvr>
-</p:sld>
-</file>
-
 <file path=ppt/slides/slide29.xml><?xml version="1.0" encoding="utf-8"?>
 <p:sld xmlns:a="http://schemas.openxmlformats.org/drawingml/2006/main" xmlns:r="http://schemas.openxmlformats.org/officeDocument/2006/relationships" xmlns:p="http://schemas.openxmlformats.org/presentationml/2006/main">
   <p:cSld name="Slide 29">
@@ -26449,7 +26568,7 @@
                 <a:ea typeface="Calibri" pitchFamily="34" charset="-122"/>
                 <a:cs typeface="Calibri" pitchFamily="34" charset="-120"/>
               </a:rPr>
-              <a:t>Future Work</a:t>
+              <a:t>Conclusion</a:t>
             </a:r>
             <a:endParaRPr lang="en-US" sz="1600" dirty="0"/>
           </a:p>
@@ -26488,7 +26607,7 @@
                 <a:ea typeface="Cambria" pitchFamily="34" charset="-122"/>
                 <a:cs typeface="Cambria" pitchFamily="34" charset="-120"/>
               </a:rPr>
-              <a:t>Future Work</a:t>
+              <a:t>Conclusion</a:t>
             </a:r>
             <a:endParaRPr lang="en-US" sz="2800" dirty="0"/>
           </a:p>
@@ -26575,7 +26694,7 @@
               <a:buChar char="■"/>
             </a:pPr>
             <a:r>
-              <a:rPr lang="en-US" sz="2100" dirty="0">
+              <a:rPr lang="en-US" sz="1900" dirty="0">
                 <a:solidFill>
                   <a:srgbClr val="1F1A33"/>
                 </a:solidFill>
@@ -26583,9 +26702,9 @@
                 <a:ea typeface="Calibri" pitchFamily="34" charset="-122"/>
                 <a:cs typeface="Calibri" pitchFamily="34" charset="-120"/>
               </a:rPr>
-              <a:t>Parallelize the delta coding, Huffman coding and reconstruction stages.</a:t>
-            </a:r>
-            <a:endParaRPr lang="en-US" sz="2100" dirty="0"/>
+              <a:t>A hybrid image compression framework was implemented: LBG vector quantization, delta coding and Huffman coding.</a:t>
+            </a:r>
+            <a:endParaRPr lang="en-US" sz="1900" dirty="0"/>
           </a:p>
           <a:p>
             <a:pPr marL="342900" indent="-342900">
@@ -26596,7 +26715,7 @@
               <a:buChar char="■"/>
             </a:pPr>
             <a:r>
-              <a:rPr lang="en-US" sz="2100" dirty="0">
+              <a:rPr lang="en-US" sz="1900" dirty="0">
                 <a:solidFill>
                   <a:srgbClr val="1F1A33"/>
                 </a:solidFill>
@@ -26604,9 +26723,9 @@
                 <a:ea typeface="Calibri" pitchFamily="34" charset="-122"/>
                 <a:cs typeface="Calibri" pitchFamily="34" charset="-120"/>
               </a:rPr>
-              <a:t>Evaluate other block sizes, codebook sizes and larger images.</a:t>
-            </a:r>
-            <a:endParaRPr lang="en-US" sz="2100" dirty="0"/>
+              <a:t>LBG training was parallelized with MPI: 9.19× speedup on 14 processes (efficiency ≈ 66%); total speedup 5.00× (gray) and 6.84× (color).</a:t>
+            </a:r>
+            <a:endParaRPr lang="en-US" sz="1900" dirty="0"/>
           </a:p>
           <a:p>
             <a:pPr marL="342900" indent="-342900">
@@ -26617,7 +26736,7 @@
               <a:buChar char="■"/>
             </a:pPr>
             <a:r>
-              <a:rPr lang="en-US" sz="2100" dirty="0">
+              <a:rPr lang="en-US" sz="1900" dirty="0">
                 <a:solidFill>
                   <a:srgbClr val="1F1A33"/>
                 </a:solidFill>
@@ -26625,9 +26744,9 @@
                 <a:ea typeface="Calibri" pitchFamily="34" charset="-122"/>
                 <a:cs typeface="Calibri" pitchFamily="34" charset="-120"/>
               </a:rPr>
-              <a:t>Define an efficiency measure that accounts for the different speeds of P-cores and E-cores.</a:t>
-            </a:r>
-            <a:endParaRPr lang="en-US" sz="2100" dirty="0"/>
+              <a:t>The speed-aware (Adaptive) distribution reduced LBG time by 17.2–28.3% compared with Equal distribution (P = 8 to 14).</a:t>
+            </a:r>
+            <a:endParaRPr lang="en-US" sz="1900" dirty="0"/>
           </a:p>
           <a:p>
             <a:pPr marL="342900" indent="-342900">
@@ -26638,7 +26757,7 @@
               <a:buChar char="■"/>
             </a:pPr>
             <a:r>
-              <a:rPr lang="en-US" sz="2100" dirty="0">
+              <a:rPr lang="en-US" sz="1900" dirty="0">
                 <a:solidFill>
                   <a:srgbClr val="1F1A33"/>
                 </a:solidFill>
@@ -26646,9 +26765,9 @@
                 <a:ea typeface="Calibri" pitchFamily="34" charset="-122"/>
                 <a:cs typeface="Calibri" pitchFamily="34" charset="-120"/>
               </a:rPr>
-              <a:t>Implement a complete container file format (stored Huffman table and header) with a stand-alone decoder; the current program only accounts the compressed size.</a:t>
-            </a:r>
-            <a:endParaRPr lang="en-US" sz="2100" dirty="0"/>
+              <a:t>The parallel results were identical to the sequential ones: same reconstructed images and quality metrics.</a:t>
+            </a:r>
+            <a:endParaRPr lang="en-US" sz="1900" dirty="0"/>
           </a:p>
           <a:p>
             <a:pPr marL="342900" indent="-342900">
@@ -26659,7 +26778,7 @@
               <a:buChar char="■"/>
             </a:pPr>
             <a:r>
-              <a:rPr lang="en-US" sz="2100" dirty="0">
+              <a:rPr lang="en-US" sz="1900" dirty="0">
                 <a:solidFill>
                   <a:srgbClr val="1F1A33"/>
                 </a:solidFill>
@@ -26667,9 +26786,30 @@
                 <a:ea typeface="Calibri" pitchFamily="34" charset="-122"/>
                 <a:cs typeface="Calibri" pitchFamily="34" charset="-120"/>
               </a:rPr>
-              <a:t>Extend the study to other hybrid CPUs and to hybrid MPI + OpenMP implementations.</a:t>
-            </a:r>
-            <a:endParaRPr lang="en-US" sz="2100" dirty="0"/>
+              <a:t>Quality: mean PSNR 29.49 dB and SSIM 0.8266 (gray); 28.80 dB and 0.7654 (color), at a compression ratio of ___ (gray) and ___ (color).</a:t>
+            </a:r>
+            <a:endParaRPr lang="en-US" sz="1900" dirty="0"/>
+          </a:p>
+          <a:p>
+            <a:pPr marL="342900" indent="-342900">
+              <a:spcAft>
+                <a:spcPts val="1000"/>
+              </a:spcAft>
+              <a:buSzPct val="100000"/>
+              <a:buChar char="■"/>
+            </a:pPr>
+            <a:r>
+              <a:rPr lang="en-US" sz="1900" dirty="0">
+                <a:solidFill>
+                  <a:srgbClr val="1F1A33"/>
+                </a:solidFill>
+                <a:latin typeface="Calibri" pitchFamily="34" charset="0"/>
+                <a:ea typeface="Calibri" pitchFamily="34" charset="-122"/>
+                <a:cs typeface="Calibri" pitchFamily="34" charset="-120"/>
+              </a:rPr>
+              <a:t>The total speedup is limited by the sequential coding and reconstruction stages.</a:t>
+            </a:r>
+            <a:endParaRPr lang="en-US" sz="1900" dirty="0"/>
           </a:p>
         </p:txBody>
       </p:sp>
@@ -27227,6 +27367,322 @@
 <file path=ppt/slides/slide30.xml><?xml version="1.0" encoding="utf-8"?>
 <p:sld xmlns:a="http://schemas.openxmlformats.org/drawingml/2006/main" xmlns:r="http://schemas.openxmlformats.org/officeDocument/2006/relationships" xmlns:p="http://schemas.openxmlformats.org/presentationml/2006/main">
   <p:cSld name="Slide 30">
+    <p:bg>
+      <p:bgPr>
+        <a:solidFill>
+          <a:srgbClr val="FFFFFF"/>
+        </a:solidFill>
+      </p:bgPr>
+    </p:bg>
+    <p:spTree>
+      <p:nvGrpSpPr>
+        <p:cNvPr id="1" name=""/>
+        <p:cNvGrpSpPr/>
+        <p:nvPr/>
+      </p:nvGrpSpPr>
+      <p:grpSpPr>
+        <a:xfrm>
+          <a:off x="0" y="0"/>
+          <a:ext cx="0" cy="0"/>
+          <a:chOff x="0" y="0"/>
+          <a:chExt cx="0" cy="0"/>
+        </a:xfrm>
+      </p:grpSpPr>
+      <p:sp>
+        <p:nvSpPr>
+          <p:cNvPr id="2" name="Shape 0"/>
+          <p:cNvSpPr/>
+          <p:nvPr/>
+        </p:nvSpPr>
+        <p:spPr>
+          <a:xfrm>
+            <a:off x="457200" y="320040"/>
+            <a:ext cx="2103120" cy="502920"/>
+          </a:xfrm>
+          <a:prstGeom prst="roundRect">
+            <a:avLst>
+              <a:gd name="adj" fmla="val 18182"/>
+            </a:avLst>
+          </a:prstGeom>
+          <a:solidFill>
+            <a:srgbClr val="2E2055"/>
+          </a:solidFill>
+          <a:ln w="12700">
+            <a:solidFill>
+              <a:srgbClr val="2E2055"/>
+            </a:solidFill>
+            <a:prstDash val="solid"/>
+          </a:ln>
+        </p:spPr>
+      </p:sp>
+      <p:sp>
+        <p:nvSpPr>
+          <p:cNvPr id="3" name="Text 1"/>
+          <p:cNvSpPr/>
+          <p:nvPr/>
+        </p:nvSpPr>
+        <p:spPr>
+          <a:xfrm>
+            <a:off x="457200" y="320040"/>
+            <a:ext cx="2103120" cy="502920"/>
+          </a:xfrm>
+          <a:prstGeom prst="rect">
+            <a:avLst/>
+          </a:prstGeom>
+          <a:noFill/>
+          <a:ln/>
+        </p:spPr>
+        <p:txBody>
+          <a:bodyPr wrap="square" lIns="0" tIns="0" rIns="0" bIns="0" rtlCol="0" anchor="ctr"/>
+          <a:lstStyle/>
+          <a:p>
+            <a:pPr algn="ctr" indent="0" marL="0">
+              <a:buNone/>
+            </a:pPr>
+            <a:r>
+              <a:rPr lang="en-US" sz="1600" b="1" dirty="0">
+                <a:solidFill>
+                  <a:srgbClr val="FFFFFF"/>
+                </a:solidFill>
+                <a:latin typeface="Calibri" pitchFamily="34" charset="0"/>
+                <a:ea typeface="Calibri" pitchFamily="34" charset="-122"/>
+                <a:cs typeface="Calibri" pitchFamily="34" charset="-120"/>
+              </a:rPr>
+              <a:t>Future Work</a:t>
+            </a:r>
+            <a:endParaRPr lang="en-US" sz="1600" dirty="0"/>
+          </a:p>
+        </p:txBody>
+      </p:sp>
+      <p:sp>
+        <p:nvSpPr>
+          <p:cNvPr id="4" name="Text 2"/>
+          <p:cNvSpPr/>
+          <p:nvPr/>
+        </p:nvSpPr>
+        <p:spPr>
+          <a:xfrm>
+            <a:off x="2743200" y="274320"/>
+            <a:ext cx="9418320" cy="594360"/>
+          </a:xfrm>
+          <a:prstGeom prst="rect">
+            <a:avLst/>
+          </a:prstGeom>
+          <a:noFill/>
+          <a:ln/>
+        </p:spPr>
+        <p:txBody>
+          <a:bodyPr wrap="square" lIns="0" tIns="0" rIns="0" bIns="0" rtlCol="0" anchor="ctr"/>
+          <a:lstStyle/>
+          <a:p>
+            <a:pPr indent="0" marL="0">
+              <a:buNone/>
+            </a:pPr>
+            <a:r>
+              <a:rPr lang="en-US" sz="2800" b="1" dirty="0">
+                <a:solidFill>
+                  <a:srgbClr val="2E2055"/>
+                </a:solidFill>
+                <a:latin typeface="Cambria" pitchFamily="34" charset="0"/>
+                <a:ea typeface="Cambria" pitchFamily="34" charset="-122"/>
+                <a:cs typeface="Cambria" pitchFamily="34" charset="-120"/>
+              </a:rPr>
+              <a:t>Future Work</a:t>
+            </a:r>
+            <a:endParaRPr lang="en-US" sz="2800" dirty="0"/>
+          </a:p>
+        </p:txBody>
+      </p:sp>
+      <p:sp>
+        <p:nvSpPr>
+          <p:cNvPr id="5" name="Shape 3"/>
+          <p:cNvSpPr/>
+          <p:nvPr/>
+        </p:nvSpPr>
+        <p:spPr>
+          <a:xfrm>
+            <a:off x="457200" y="960120"/>
+            <a:ext cx="11274552" cy="36576"/>
+          </a:xfrm>
+          <a:prstGeom prst="rect">
+            <a:avLst/>
+          </a:prstGeom>
+          <a:solidFill>
+            <a:srgbClr val="2E2055"/>
+          </a:solidFill>
+          <a:ln w="12700">
+            <a:solidFill>
+              <a:srgbClr val="2E2055"/>
+            </a:solidFill>
+            <a:prstDash val="solid"/>
+          </a:ln>
+        </p:spPr>
+      </p:sp>
+      <p:sp>
+        <p:nvSpPr>
+          <p:cNvPr id="6" name="Shape 4"/>
+          <p:cNvSpPr/>
+          <p:nvPr/>
+        </p:nvSpPr>
+        <p:spPr>
+          <a:xfrm>
+            <a:off x="640080" y="1280160"/>
+            <a:ext cx="10927080" cy="5029200"/>
+          </a:xfrm>
+          <a:prstGeom prst="roundRect">
+            <a:avLst>
+              <a:gd name="adj" fmla="val 1455"/>
+            </a:avLst>
+          </a:prstGeom>
+          <a:solidFill>
+            <a:srgbClr val="F5F1FB"/>
+          </a:solidFill>
+          <a:ln w="12700">
+            <a:solidFill>
+              <a:srgbClr val="F5F1FB"/>
+            </a:solidFill>
+            <a:prstDash val="solid"/>
+          </a:ln>
+        </p:spPr>
+      </p:sp>
+      <p:sp>
+        <p:nvSpPr>
+          <p:cNvPr id="7" name="Text 5"/>
+          <p:cNvSpPr/>
+          <p:nvPr/>
+        </p:nvSpPr>
+        <p:spPr>
+          <a:xfrm>
+            <a:off x="777240" y="1371600"/>
+            <a:ext cx="10652760" cy="4846320"/>
+          </a:xfrm>
+          <a:prstGeom prst="rect">
+            <a:avLst/>
+          </a:prstGeom>
+          <a:noFill/>
+          <a:ln/>
+        </p:spPr>
+        <p:txBody>
+          <a:bodyPr wrap="square" lIns="1016" tIns="1016" rIns="1016" bIns="1016" rtlCol="0" anchor="t"/>
+          <a:lstStyle/>
+          <a:p>
+            <a:pPr marL="342900" indent="-342900">
+              <a:spcAft>
+                <a:spcPts val="1000"/>
+              </a:spcAft>
+              <a:buSzPct val="100000"/>
+              <a:buChar char="■"/>
+            </a:pPr>
+            <a:r>
+              <a:rPr lang="en-US" sz="2100" dirty="0">
+                <a:solidFill>
+                  <a:srgbClr val="1F1A33"/>
+                </a:solidFill>
+                <a:latin typeface="Calibri" pitchFamily="34" charset="0"/>
+                <a:ea typeface="Calibri" pitchFamily="34" charset="-122"/>
+                <a:cs typeface="Calibri" pitchFamily="34" charset="-120"/>
+              </a:rPr>
+              <a:t>Parallelize the delta coding, Huffman coding and reconstruction stages.</a:t>
+            </a:r>
+            <a:endParaRPr lang="en-US" sz="2100" dirty="0"/>
+          </a:p>
+          <a:p>
+            <a:pPr marL="342900" indent="-342900">
+              <a:spcAft>
+                <a:spcPts val="1000"/>
+              </a:spcAft>
+              <a:buSzPct val="100000"/>
+              <a:buChar char="■"/>
+            </a:pPr>
+            <a:r>
+              <a:rPr lang="en-US" sz="2100" dirty="0">
+                <a:solidFill>
+                  <a:srgbClr val="1F1A33"/>
+                </a:solidFill>
+                <a:latin typeface="Calibri" pitchFamily="34" charset="0"/>
+                <a:ea typeface="Calibri" pitchFamily="34" charset="-122"/>
+                <a:cs typeface="Calibri" pitchFamily="34" charset="-120"/>
+              </a:rPr>
+              <a:t>Evaluate other block sizes, codebook sizes and larger images.</a:t>
+            </a:r>
+            <a:endParaRPr lang="en-US" sz="2100" dirty="0"/>
+          </a:p>
+          <a:p>
+            <a:pPr marL="342900" indent="-342900">
+              <a:spcAft>
+                <a:spcPts val="1000"/>
+              </a:spcAft>
+              <a:buSzPct val="100000"/>
+              <a:buChar char="■"/>
+            </a:pPr>
+            <a:r>
+              <a:rPr lang="en-US" sz="2100" dirty="0">
+                <a:solidFill>
+                  <a:srgbClr val="1F1A33"/>
+                </a:solidFill>
+                <a:latin typeface="Calibri" pitchFamily="34" charset="0"/>
+                <a:ea typeface="Calibri" pitchFamily="34" charset="-122"/>
+                <a:cs typeface="Calibri" pitchFamily="34" charset="-120"/>
+              </a:rPr>
+              <a:t>Define an efficiency measure that accounts for the different speeds of P-cores and E-cores.</a:t>
+            </a:r>
+            <a:endParaRPr lang="en-US" sz="2100" dirty="0"/>
+          </a:p>
+          <a:p>
+            <a:pPr marL="342900" indent="-342900">
+              <a:spcAft>
+                <a:spcPts val="1000"/>
+              </a:spcAft>
+              <a:buSzPct val="100000"/>
+              <a:buChar char="■"/>
+            </a:pPr>
+            <a:r>
+              <a:rPr lang="en-US" sz="2100" dirty="0">
+                <a:solidFill>
+                  <a:srgbClr val="1F1A33"/>
+                </a:solidFill>
+                <a:latin typeface="Calibri" pitchFamily="34" charset="0"/>
+                <a:ea typeface="Calibri" pitchFamily="34" charset="-122"/>
+                <a:cs typeface="Calibri" pitchFamily="34" charset="-120"/>
+              </a:rPr>
+              <a:t>Implement a complete container file format (stored Huffman table and header) with a stand-alone decoder; the current program only accounts the compressed size.</a:t>
+            </a:r>
+            <a:endParaRPr lang="en-US" sz="2100" dirty="0"/>
+          </a:p>
+          <a:p>
+            <a:pPr marL="342900" indent="-342900">
+              <a:spcAft>
+                <a:spcPts val="1000"/>
+              </a:spcAft>
+              <a:buSzPct val="100000"/>
+              <a:buChar char="■"/>
+            </a:pPr>
+            <a:r>
+              <a:rPr lang="en-US" sz="2100" dirty="0">
+                <a:solidFill>
+                  <a:srgbClr val="1F1A33"/>
+                </a:solidFill>
+                <a:latin typeface="Calibri" pitchFamily="34" charset="0"/>
+                <a:ea typeface="Calibri" pitchFamily="34" charset="-122"/>
+                <a:cs typeface="Calibri" pitchFamily="34" charset="-120"/>
+              </a:rPr>
+              <a:t>Extend the study to other hybrid CPUs and to hybrid MPI + OpenMP implementations.</a:t>
+            </a:r>
+            <a:endParaRPr lang="en-US" sz="2100" dirty="0"/>
+          </a:p>
+        </p:txBody>
+      </p:sp>
+    </p:spTree>
+  </p:cSld>
+  <p:clrMapOvr>
+    <a:masterClrMapping/>
+  </p:clrMapOvr>
+</p:sld>
+</file>
+
+<file path=ppt/slides/slide31.xml><?xml version="1.0" encoding="utf-8"?>
+<p:sld xmlns:a="http://schemas.openxmlformats.org/drawingml/2006/main" xmlns:r="http://schemas.openxmlformats.org/officeDocument/2006/relationships" xmlns:p="http://schemas.openxmlformats.org/presentationml/2006/main">
+  <p:cSld name="Slide 31">
     <p:bg>
       <p:bgPr>
         <a:solidFill>

</xml_diff>

<commit_message>
Add separate gray/color total speedup slide
Co-Authored-By: Claude Sonnet 5.5 <noreply@anthropic.com>
Claude-Session: https://claude.ai/code/session_01T6gEewJ8YaCdmnsfS34RJd
</commit_message>
<xml_diff>
--- a/results/seminar/figs/Seminar_Ibtihal_v3.pptx
+++ b/results/seminar/figs/Seminar_Ibtihal_v3.pptx
@@ -36,9 +36,10 @@
     <p:sldId id="284" r:id="rId30"/>
     <p:sldId id="285" r:id="rId31"/>
     <p:sldId id="286" r:id="rId32"/>
+    <p:sldId id="287" r:id="rId33"/>
   </p:sldIdLst>
   <p:notesMasterIdLst>
-    <p:notesMasterId r:id="rId33"/>
+    <p:notesMasterId r:id="rId34"/>
   </p:notesMasterIdLst>
   <p:sldSz cx="12192000" cy="6858000"/>
   <p:notesSz cx="6858000" cy="12192000"/>
@@ -2668,6 +2669,94 @@
             <a:fld id="{F7021451-1387-4CA6-816F-3879F97B5CBC}" type="slidenum">
               <a:rPr lang="en-US"/>
               <a:t>31</a:t>
+            </a:fld>
+            <a:endParaRPr lang="en-US"/>
+          </a:p>
+        </p:txBody>
+      </p:sp>
+    </p:spTree>
+    <p:extLst>
+      <p:ext uri="{BB962C8B-B14F-4D97-AF65-F5344CB8AC3E}">
+        <p14:creationId xmlns:p14="http://schemas.microsoft.com/office/powerpoint/2010/main" val="1024086991"/>
+      </p:ext>
+    </p:extLst>
+  </p:cSld>
+  <p:clrMapOvr>
+    <a:masterClrMapping/>
+  </p:clrMapOvr>
+</p:notes>
+</file>
+
+<file path=ppt/notesSlides/notesSlide32.xml><?xml version="1.0" encoding="utf-8"?>
+<p:notes xmlns:a="http://schemas.openxmlformats.org/drawingml/2006/main" xmlns:r="http://schemas.openxmlformats.org/officeDocument/2006/relationships" xmlns:p="http://schemas.openxmlformats.org/presentationml/2006/main">
+  <p:cSld>
+    <p:spTree>
+      <p:nvGrpSpPr>
+        <p:cNvPr id="1" name=""/>
+        <p:cNvGrpSpPr/>
+        <p:nvPr/>
+      </p:nvGrpSpPr>
+      <p:grpSpPr>
+        <a:xfrm>
+          <a:off x="0" y="0"/>
+          <a:ext cx="0" cy="0"/>
+          <a:chOff x="0" y="0"/>
+          <a:chExt cx="0" cy="0"/>
+        </a:xfrm>
+      </p:grpSpPr>
+      <p:sp>
+        <p:nvSpPr>
+          <p:cNvPr id="2" name="Slide Image Placeholder 1"/>
+          <p:cNvSpPr>
+            <a:spLocks noGrp="1" noRot="1" noChangeAspect="1"/>
+          </p:cNvSpPr>
+          <p:nvPr>
+            <p:ph type="sldImg"/>
+          </p:nvPr>
+        </p:nvSpPr>
+        <p:spPr/>
+      </p:sp>
+      <p:sp>
+        <p:nvSpPr>
+          <p:cNvPr id="3" name="Notes Placeholder 2"/>
+          <p:cNvSpPr>
+            <a:spLocks noGrp="1"/>
+          </p:cNvSpPr>
+          <p:nvPr>
+            <p:ph type="body" idx="1"/>
+          </p:nvPr>
+        </p:nvSpPr>
+        <p:spPr/>
+        <p:txBody>
+          <a:bodyPr/>
+          <a:lstStyle/>
+          <a:p>
+            <a:r>
+              <a:rPr lang="en-US" dirty="0"/>
+              <a:t/>
+            </a:r>
+            <a:endParaRPr lang="en-US" dirty="0"/>
+          </a:p>
+        </p:txBody>
+      </p:sp>
+      <p:sp>
+        <p:nvSpPr>
+          <p:cNvPr id="4" name="Slide Number Placeholder 3"/>
+          <p:cNvSpPr>
+            <a:spLocks noGrp="1"/>
+          </p:cNvSpPr>
+          <p:nvPr>
+            <p:ph type="sldNum" sz="quarter" idx="10"/>
+          </p:nvPr>
+        </p:nvSpPr>
+        <p:spPr/>
+        <p:txBody>
+          <a:bodyPr/>
+          <a:lstStyle/>
+          <a:p>
+            <a:fld id="{F7021451-1387-4CA6-816F-3879F97B5CBC}" type="slidenum">
+              <a:rPr lang="en-US"/>
+              <a:t>32</a:t>
             </a:fld>
             <a:endParaRPr lang="en-US"/>
           </a:p>
@@ -22612,7 +22701,7 @@
                 <a:ea typeface="Calibri" pitchFamily="34" charset="-122"/>
                 <a:cs typeface="Calibri" pitchFamily="34" charset="-120"/>
               </a:rPr>
-              <a:t>Total time: 5.00× (gray) and 6.84× (color), because coding and reconstruction remain sequential.</a:t>
+              <a:t>This is the LBG stage (mean of the 8 images). The total speedup is shown separately for gray and color on the next slide.</a:t>
             </a:r>
             <a:endParaRPr lang="en-US" sz="1600" dirty="0"/>
           </a:p>
@@ -22749,7 +22838,7 @@
                 <a:ea typeface="Cambria" pitchFamily="34" charset="-122"/>
                 <a:cs typeface="Cambria" pitchFamily="34" charset="-120"/>
               </a:rPr>
-              <a:t>Equal vs Adaptive Workload Distribution</a:t>
+              <a:t>Total Speedup: Grayscale and Color</a:t>
             </a:r>
             <a:endParaRPr lang="en-US" sz="2800" dirty="0"/>
           </a:p>
@@ -22809,7 +22898,7 @@
       </p:sp>
       <p:pic>
         <p:nvPicPr>
-          <p:cNvPr id="7" name="Image 0" descr="assets/eqad_chart.png">    </p:cNvPr>
+          <p:cNvPr id="7" name="Image 0" descr="assets/total_speedup_chart.png">    </p:cNvPr>
           <p:cNvPicPr>
             <a:picLocks noChangeAspect="1"/>
           </p:cNvPicPr>
@@ -22881,7 +22970,7 @@
           <a:p>
             <a:pPr marL="342900" indent="-342900">
               <a:spcAft>
-                <a:spcPts val="800"/>
+                <a:spcPts val="1000"/>
               </a:spcAft>
               <a:buSzPct val="100000"/>
               <a:buChar char="■"/>
@@ -22895,14 +22984,14 @@
                 <a:ea typeface="Calibri" pitchFamily="34" charset="-122"/>
                 <a:cs typeface="Calibri" pitchFamily="34" charset="-120"/>
               </a:rPr>
-              <a:t>With Equal distribution, the faster P-cores finish early and wait for the E-cores: 7.61× at P = 14.</a:t>
+              <a:t>Total speedup at P = 14: 5.00× (grayscale) and 6.84× (color); efficiency 35.7% and 48.9%.</a:t>
             </a:r>
             <a:endParaRPr lang="en-US" sz="1500" dirty="0"/>
           </a:p>
           <a:p>
             <a:pPr marL="342900" indent="-342900">
               <a:spcAft>
-                <a:spcPts val="800"/>
+                <a:spcPts val="1000"/>
               </a:spcAft>
               <a:buSzPct val="100000"/>
               <a:buChar char="■"/>
@@ -22916,14 +23005,14 @@
                 <a:ea typeface="Calibri" pitchFamily="34" charset="-122"/>
                 <a:cs typeface="Calibri" pitchFamily="34" charset="-120"/>
               </a:rPr>
-              <a:t>Adaptive distribution reaches 9.19× at P = 14.</a:t>
+              <a:t>It is lower than the LBG speedup (9.19×) because delta coding, Huffman coding and reconstruction remain sequential.</a:t>
             </a:r>
             <a:endParaRPr lang="en-US" sz="1500" dirty="0"/>
           </a:p>
           <a:p>
             <a:pPr marL="342900" indent="-342900">
               <a:spcAft>
-                <a:spcPts val="800"/>
+                <a:spcPts val="1000"/>
               </a:spcAft>
               <a:buSzPct val="100000"/>
               <a:buChar char="■"/>
@@ -22937,14 +23026,14 @@
                 <a:ea typeface="Calibri" pitchFamily="34" charset="-122"/>
                 <a:cs typeface="Calibri" pitchFamily="34" charset="-120"/>
               </a:rPr>
-              <a:t>LBG time is reduced by 28.3%, 23.6%, 19.8% and 17.2% at P = 8, 10, 12 and 14.</a:t>
+              <a:t>Color images gain more: LBG is 81% of their sequential time, against 77% for grayscale.</a:t>
             </a:r>
             <a:endParaRPr lang="en-US" sz="1500" dirty="0"/>
           </a:p>
           <a:p>
             <a:pPr marL="342900" indent="-342900">
               <a:spcAft>
-                <a:spcPts val="800"/>
+                <a:spcPts val="1000"/>
               </a:spcAft>
               <a:buSzPct val="100000"/>
               <a:buChar char="■"/>
@@ -22958,49 +23047,7 @@
                 <a:ea typeface="Calibri" pitchFamily="34" charset="-122"/>
                 <a:cs typeface="Calibri" pitchFamily="34" charset="-120"/>
               </a:rPr>
-              <a:t>Total time is reduced by 17.9% to 8.8%.</a:t>
-            </a:r>
-            <a:endParaRPr lang="en-US" sz="1500" dirty="0"/>
-          </a:p>
-          <a:p>
-            <a:pPr marL="342900" indent="-342900">
-              <a:spcAft>
-                <a:spcPts val="800"/>
-              </a:spcAft>
-              <a:buSzPct val="100000"/>
-              <a:buChar char="■"/>
-            </a:pPr>
-            <a:r>
-              <a:rPr lang="en-US" sz="1500" dirty="0">
-                <a:solidFill>
-                  <a:srgbClr val="1F1A33"/>
-                </a:solidFill>
-                <a:latin typeface="Calibri" pitchFamily="34" charset="0"/>
-                <a:ea typeface="Calibri" pitchFamily="34" charset="-122"/>
-                <a:cs typeface="Calibri" pitchFamily="34" charset="-120"/>
-              </a:rPr>
-              <a:t>No adaptive-distribution benefit was observed when only P-cores were used (P ≤ 6).</a:t>
-            </a:r>
-            <a:endParaRPr lang="en-US" sz="1500" dirty="0"/>
-          </a:p>
-          <a:p>
-            <a:pPr marL="342900" indent="-342900">
-              <a:spcAft>
-                <a:spcPts val="800"/>
-              </a:spcAft>
-              <a:buSzPct val="100000"/>
-              <a:buChar char="■"/>
-            </a:pPr>
-            <a:r>
-              <a:rPr lang="en-US" sz="1500" dirty="0">
-                <a:solidFill>
-                  <a:srgbClr val="1F1A33"/>
-                </a:solidFill>
-                <a:latin typeface="Calibri" pitchFamily="34" charset="0"/>
-                <a:ea typeface="Calibri" pitchFamily="34" charset="-122"/>
-                <a:cs typeface="Calibri" pitchFamily="34" charset="-120"/>
-              </a:rPr>
-              <a:t>The reconstructed images are identical in both cases.</a:t>
+              <a:t>Total time includes all compression stages; the shaded bands show the minimum to maximum over the images of each type.</a:t>
             </a:r>
             <a:endParaRPr lang="en-US" sz="1500" dirty="0"/>
           </a:p>
@@ -23137,7 +23184,7 @@
                 <a:ea typeface="Cambria" pitchFamily="34" charset="-122"/>
                 <a:cs typeface="Cambria" pitchFamily="34" charset="-120"/>
               </a:rPr>
-              <a:t>Throughput</a:t>
+              <a:t>Equal vs Adaptive Workload Distribution</a:t>
             </a:r>
             <a:endParaRPr lang="en-US" sz="2800" dirty="0"/>
           </a:p>
@@ -23197,7 +23244,7 @@
       </p:sp>
       <p:pic>
         <p:nvPicPr>
-          <p:cNvPr id="7" name="Image 0" descr="assets/throughput_ch4.png">    </p:cNvPr>
+          <p:cNvPr id="7" name="Image 0" descr="assets/eqad_chart.png">    </p:cNvPr>
           <p:cNvPicPr>
             <a:picLocks noChangeAspect="1"/>
           </p:cNvPicPr>
@@ -23211,8 +23258,8 @@
         </p:blipFill>
         <p:spPr>
           <a:xfrm>
-            <a:off x="457200" y="1269906"/>
-            <a:ext cx="7498080" cy="4958268"/>
+            <a:off x="457200" y="1467016"/>
+            <a:ext cx="7498080" cy="4564049"/>
           </a:xfrm>
           <a:prstGeom prst="rect">
             <a:avLst/>
@@ -23269,7 +23316,7 @@
           <a:p>
             <a:pPr marL="342900" indent="-342900">
               <a:spcAft>
-                <a:spcPts val="900"/>
+                <a:spcPts val="800"/>
               </a:spcAft>
               <a:buSzPct val="100000"/>
               <a:buChar char="■"/>
@@ -23283,14 +23330,14 @@
                 <a:ea typeface="Calibri" pitchFamily="34" charset="-122"/>
                 <a:cs typeface="Calibri" pitchFamily="34" charset="-120"/>
               </a:rPr>
-              <a:t>Throughput = original image size / total execution time (MiB/s).</a:t>
+              <a:t>With Equal distribution, the faster P-cores finish early and wait for the E-cores: 7.61× at P = 14.</a:t>
             </a:r>
             <a:endParaRPr lang="en-US" sz="1500" dirty="0"/>
           </a:p>
           <a:p>
             <a:pPr marL="342900" indent="-342900">
               <a:spcAft>
-                <a:spcPts val="900"/>
+                <a:spcPts val="800"/>
               </a:spcAft>
               <a:buSzPct val="100000"/>
               <a:buChar char="■"/>
@@ -23304,14 +23351,14 @@
                 <a:ea typeface="Calibri" pitchFamily="34" charset="-122"/>
                 <a:cs typeface="Calibri" pitchFamily="34" charset="-120"/>
               </a:rPr>
-              <a:t>Grayscale: 1.30 → 3.35 MiB/s from P = 2 to P = 14.</a:t>
+              <a:t>Adaptive distribution reaches 9.19× at P = 14.</a:t>
             </a:r>
             <a:endParaRPr lang="en-US" sz="1500" dirty="0"/>
           </a:p>
           <a:p>
             <a:pPr marL="342900" indent="-342900">
               <a:spcAft>
-                <a:spcPts val="900"/>
+                <a:spcPts val="800"/>
               </a:spcAft>
               <a:buSzPct val="100000"/>
               <a:buChar char="■"/>
@@ -23325,14 +23372,14 @@
                 <a:ea typeface="Calibri" pitchFamily="34" charset="-122"/>
                 <a:cs typeface="Calibri" pitchFamily="34" charset="-120"/>
               </a:rPr>
-              <a:t>Color: 1.42 → 4.54 MiB/s.</a:t>
+              <a:t>LBG time is reduced by 28.3%, 23.6%, 19.8% and 17.2% at P = 8, 10, 12 and 14.</a:t>
             </a:r>
             <a:endParaRPr lang="en-US" sz="1500" dirty="0"/>
           </a:p>
           <a:p>
             <a:pPr marL="342900" indent="-342900">
               <a:spcAft>
-                <a:spcPts val="900"/>
+                <a:spcPts val="800"/>
               </a:spcAft>
               <a:buSzPct val="100000"/>
               <a:buChar char="■"/>
@@ -23346,14 +23393,14 @@
                 <a:ea typeface="Calibri" pitchFamily="34" charset="-122"/>
                 <a:cs typeface="Calibri" pitchFamily="34" charset="-120"/>
               </a:rPr>
-              <a:t>Color images hold three times more data, but their total time grows by only about 2.2× at P = 14, so their throughput is higher.</a:t>
+              <a:t>Total time is reduced by 17.9% to 8.8%.</a:t>
             </a:r>
             <a:endParaRPr lang="en-US" sz="1500" dirty="0"/>
           </a:p>
           <a:p>
             <a:pPr marL="342900" indent="-342900">
               <a:spcAft>
-                <a:spcPts val="900"/>
+                <a:spcPts val="800"/>
               </a:spcAft>
               <a:buSzPct val="100000"/>
               <a:buChar char="■"/>
@@ -23367,7 +23414,28 @@
                 <a:ea typeface="Calibri" pitchFamily="34" charset="-122"/>
                 <a:cs typeface="Calibri" pitchFamily="34" charset="-120"/>
               </a:rPr>
-              <a:t>Shaded bands: minimum to maximum over the images.</a:t>
+              <a:t>No adaptive-distribution benefit was observed when only P-cores were used (P ≤ 6).</a:t>
+            </a:r>
+            <a:endParaRPr lang="en-US" sz="1500" dirty="0"/>
+          </a:p>
+          <a:p>
+            <a:pPr marL="342900" indent="-342900">
+              <a:spcAft>
+                <a:spcPts val="800"/>
+              </a:spcAft>
+              <a:buSzPct val="100000"/>
+              <a:buChar char="■"/>
+            </a:pPr>
+            <a:r>
+              <a:rPr lang="en-US" sz="1500" dirty="0">
+                <a:solidFill>
+                  <a:srgbClr val="1F1A33"/>
+                </a:solidFill>
+                <a:latin typeface="Calibri" pitchFamily="34" charset="0"/>
+                <a:ea typeface="Calibri" pitchFamily="34" charset="-122"/>
+                <a:cs typeface="Calibri" pitchFamily="34" charset="-120"/>
+              </a:rPr>
+              <a:t>The reconstructed images are identical in both cases.</a:t>
             </a:r>
             <a:endParaRPr lang="en-US" sz="1500" dirty="0"/>
           </a:p>
@@ -23504,7 +23572,7 @@
                 <a:ea typeface="Cambria" pitchFamily="34" charset="-122"/>
                 <a:cs typeface="Cambria" pitchFamily="34" charset="-120"/>
               </a:rPr>
-              <a:t>Karp–Flatt Metric</a:t>
+              <a:t>Throughput</a:t>
             </a:r>
             <a:endParaRPr lang="en-US" sz="2800" dirty="0"/>
           </a:p>
@@ -23535,9 +23603,376 @@
           </a:ln>
         </p:spPr>
       </p:sp>
+      <p:sp>
+        <p:nvSpPr>
+          <p:cNvPr id="6" name="Shape 4"/>
+          <p:cNvSpPr/>
+          <p:nvPr/>
+        </p:nvSpPr>
+        <p:spPr>
+          <a:xfrm>
+            <a:off x="457200" y="1234440"/>
+            <a:ext cx="7498080" cy="5029200"/>
+          </a:xfrm>
+          <a:prstGeom prst="roundRect">
+            <a:avLst>
+              <a:gd name="adj" fmla="val 1455"/>
+            </a:avLst>
+          </a:prstGeom>
+          <a:solidFill>
+            <a:srgbClr val="FFFFFF"/>
+          </a:solidFill>
+          <a:ln w="15875">
+            <a:solidFill>
+              <a:srgbClr val="2A9D8F"/>
+            </a:solidFill>
+            <a:prstDash val="solid"/>
+          </a:ln>
+        </p:spPr>
+      </p:sp>
+      <p:pic>
+        <p:nvPicPr>
+          <p:cNvPr id="7" name="Image 0" descr="assets/throughput_ch4.png">    </p:cNvPr>
+          <p:cNvPicPr>
+            <a:picLocks noChangeAspect="1"/>
+          </p:cNvPicPr>
+          <p:nvPr/>
+        </p:nvPicPr>
+        <p:blipFill>
+          <a:blip r:embed="rId1"/>
+          <a:stretch>
+            <a:fillRect/>
+          </a:stretch>
+        </p:blipFill>
+        <p:spPr>
+          <a:xfrm>
+            <a:off x="457200" y="1269906"/>
+            <a:ext cx="7498080" cy="4958268"/>
+          </a:xfrm>
+          <a:prstGeom prst="rect">
+            <a:avLst/>
+          </a:prstGeom>
+        </p:spPr>
+      </p:pic>
+      <p:sp>
+        <p:nvSpPr>
+          <p:cNvPr id="8" name="Shape 5"/>
+          <p:cNvSpPr/>
+          <p:nvPr/>
+        </p:nvSpPr>
+        <p:spPr>
+          <a:xfrm>
+            <a:off x="8183880" y="1234440"/>
+            <a:ext cx="3566160" cy="5029200"/>
+          </a:xfrm>
+          <a:prstGeom prst="roundRect">
+            <a:avLst>
+              <a:gd name="adj" fmla="val 2051"/>
+            </a:avLst>
+          </a:prstGeom>
+          <a:solidFill>
+            <a:srgbClr val="F5F1FB"/>
+          </a:solidFill>
+          <a:ln w="12700">
+            <a:solidFill>
+              <a:srgbClr val="F5F1FB"/>
+            </a:solidFill>
+            <a:prstDash val="solid"/>
+          </a:ln>
+        </p:spPr>
+      </p:sp>
+      <p:sp>
+        <p:nvSpPr>
+          <p:cNvPr id="9" name="Text 6"/>
+          <p:cNvSpPr/>
+          <p:nvPr/>
+        </p:nvSpPr>
+        <p:spPr>
+          <a:xfrm>
+            <a:off x="8275320" y="1325880"/>
+            <a:ext cx="3383280" cy="4846320"/>
+          </a:xfrm>
+          <a:prstGeom prst="rect">
+            <a:avLst/>
+          </a:prstGeom>
+          <a:noFill/>
+          <a:ln/>
+        </p:spPr>
+        <p:txBody>
+          <a:bodyPr wrap="square" lIns="1016" tIns="1016" rIns="1016" bIns="1016" rtlCol="0" anchor="t"/>
+          <a:lstStyle/>
+          <a:p>
+            <a:pPr marL="342900" indent="-342900">
+              <a:spcAft>
+                <a:spcPts val="900"/>
+              </a:spcAft>
+              <a:buSzPct val="100000"/>
+              <a:buChar char="■"/>
+            </a:pPr>
+            <a:r>
+              <a:rPr lang="en-US" sz="1500" dirty="0">
+                <a:solidFill>
+                  <a:srgbClr val="1F1A33"/>
+                </a:solidFill>
+                <a:latin typeface="Calibri" pitchFamily="34" charset="0"/>
+                <a:ea typeface="Calibri" pitchFamily="34" charset="-122"/>
+                <a:cs typeface="Calibri" pitchFamily="34" charset="-120"/>
+              </a:rPr>
+              <a:t>Throughput = original image size / total execution time (MiB/s).</a:t>
+            </a:r>
+            <a:endParaRPr lang="en-US" sz="1500" dirty="0"/>
+          </a:p>
+          <a:p>
+            <a:pPr marL="342900" indent="-342900">
+              <a:spcAft>
+                <a:spcPts val="900"/>
+              </a:spcAft>
+              <a:buSzPct val="100000"/>
+              <a:buChar char="■"/>
+            </a:pPr>
+            <a:r>
+              <a:rPr lang="en-US" sz="1500" dirty="0">
+                <a:solidFill>
+                  <a:srgbClr val="1F1A33"/>
+                </a:solidFill>
+                <a:latin typeface="Calibri" pitchFamily="34" charset="0"/>
+                <a:ea typeface="Calibri" pitchFamily="34" charset="-122"/>
+                <a:cs typeface="Calibri" pitchFamily="34" charset="-120"/>
+              </a:rPr>
+              <a:t>Grayscale: 1.30 → 3.35 MiB/s from P = 2 to P = 14.</a:t>
+            </a:r>
+            <a:endParaRPr lang="en-US" sz="1500" dirty="0"/>
+          </a:p>
+          <a:p>
+            <a:pPr marL="342900" indent="-342900">
+              <a:spcAft>
+                <a:spcPts val="900"/>
+              </a:spcAft>
+              <a:buSzPct val="100000"/>
+              <a:buChar char="■"/>
+            </a:pPr>
+            <a:r>
+              <a:rPr lang="en-US" sz="1500" dirty="0">
+                <a:solidFill>
+                  <a:srgbClr val="1F1A33"/>
+                </a:solidFill>
+                <a:latin typeface="Calibri" pitchFamily="34" charset="0"/>
+                <a:ea typeface="Calibri" pitchFamily="34" charset="-122"/>
+                <a:cs typeface="Calibri" pitchFamily="34" charset="-120"/>
+              </a:rPr>
+              <a:t>Color: 1.42 → 4.54 MiB/s.</a:t>
+            </a:r>
+            <a:endParaRPr lang="en-US" sz="1500" dirty="0"/>
+          </a:p>
+          <a:p>
+            <a:pPr marL="342900" indent="-342900">
+              <a:spcAft>
+                <a:spcPts val="900"/>
+              </a:spcAft>
+              <a:buSzPct val="100000"/>
+              <a:buChar char="■"/>
+            </a:pPr>
+            <a:r>
+              <a:rPr lang="en-US" sz="1500" dirty="0">
+                <a:solidFill>
+                  <a:srgbClr val="1F1A33"/>
+                </a:solidFill>
+                <a:latin typeface="Calibri" pitchFamily="34" charset="0"/>
+                <a:ea typeface="Calibri" pitchFamily="34" charset="-122"/>
+                <a:cs typeface="Calibri" pitchFamily="34" charset="-120"/>
+              </a:rPr>
+              <a:t>Color images hold three times more data, but their total time grows by only about 2.2× at P = 14, so their throughput is higher.</a:t>
+            </a:r>
+            <a:endParaRPr lang="en-US" sz="1500" dirty="0"/>
+          </a:p>
+          <a:p>
+            <a:pPr marL="342900" indent="-342900">
+              <a:spcAft>
+                <a:spcPts val="900"/>
+              </a:spcAft>
+              <a:buSzPct val="100000"/>
+              <a:buChar char="■"/>
+            </a:pPr>
+            <a:r>
+              <a:rPr lang="en-US" sz="1500" dirty="0">
+                <a:solidFill>
+                  <a:srgbClr val="1F1A33"/>
+                </a:solidFill>
+                <a:latin typeface="Calibri" pitchFamily="34" charset="0"/>
+                <a:ea typeface="Calibri" pitchFamily="34" charset="-122"/>
+                <a:cs typeface="Calibri" pitchFamily="34" charset="-120"/>
+              </a:rPr>
+              <a:t>Shaded bands: minimum to maximum over the images.</a:t>
+            </a:r>
+            <a:endParaRPr lang="en-US" sz="1500" dirty="0"/>
+          </a:p>
+        </p:txBody>
+      </p:sp>
+    </p:spTree>
+  </p:cSld>
+  <p:clrMapOvr>
+    <a:masterClrMapping/>
+  </p:clrMapOvr>
+</p:sld>
+</file>
+
+<file path=ppt/slides/slide29.xml><?xml version="1.0" encoding="utf-8"?>
+<p:sld xmlns:a="http://schemas.openxmlformats.org/drawingml/2006/main" xmlns:r="http://schemas.openxmlformats.org/officeDocument/2006/relationships" xmlns:p="http://schemas.openxmlformats.org/presentationml/2006/main">
+  <p:cSld name="Slide 29">
+    <p:bg>
+      <p:bgPr>
+        <a:solidFill>
+          <a:srgbClr val="FFFFFF"/>
+        </a:solidFill>
+      </p:bgPr>
+    </p:bg>
+    <p:spTree>
+      <p:nvGrpSpPr>
+        <p:cNvPr id="1" name=""/>
+        <p:cNvGrpSpPr/>
+        <p:nvPr/>
+      </p:nvGrpSpPr>
+      <p:grpSpPr>
+        <a:xfrm>
+          <a:off x="0" y="0"/>
+          <a:ext cx="0" cy="0"/>
+          <a:chOff x="0" y="0"/>
+          <a:chExt cx="0" cy="0"/>
+        </a:xfrm>
+      </p:grpSpPr>
+      <p:sp>
+        <p:nvSpPr>
+          <p:cNvPr id="2" name="Shape 0"/>
+          <p:cNvSpPr/>
+          <p:nvPr/>
+        </p:nvSpPr>
+        <p:spPr>
+          <a:xfrm>
+            <a:off x="457200" y="320040"/>
+            <a:ext cx="1737360" cy="502920"/>
+          </a:xfrm>
+          <a:prstGeom prst="roundRect">
+            <a:avLst>
+              <a:gd name="adj" fmla="val 18182"/>
+            </a:avLst>
+          </a:prstGeom>
+          <a:solidFill>
+            <a:srgbClr val="2A9D8F"/>
+          </a:solidFill>
+          <a:ln w="12700">
+            <a:solidFill>
+              <a:srgbClr val="2A9D8F"/>
+            </a:solidFill>
+            <a:prstDash val="solid"/>
+          </a:ln>
+        </p:spPr>
+      </p:sp>
+      <p:sp>
+        <p:nvSpPr>
+          <p:cNvPr id="3" name="Text 1"/>
+          <p:cNvSpPr/>
+          <p:nvPr/>
+        </p:nvSpPr>
+        <p:spPr>
+          <a:xfrm>
+            <a:off x="457200" y="320040"/>
+            <a:ext cx="1737360" cy="502920"/>
+          </a:xfrm>
+          <a:prstGeom prst="rect">
+            <a:avLst/>
+          </a:prstGeom>
+          <a:noFill/>
+          <a:ln/>
+        </p:spPr>
+        <p:txBody>
+          <a:bodyPr wrap="square" lIns="0" tIns="0" rIns="0" bIns="0" rtlCol="0" anchor="ctr"/>
+          <a:lstStyle/>
+          <a:p>
+            <a:pPr algn="ctr" indent="0" marL="0">
+              <a:buNone/>
+            </a:pPr>
+            <a:r>
+              <a:rPr lang="en-US" sz="1800" b="1" dirty="0">
+                <a:solidFill>
+                  <a:srgbClr val="FFFFFF"/>
+                </a:solidFill>
+                <a:latin typeface="Calibri" pitchFamily="34" charset="0"/>
+                <a:ea typeface="Calibri" pitchFamily="34" charset="-122"/>
+                <a:cs typeface="Calibri" pitchFamily="34" charset="-120"/>
+              </a:rPr>
+              <a:t>Results</a:t>
+            </a:r>
+            <a:endParaRPr lang="en-US" sz="1800" dirty="0"/>
+          </a:p>
+        </p:txBody>
+      </p:sp>
+      <p:sp>
+        <p:nvSpPr>
+          <p:cNvPr id="4" name="Text 2"/>
+          <p:cNvSpPr/>
+          <p:nvPr/>
+        </p:nvSpPr>
+        <p:spPr>
+          <a:xfrm>
+            <a:off x="2377440" y="274320"/>
+            <a:ext cx="9326880" cy="594360"/>
+          </a:xfrm>
+          <a:prstGeom prst="rect">
+            <a:avLst/>
+          </a:prstGeom>
+          <a:noFill/>
+          <a:ln/>
+        </p:spPr>
+        <p:txBody>
+          <a:bodyPr wrap="square" lIns="0" tIns="0" rIns="0" bIns="0" rtlCol="0" anchor="ctr"/>
+          <a:lstStyle/>
+          <a:p>
+            <a:pPr indent="0" marL="0">
+              <a:buNone/>
+            </a:pPr>
+            <a:r>
+              <a:rPr lang="en-US" sz="2800" b="1" dirty="0">
+                <a:solidFill>
+                  <a:srgbClr val="2E2055"/>
+                </a:solidFill>
+                <a:latin typeface="Cambria" pitchFamily="34" charset="0"/>
+                <a:ea typeface="Cambria" pitchFamily="34" charset="-122"/>
+                <a:cs typeface="Cambria" pitchFamily="34" charset="-120"/>
+              </a:rPr>
+              <a:t>Karp–Flatt Metric</a:t>
+            </a:r>
+            <a:endParaRPr lang="en-US" sz="2800" dirty="0"/>
+          </a:p>
+        </p:txBody>
+      </p:sp>
+      <p:sp>
+        <p:nvSpPr>
+          <p:cNvPr id="5" name="Shape 3"/>
+          <p:cNvSpPr/>
+          <p:nvPr/>
+        </p:nvSpPr>
+        <p:spPr>
+          <a:xfrm>
+            <a:off x="457200" y="960120"/>
+            <a:ext cx="11274552" cy="36576"/>
+          </a:xfrm>
+          <a:prstGeom prst="rect">
+            <a:avLst/>
+          </a:prstGeom>
+          <a:solidFill>
+            <a:srgbClr val="2A9D8F"/>
+          </a:solidFill>
+          <a:ln w="12700">
+            <a:solidFill>
+              <a:srgbClr val="2A9D8F"/>
+            </a:solidFill>
+            <a:prstDash val="solid"/>
+          </a:ln>
+        </p:spPr>
+      </p:sp>
       <p:graphicFrame>
         <p:nvGraphicFramePr>
-          <p:cNvPr id="29" name="Table 0"/>
+          <p:cNvPr id="30" name="Table 0"/>
           <p:cNvGraphicFramePr>
             <a:graphicFrameLocks noGrp="1"/>
           </p:cNvGraphicFramePr>
@@ -26484,343 +26919,6 @@
 </p:sld>
 </file>
 
-<file path=ppt/slides/slide29.xml><?xml version="1.0" encoding="utf-8"?>
-<p:sld xmlns:a="http://schemas.openxmlformats.org/drawingml/2006/main" xmlns:r="http://schemas.openxmlformats.org/officeDocument/2006/relationships" xmlns:p="http://schemas.openxmlformats.org/presentationml/2006/main">
-  <p:cSld name="Slide 29">
-    <p:bg>
-      <p:bgPr>
-        <a:solidFill>
-          <a:srgbClr val="FFFFFF"/>
-        </a:solidFill>
-      </p:bgPr>
-    </p:bg>
-    <p:spTree>
-      <p:nvGrpSpPr>
-        <p:cNvPr id="1" name=""/>
-        <p:cNvGrpSpPr/>
-        <p:nvPr/>
-      </p:nvGrpSpPr>
-      <p:grpSpPr>
-        <a:xfrm>
-          <a:off x="0" y="0"/>
-          <a:ext cx="0" cy="0"/>
-          <a:chOff x="0" y="0"/>
-          <a:chExt cx="0" cy="0"/>
-        </a:xfrm>
-      </p:grpSpPr>
-      <p:sp>
-        <p:nvSpPr>
-          <p:cNvPr id="2" name="Shape 0"/>
-          <p:cNvSpPr/>
-          <p:nvPr/>
-        </p:nvSpPr>
-        <p:spPr>
-          <a:xfrm>
-            <a:off x="457200" y="320040"/>
-            <a:ext cx="2103120" cy="502920"/>
-          </a:xfrm>
-          <a:prstGeom prst="roundRect">
-            <a:avLst>
-              <a:gd name="adj" fmla="val 18182"/>
-            </a:avLst>
-          </a:prstGeom>
-          <a:solidFill>
-            <a:srgbClr val="2E2055"/>
-          </a:solidFill>
-          <a:ln w="12700">
-            <a:solidFill>
-              <a:srgbClr val="2E2055"/>
-            </a:solidFill>
-            <a:prstDash val="solid"/>
-          </a:ln>
-        </p:spPr>
-      </p:sp>
-      <p:sp>
-        <p:nvSpPr>
-          <p:cNvPr id="3" name="Text 1"/>
-          <p:cNvSpPr/>
-          <p:nvPr/>
-        </p:nvSpPr>
-        <p:spPr>
-          <a:xfrm>
-            <a:off x="457200" y="320040"/>
-            <a:ext cx="2103120" cy="502920"/>
-          </a:xfrm>
-          <a:prstGeom prst="rect">
-            <a:avLst/>
-          </a:prstGeom>
-          <a:noFill/>
-          <a:ln/>
-        </p:spPr>
-        <p:txBody>
-          <a:bodyPr wrap="square" lIns="0" tIns="0" rIns="0" bIns="0" rtlCol="0" anchor="ctr"/>
-          <a:lstStyle/>
-          <a:p>
-            <a:pPr algn="ctr" indent="0" marL="0">
-              <a:buNone/>
-            </a:pPr>
-            <a:r>
-              <a:rPr lang="en-US" sz="1600" b="1" dirty="0">
-                <a:solidFill>
-                  <a:srgbClr val="FFFFFF"/>
-                </a:solidFill>
-                <a:latin typeface="Calibri" pitchFamily="34" charset="0"/>
-                <a:ea typeface="Calibri" pitchFamily="34" charset="-122"/>
-                <a:cs typeface="Calibri" pitchFamily="34" charset="-120"/>
-              </a:rPr>
-              <a:t>Conclusion</a:t>
-            </a:r>
-            <a:endParaRPr lang="en-US" sz="1600" dirty="0"/>
-          </a:p>
-        </p:txBody>
-      </p:sp>
-      <p:sp>
-        <p:nvSpPr>
-          <p:cNvPr id="4" name="Text 2"/>
-          <p:cNvSpPr/>
-          <p:nvPr/>
-        </p:nvSpPr>
-        <p:spPr>
-          <a:xfrm>
-            <a:off x="2743200" y="274320"/>
-            <a:ext cx="9418320" cy="594360"/>
-          </a:xfrm>
-          <a:prstGeom prst="rect">
-            <a:avLst/>
-          </a:prstGeom>
-          <a:noFill/>
-          <a:ln/>
-        </p:spPr>
-        <p:txBody>
-          <a:bodyPr wrap="square" lIns="0" tIns="0" rIns="0" bIns="0" rtlCol="0" anchor="ctr"/>
-          <a:lstStyle/>
-          <a:p>
-            <a:pPr indent="0" marL="0">
-              <a:buNone/>
-            </a:pPr>
-            <a:r>
-              <a:rPr lang="en-US" sz="2800" b="1" dirty="0">
-                <a:solidFill>
-                  <a:srgbClr val="2E2055"/>
-                </a:solidFill>
-                <a:latin typeface="Cambria" pitchFamily="34" charset="0"/>
-                <a:ea typeface="Cambria" pitchFamily="34" charset="-122"/>
-                <a:cs typeface="Cambria" pitchFamily="34" charset="-120"/>
-              </a:rPr>
-              <a:t>Conclusion</a:t>
-            </a:r>
-            <a:endParaRPr lang="en-US" sz="2800" dirty="0"/>
-          </a:p>
-        </p:txBody>
-      </p:sp>
-      <p:sp>
-        <p:nvSpPr>
-          <p:cNvPr id="5" name="Shape 3"/>
-          <p:cNvSpPr/>
-          <p:nvPr/>
-        </p:nvSpPr>
-        <p:spPr>
-          <a:xfrm>
-            <a:off x="457200" y="960120"/>
-            <a:ext cx="11274552" cy="36576"/>
-          </a:xfrm>
-          <a:prstGeom prst="rect">
-            <a:avLst/>
-          </a:prstGeom>
-          <a:solidFill>
-            <a:srgbClr val="2E2055"/>
-          </a:solidFill>
-          <a:ln w="12700">
-            <a:solidFill>
-              <a:srgbClr val="2E2055"/>
-            </a:solidFill>
-            <a:prstDash val="solid"/>
-          </a:ln>
-        </p:spPr>
-      </p:sp>
-      <p:sp>
-        <p:nvSpPr>
-          <p:cNvPr id="6" name="Shape 4"/>
-          <p:cNvSpPr/>
-          <p:nvPr/>
-        </p:nvSpPr>
-        <p:spPr>
-          <a:xfrm>
-            <a:off x="640080" y="1280160"/>
-            <a:ext cx="10927080" cy="5029200"/>
-          </a:xfrm>
-          <a:prstGeom prst="roundRect">
-            <a:avLst>
-              <a:gd name="adj" fmla="val 1455"/>
-            </a:avLst>
-          </a:prstGeom>
-          <a:solidFill>
-            <a:srgbClr val="F5F1FB"/>
-          </a:solidFill>
-          <a:ln w="12700">
-            <a:solidFill>
-              <a:srgbClr val="F5F1FB"/>
-            </a:solidFill>
-            <a:prstDash val="solid"/>
-          </a:ln>
-        </p:spPr>
-      </p:sp>
-      <p:sp>
-        <p:nvSpPr>
-          <p:cNvPr id="7" name="Text 5"/>
-          <p:cNvSpPr/>
-          <p:nvPr/>
-        </p:nvSpPr>
-        <p:spPr>
-          <a:xfrm>
-            <a:off x="777240" y="1371600"/>
-            <a:ext cx="10652760" cy="4846320"/>
-          </a:xfrm>
-          <a:prstGeom prst="rect">
-            <a:avLst/>
-          </a:prstGeom>
-          <a:noFill/>
-          <a:ln/>
-        </p:spPr>
-        <p:txBody>
-          <a:bodyPr wrap="square" lIns="1016" tIns="1016" rIns="1016" bIns="1016" rtlCol="0" anchor="t"/>
-          <a:lstStyle/>
-          <a:p>
-            <a:pPr marL="342900" indent="-342900">
-              <a:spcAft>
-                <a:spcPts val="1000"/>
-              </a:spcAft>
-              <a:buSzPct val="100000"/>
-              <a:buChar char="■"/>
-            </a:pPr>
-            <a:r>
-              <a:rPr lang="en-US" sz="1900" dirty="0">
-                <a:solidFill>
-                  <a:srgbClr val="1F1A33"/>
-                </a:solidFill>
-                <a:latin typeface="Calibri" pitchFamily="34" charset="0"/>
-                <a:ea typeface="Calibri" pitchFamily="34" charset="-122"/>
-                <a:cs typeface="Calibri" pitchFamily="34" charset="-120"/>
-              </a:rPr>
-              <a:t>A hybrid image compression framework was implemented: LBG vector quantization, delta coding and Huffman coding.</a:t>
-            </a:r>
-            <a:endParaRPr lang="en-US" sz="1900" dirty="0"/>
-          </a:p>
-          <a:p>
-            <a:pPr marL="342900" indent="-342900">
-              <a:spcAft>
-                <a:spcPts val="1000"/>
-              </a:spcAft>
-              <a:buSzPct val="100000"/>
-              <a:buChar char="■"/>
-            </a:pPr>
-            <a:r>
-              <a:rPr lang="en-US" sz="1900" dirty="0">
-                <a:solidFill>
-                  <a:srgbClr val="1F1A33"/>
-                </a:solidFill>
-                <a:latin typeface="Calibri" pitchFamily="34" charset="0"/>
-                <a:ea typeface="Calibri" pitchFamily="34" charset="-122"/>
-                <a:cs typeface="Calibri" pitchFamily="34" charset="-120"/>
-              </a:rPr>
-              <a:t>LBG training was parallelized with MPI: 9.19× speedup on 14 processes (efficiency ≈ 66%); total speedup 5.00× (gray) and 6.84× (color).</a:t>
-            </a:r>
-            <a:endParaRPr lang="en-US" sz="1900" dirty="0"/>
-          </a:p>
-          <a:p>
-            <a:pPr marL="342900" indent="-342900">
-              <a:spcAft>
-                <a:spcPts val="1000"/>
-              </a:spcAft>
-              <a:buSzPct val="100000"/>
-              <a:buChar char="■"/>
-            </a:pPr>
-            <a:r>
-              <a:rPr lang="en-US" sz="1900" dirty="0">
-                <a:solidFill>
-                  <a:srgbClr val="1F1A33"/>
-                </a:solidFill>
-                <a:latin typeface="Calibri" pitchFamily="34" charset="0"/>
-                <a:ea typeface="Calibri" pitchFamily="34" charset="-122"/>
-                <a:cs typeface="Calibri" pitchFamily="34" charset="-120"/>
-              </a:rPr>
-              <a:t>The speed-aware (Adaptive) distribution reduced LBG time by 17.2–28.3% compared with Equal distribution (P = 8 to 14).</a:t>
-            </a:r>
-            <a:endParaRPr lang="en-US" sz="1900" dirty="0"/>
-          </a:p>
-          <a:p>
-            <a:pPr marL="342900" indent="-342900">
-              <a:spcAft>
-                <a:spcPts val="1000"/>
-              </a:spcAft>
-              <a:buSzPct val="100000"/>
-              <a:buChar char="■"/>
-            </a:pPr>
-            <a:r>
-              <a:rPr lang="en-US" sz="1900" dirty="0">
-                <a:solidFill>
-                  <a:srgbClr val="1F1A33"/>
-                </a:solidFill>
-                <a:latin typeface="Calibri" pitchFamily="34" charset="0"/>
-                <a:ea typeface="Calibri" pitchFamily="34" charset="-122"/>
-                <a:cs typeface="Calibri" pitchFamily="34" charset="-120"/>
-              </a:rPr>
-              <a:t>The parallel results were identical to the sequential ones: same reconstructed images and quality metrics.</a:t>
-            </a:r>
-            <a:endParaRPr lang="en-US" sz="1900" dirty="0"/>
-          </a:p>
-          <a:p>
-            <a:pPr marL="342900" indent="-342900">
-              <a:spcAft>
-                <a:spcPts val="1000"/>
-              </a:spcAft>
-              <a:buSzPct val="100000"/>
-              <a:buChar char="■"/>
-            </a:pPr>
-            <a:r>
-              <a:rPr lang="en-US" sz="1900" dirty="0">
-                <a:solidFill>
-                  <a:srgbClr val="1F1A33"/>
-                </a:solidFill>
-                <a:latin typeface="Calibri" pitchFamily="34" charset="0"/>
-                <a:ea typeface="Calibri" pitchFamily="34" charset="-122"/>
-                <a:cs typeface="Calibri" pitchFamily="34" charset="-120"/>
-              </a:rPr>
-              <a:t>Quality: mean PSNR 29.49 dB and SSIM 0.8266 (gray); 28.80 dB and 0.7654 (color), at a compression ratio of ___ (gray) and ___ (color).</a:t>
-            </a:r>
-            <a:endParaRPr lang="en-US" sz="1900" dirty="0"/>
-          </a:p>
-          <a:p>
-            <a:pPr marL="342900" indent="-342900">
-              <a:spcAft>
-                <a:spcPts val="1000"/>
-              </a:spcAft>
-              <a:buSzPct val="100000"/>
-              <a:buChar char="■"/>
-            </a:pPr>
-            <a:r>
-              <a:rPr lang="en-US" sz="1900" dirty="0">
-                <a:solidFill>
-                  <a:srgbClr val="1F1A33"/>
-                </a:solidFill>
-                <a:latin typeface="Calibri" pitchFamily="34" charset="0"/>
-                <a:ea typeface="Calibri" pitchFamily="34" charset="-122"/>
-                <a:cs typeface="Calibri" pitchFamily="34" charset="-120"/>
-              </a:rPr>
-              <a:t>The total speedup is limited by the sequential coding and reconstruction stages.</a:t>
-            </a:r>
-            <a:endParaRPr lang="en-US" sz="1900" dirty="0"/>
-          </a:p>
-        </p:txBody>
-      </p:sp>
-    </p:spTree>
-  </p:cSld>
-  <p:clrMapOvr>
-    <a:masterClrMapping/>
-  </p:clrMapOvr>
-</p:sld>
-</file>
-
 <file path=ppt/slides/slide3.xml><?xml version="1.0" encoding="utf-8"?>
 <p:sld xmlns:a="http://schemas.openxmlformats.org/drawingml/2006/main" xmlns:r="http://schemas.openxmlformats.org/officeDocument/2006/relationships" xmlns:p="http://schemas.openxmlformats.org/presentationml/2006/main">
   <p:cSld name="Slide 3">
@@ -27448,7 +27546,7 @@
                 <a:ea typeface="Calibri" pitchFamily="34" charset="-122"/>
                 <a:cs typeface="Calibri" pitchFamily="34" charset="-120"/>
               </a:rPr>
-              <a:t>Future Work</a:t>
+              <a:t>Conclusion</a:t>
             </a:r>
             <a:endParaRPr lang="en-US" sz="1600" dirty="0"/>
           </a:p>
@@ -27487,7 +27585,7 @@
                 <a:ea typeface="Cambria" pitchFamily="34" charset="-122"/>
                 <a:cs typeface="Cambria" pitchFamily="34" charset="-120"/>
               </a:rPr>
-              <a:t>Future Work</a:t>
+              <a:t>Conclusion</a:t>
             </a:r>
             <a:endParaRPr lang="en-US" sz="2800" dirty="0"/>
           </a:p>
@@ -27574,7 +27672,7 @@
               <a:buChar char="■"/>
             </a:pPr>
             <a:r>
-              <a:rPr lang="en-US" sz="2100" dirty="0">
+              <a:rPr lang="en-US" sz="1900" dirty="0">
                 <a:solidFill>
                   <a:srgbClr val="1F1A33"/>
                 </a:solidFill>
@@ -27582,9 +27680,9 @@
                 <a:ea typeface="Calibri" pitchFamily="34" charset="-122"/>
                 <a:cs typeface="Calibri" pitchFamily="34" charset="-120"/>
               </a:rPr>
-              <a:t>Parallelize the delta coding, Huffman coding and reconstruction stages.</a:t>
-            </a:r>
-            <a:endParaRPr lang="en-US" sz="2100" dirty="0"/>
+              <a:t>A hybrid image compression framework was implemented: LBG vector quantization, delta coding and Huffman coding.</a:t>
+            </a:r>
+            <a:endParaRPr lang="en-US" sz="1900" dirty="0"/>
           </a:p>
           <a:p>
             <a:pPr marL="342900" indent="-342900">
@@ -27595,7 +27693,7 @@
               <a:buChar char="■"/>
             </a:pPr>
             <a:r>
-              <a:rPr lang="en-US" sz="2100" dirty="0">
+              <a:rPr lang="en-US" sz="1900" dirty="0">
                 <a:solidFill>
                   <a:srgbClr val="1F1A33"/>
                 </a:solidFill>
@@ -27603,9 +27701,9 @@
                 <a:ea typeface="Calibri" pitchFamily="34" charset="-122"/>
                 <a:cs typeface="Calibri" pitchFamily="34" charset="-120"/>
               </a:rPr>
-              <a:t>Evaluate other block sizes, codebook sizes and larger images.</a:t>
-            </a:r>
-            <a:endParaRPr lang="en-US" sz="2100" dirty="0"/>
+              <a:t>LBG training was parallelized with MPI: 9.19× speedup on 14 processes (efficiency ≈ 66%); total speedup 5.00× (gray) and 6.84× (color).</a:t>
+            </a:r>
+            <a:endParaRPr lang="en-US" sz="1900" dirty="0"/>
           </a:p>
           <a:p>
             <a:pPr marL="342900" indent="-342900">
@@ -27616,7 +27714,7 @@
               <a:buChar char="■"/>
             </a:pPr>
             <a:r>
-              <a:rPr lang="en-US" sz="2100" dirty="0">
+              <a:rPr lang="en-US" sz="1900" dirty="0">
                 <a:solidFill>
                   <a:srgbClr val="1F1A33"/>
                 </a:solidFill>
@@ -27624,9 +27722,9 @@
                 <a:ea typeface="Calibri" pitchFamily="34" charset="-122"/>
                 <a:cs typeface="Calibri" pitchFamily="34" charset="-120"/>
               </a:rPr>
-              <a:t>Define an efficiency measure that accounts for the different speeds of P-cores and E-cores.</a:t>
-            </a:r>
-            <a:endParaRPr lang="en-US" sz="2100" dirty="0"/>
+              <a:t>The speed-aware (Adaptive) distribution reduced LBG time by 17.2–28.3% compared with Equal distribution (P = 8 to 14).</a:t>
+            </a:r>
+            <a:endParaRPr lang="en-US" sz="1900" dirty="0"/>
           </a:p>
           <a:p>
             <a:pPr marL="342900" indent="-342900">
@@ -27637,7 +27735,7 @@
               <a:buChar char="■"/>
             </a:pPr>
             <a:r>
-              <a:rPr lang="en-US" sz="2100" dirty="0">
+              <a:rPr lang="en-US" sz="1900" dirty="0">
                 <a:solidFill>
                   <a:srgbClr val="1F1A33"/>
                 </a:solidFill>
@@ -27645,9 +27743,9 @@
                 <a:ea typeface="Calibri" pitchFamily="34" charset="-122"/>
                 <a:cs typeface="Calibri" pitchFamily="34" charset="-120"/>
               </a:rPr>
-              <a:t>Implement a complete container file format (stored Huffman table and header) with a stand-alone decoder; the current program only accounts the compressed size.</a:t>
-            </a:r>
-            <a:endParaRPr lang="en-US" sz="2100" dirty="0"/>
+              <a:t>The parallel results were identical to the sequential ones: same reconstructed images and quality metrics.</a:t>
+            </a:r>
+            <a:endParaRPr lang="en-US" sz="1900" dirty="0"/>
           </a:p>
           <a:p>
             <a:pPr marL="342900" indent="-342900">
@@ -27658,7 +27756,7 @@
               <a:buChar char="■"/>
             </a:pPr>
             <a:r>
-              <a:rPr lang="en-US" sz="2100" dirty="0">
+              <a:rPr lang="en-US" sz="1900" dirty="0">
                 <a:solidFill>
                   <a:srgbClr val="1F1A33"/>
                 </a:solidFill>
@@ -27666,9 +27764,30 @@
                 <a:ea typeface="Calibri" pitchFamily="34" charset="-122"/>
                 <a:cs typeface="Calibri" pitchFamily="34" charset="-120"/>
               </a:rPr>
-              <a:t>Extend the study to other hybrid CPUs and to hybrid MPI + OpenMP implementations.</a:t>
-            </a:r>
-            <a:endParaRPr lang="en-US" sz="2100" dirty="0"/>
+              <a:t>Quality: mean PSNR 29.49 dB and SSIM 0.8266 (gray); 28.80 dB and 0.7654 (color), at a compression ratio of ___ (gray) and ___ (color).</a:t>
+            </a:r>
+            <a:endParaRPr lang="en-US" sz="1900" dirty="0"/>
+          </a:p>
+          <a:p>
+            <a:pPr marL="342900" indent="-342900">
+              <a:spcAft>
+                <a:spcPts val="1000"/>
+              </a:spcAft>
+              <a:buSzPct val="100000"/>
+              <a:buChar char="■"/>
+            </a:pPr>
+            <a:r>
+              <a:rPr lang="en-US" sz="1900" dirty="0">
+                <a:solidFill>
+                  <a:srgbClr val="1F1A33"/>
+                </a:solidFill>
+                <a:latin typeface="Calibri" pitchFamily="34" charset="0"/>
+                <a:ea typeface="Calibri" pitchFamily="34" charset="-122"/>
+                <a:cs typeface="Calibri" pitchFamily="34" charset="-120"/>
+              </a:rPr>
+              <a:t>The total speedup is limited by the sequential coding and reconstruction stages.</a:t>
+            </a:r>
+            <a:endParaRPr lang="en-US" sz="1900" dirty="0"/>
           </a:p>
         </p:txBody>
       </p:sp>
@@ -27683,6 +27802,322 @@
 <file path=ppt/slides/slide31.xml><?xml version="1.0" encoding="utf-8"?>
 <p:sld xmlns:a="http://schemas.openxmlformats.org/drawingml/2006/main" xmlns:r="http://schemas.openxmlformats.org/officeDocument/2006/relationships" xmlns:p="http://schemas.openxmlformats.org/presentationml/2006/main">
   <p:cSld name="Slide 31">
+    <p:bg>
+      <p:bgPr>
+        <a:solidFill>
+          <a:srgbClr val="FFFFFF"/>
+        </a:solidFill>
+      </p:bgPr>
+    </p:bg>
+    <p:spTree>
+      <p:nvGrpSpPr>
+        <p:cNvPr id="1" name=""/>
+        <p:cNvGrpSpPr/>
+        <p:nvPr/>
+      </p:nvGrpSpPr>
+      <p:grpSpPr>
+        <a:xfrm>
+          <a:off x="0" y="0"/>
+          <a:ext cx="0" cy="0"/>
+          <a:chOff x="0" y="0"/>
+          <a:chExt cx="0" cy="0"/>
+        </a:xfrm>
+      </p:grpSpPr>
+      <p:sp>
+        <p:nvSpPr>
+          <p:cNvPr id="2" name="Shape 0"/>
+          <p:cNvSpPr/>
+          <p:nvPr/>
+        </p:nvSpPr>
+        <p:spPr>
+          <a:xfrm>
+            <a:off x="457200" y="320040"/>
+            <a:ext cx="2103120" cy="502920"/>
+          </a:xfrm>
+          <a:prstGeom prst="roundRect">
+            <a:avLst>
+              <a:gd name="adj" fmla="val 18182"/>
+            </a:avLst>
+          </a:prstGeom>
+          <a:solidFill>
+            <a:srgbClr val="2E2055"/>
+          </a:solidFill>
+          <a:ln w="12700">
+            <a:solidFill>
+              <a:srgbClr val="2E2055"/>
+            </a:solidFill>
+            <a:prstDash val="solid"/>
+          </a:ln>
+        </p:spPr>
+      </p:sp>
+      <p:sp>
+        <p:nvSpPr>
+          <p:cNvPr id="3" name="Text 1"/>
+          <p:cNvSpPr/>
+          <p:nvPr/>
+        </p:nvSpPr>
+        <p:spPr>
+          <a:xfrm>
+            <a:off x="457200" y="320040"/>
+            <a:ext cx="2103120" cy="502920"/>
+          </a:xfrm>
+          <a:prstGeom prst="rect">
+            <a:avLst/>
+          </a:prstGeom>
+          <a:noFill/>
+          <a:ln/>
+        </p:spPr>
+        <p:txBody>
+          <a:bodyPr wrap="square" lIns="0" tIns="0" rIns="0" bIns="0" rtlCol="0" anchor="ctr"/>
+          <a:lstStyle/>
+          <a:p>
+            <a:pPr algn="ctr" indent="0" marL="0">
+              <a:buNone/>
+            </a:pPr>
+            <a:r>
+              <a:rPr lang="en-US" sz="1600" b="1" dirty="0">
+                <a:solidFill>
+                  <a:srgbClr val="FFFFFF"/>
+                </a:solidFill>
+                <a:latin typeface="Calibri" pitchFamily="34" charset="0"/>
+                <a:ea typeface="Calibri" pitchFamily="34" charset="-122"/>
+                <a:cs typeface="Calibri" pitchFamily="34" charset="-120"/>
+              </a:rPr>
+              <a:t>Future Work</a:t>
+            </a:r>
+            <a:endParaRPr lang="en-US" sz="1600" dirty="0"/>
+          </a:p>
+        </p:txBody>
+      </p:sp>
+      <p:sp>
+        <p:nvSpPr>
+          <p:cNvPr id="4" name="Text 2"/>
+          <p:cNvSpPr/>
+          <p:nvPr/>
+        </p:nvSpPr>
+        <p:spPr>
+          <a:xfrm>
+            <a:off x="2743200" y="274320"/>
+            <a:ext cx="9418320" cy="594360"/>
+          </a:xfrm>
+          <a:prstGeom prst="rect">
+            <a:avLst/>
+          </a:prstGeom>
+          <a:noFill/>
+          <a:ln/>
+        </p:spPr>
+        <p:txBody>
+          <a:bodyPr wrap="square" lIns="0" tIns="0" rIns="0" bIns="0" rtlCol="0" anchor="ctr"/>
+          <a:lstStyle/>
+          <a:p>
+            <a:pPr indent="0" marL="0">
+              <a:buNone/>
+            </a:pPr>
+            <a:r>
+              <a:rPr lang="en-US" sz="2800" b="1" dirty="0">
+                <a:solidFill>
+                  <a:srgbClr val="2E2055"/>
+                </a:solidFill>
+                <a:latin typeface="Cambria" pitchFamily="34" charset="0"/>
+                <a:ea typeface="Cambria" pitchFamily="34" charset="-122"/>
+                <a:cs typeface="Cambria" pitchFamily="34" charset="-120"/>
+              </a:rPr>
+              <a:t>Future Work</a:t>
+            </a:r>
+            <a:endParaRPr lang="en-US" sz="2800" dirty="0"/>
+          </a:p>
+        </p:txBody>
+      </p:sp>
+      <p:sp>
+        <p:nvSpPr>
+          <p:cNvPr id="5" name="Shape 3"/>
+          <p:cNvSpPr/>
+          <p:nvPr/>
+        </p:nvSpPr>
+        <p:spPr>
+          <a:xfrm>
+            <a:off x="457200" y="960120"/>
+            <a:ext cx="11274552" cy="36576"/>
+          </a:xfrm>
+          <a:prstGeom prst="rect">
+            <a:avLst/>
+          </a:prstGeom>
+          <a:solidFill>
+            <a:srgbClr val="2E2055"/>
+          </a:solidFill>
+          <a:ln w="12700">
+            <a:solidFill>
+              <a:srgbClr val="2E2055"/>
+            </a:solidFill>
+            <a:prstDash val="solid"/>
+          </a:ln>
+        </p:spPr>
+      </p:sp>
+      <p:sp>
+        <p:nvSpPr>
+          <p:cNvPr id="6" name="Shape 4"/>
+          <p:cNvSpPr/>
+          <p:nvPr/>
+        </p:nvSpPr>
+        <p:spPr>
+          <a:xfrm>
+            <a:off x="640080" y="1280160"/>
+            <a:ext cx="10927080" cy="5029200"/>
+          </a:xfrm>
+          <a:prstGeom prst="roundRect">
+            <a:avLst>
+              <a:gd name="adj" fmla="val 1455"/>
+            </a:avLst>
+          </a:prstGeom>
+          <a:solidFill>
+            <a:srgbClr val="F5F1FB"/>
+          </a:solidFill>
+          <a:ln w="12700">
+            <a:solidFill>
+              <a:srgbClr val="F5F1FB"/>
+            </a:solidFill>
+            <a:prstDash val="solid"/>
+          </a:ln>
+        </p:spPr>
+      </p:sp>
+      <p:sp>
+        <p:nvSpPr>
+          <p:cNvPr id="7" name="Text 5"/>
+          <p:cNvSpPr/>
+          <p:nvPr/>
+        </p:nvSpPr>
+        <p:spPr>
+          <a:xfrm>
+            <a:off x="777240" y="1371600"/>
+            <a:ext cx="10652760" cy="4846320"/>
+          </a:xfrm>
+          <a:prstGeom prst="rect">
+            <a:avLst/>
+          </a:prstGeom>
+          <a:noFill/>
+          <a:ln/>
+        </p:spPr>
+        <p:txBody>
+          <a:bodyPr wrap="square" lIns="1016" tIns="1016" rIns="1016" bIns="1016" rtlCol="0" anchor="t"/>
+          <a:lstStyle/>
+          <a:p>
+            <a:pPr marL="342900" indent="-342900">
+              <a:spcAft>
+                <a:spcPts val="1000"/>
+              </a:spcAft>
+              <a:buSzPct val="100000"/>
+              <a:buChar char="■"/>
+            </a:pPr>
+            <a:r>
+              <a:rPr lang="en-US" sz="2100" dirty="0">
+                <a:solidFill>
+                  <a:srgbClr val="1F1A33"/>
+                </a:solidFill>
+                <a:latin typeface="Calibri" pitchFamily="34" charset="0"/>
+                <a:ea typeface="Calibri" pitchFamily="34" charset="-122"/>
+                <a:cs typeface="Calibri" pitchFamily="34" charset="-120"/>
+              </a:rPr>
+              <a:t>Parallelize the delta coding, Huffman coding and reconstruction stages.</a:t>
+            </a:r>
+            <a:endParaRPr lang="en-US" sz="2100" dirty="0"/>
+          </a:p>
+          <a:p>
+            <a:pPr marL="342900" indent="-342900">
+              <a:spcAft>
+                <a:spcPts val="1000"/>
+              </a:spcAft>
+              <a:buSzPct val="100000"/>
+              <a:buChar char="■"/>
+            </a:pPr>
+            <a:r>
+              <a:rPr lang="en-US" sz="2100" dirty="0">
+                <a:solidFill>
+                  <a:srgbClr val="1F1A33"/>
+                </a:solidFill>
+                <a:latin typeface="Calibri" pitchFamily="34" charset="0"/>
+                <a:ea typeface="Calibri" pitchFamily="34" charset="-122"/>
+                <a:cs typeface="Calibri" pitchFamily="34" charset="-120"/>
+              </a:rPr>
+              <a:t>Evaluate other block sizes, codebook sizes and larger images.</a:t>
+            </a:r>
+            <a:endParaRPr lang="en-US" sz="2100" dirty="0"/>
+          </a:p>
+          <a:p>
+            <a:pPr marL="342900" indent="-342900">
+              <a:spcAft>
+                <a:spcPts val="1000"/>
+              </a:spcAft>
+              <a:buSzPct val="100000"/>
+              <a:buChar char="■"/>
+            </a:pPr>
+            <a:r>
+              <a:rPr lang="en-US" sz="2100" dirty="0">
+                <a:solidFill>
+                  <a:srgbClr val="1F1A33"/>
+                </a:solidFill>
+                <a:latin typeface="Calibri" pitchFamily="34" charset="0"/>
+                <a:ea typeface="Calibri" pitchFamily="34" charset="-122"/>
+                <a:cs typeface="Calibri" pitchFamily="34" charset="-120"/>
+              </a:rPr>
+              <a:t>Define an efficiency measure that accounts for the different speeds of P-cores and E-cores.</a:t>
+            </a:r>
+            <a:endParaRPr lang="en-US" sz="2100" dirty="0"/>
+          </a:p>
+          <a:p>
+            <a:pPr marL="342900" indent="-342900">
+              <a:spcAft>
+                <a:spcPts val="1000"/>
+              </a:spcAft>
+              <a:buSzPct val="100000"/>
+              <a:buChar char="■"/>
+            </a:pPr>
+            <a:r>
+              <a:rPr lang="en-US" sz="2100" dirty="0">
+                <a:solidFill>
+                  <a:srgbClr val="1F1A33"/>
+                </a:solidFill>
+                <a:latin typeface="Calibri" pitchFamily="34" charset="0"/>
+                <a:ea typeface="Calibri" pitchFamily="34" charset="-122"/>
+                <a:cs typeface="Calibri" pitchFamily="34" charset="-120"/>
+              </a:rPr>
+              <a:t>Implement a complete container file format (stored Huffman table and header) with a stand-alone decoder; the current program only accounts the compressed size.</a:t>
+            </a:r>
+            <a:endParaRPr lang="en-US" sz="2100" dirty="0"/>
+          </a:p>
+          <a:p>
+            <a:pPr marL="342900" indent="-342900">
+              <a:spcAft>
+                <a:spcPts val="1000"/>
+              </a:spcAft>
+              <a:buSzPct val="100000"/>
+              <a:buChar char="■"/>
+            </a:pPr>
+            <a:r>
+              <a:rPr lang="en-US" sz="2100" dirty="0">
+                <a:solidFill>
+                  <a:srgbClr val="1F1A33"/>
+                </a:solidFill>
+                <a:latin typeface="Calibri" pitchFamily="34" charset="0"/>
+                <a:ea typeface="Calibri" pitchFamily="34" charset="-122"/>
+                <a:cs typeface="Calibri" pitchFamily="34" charset="-120"/>
+              </a:rPr>
+              <a:t>Extend the study to other hybrid CPUs and to hybrid MPI + OpenMP implementations.</a:t>
+            </a:r>
+            <a:endParaRPr lang="en-US" sz="2100" dirty="0"/>
+          </a:p>
+        </p:txBody>
+      </p:sp>
+    </p:spTree>
+  </p:cSld>
+  <p:clrMapOvr>
+    <a:masterClrMapping/>
+  </p:clrMapOvr>
+</p:sld>
+</file>
+
+<file path=ppt/slides/slide32.xml><?xml version="1.0" encoding="utf-8"?>
+<p:sld xmlns:a="http://schemas.openxmlformats.org/drawingml/2006/main" xmlns:r="http://schemas.openxmlformats.org/officeDocument/2006/relationships" xmlns:p="http://schemas.openxmlformats.org/presentationml/2006/main">
+  <p:cSld name="Slide 32">
     <p:bg>
       <p:bgPr>
         <a:solidFill>

</xml_diff>

<commit_message>
Karp-Flatt slide: Total shown separately for gray and color
Co-Authored-By: Claude Sonnet 5.5 <noreply@anthropic.com>
Claude-Session: https://claude.ai/code/session_01T6gEewJ8YaCdmnsfS34RJd
</commit_message>
<xml_diff>
--- a/results/seminar/figs/Seminar_Ibtihal_v3.pptx
+++ b/results/seminar/figs/Seminar_Ibtihal_v3.pptx
@@ -23986,20 +23986,22 @@
         </p:nvGraphicFramePr>
         <p:xfrm>
           <a:off x="457200" y="1280160"/>
-          <a:ext cx="7223760" cy="914400"/>
+          <a:ext cx="7772400" cy="914400"/>
         </p:xfrm>
         <a:graphic>
           <a:graphicData uri="http://schemas.openxmlformats.org/drawingml/2006/table">
             <a:tbl>
               <a:tblPr/>
               <a:tblGrid>
-                <a:gridCol w="822960"/>
-                <a:gridCol w="1554480"/>
-                <a:gridCol w="1645920"/>
-                <a:gridCol w="1645920"/>
-                <a:gridCol w="1554480"/>
+                <a:gridCol w="640080"/>
+                <a:gridCol w="1005840"/>
+                <a:gridCol w="1188720"/>
+                <a:gridCol w="1188720"/>
+                <a:gridCol w="1280160"/>
+                <a:gridCol w="1188720"/>
+                <a:gridCol w="1280160"/>
               </a:tblGrid>
-              <a:tr h="502920">
+              <a:tr h="530352">
                 <a:tc>
                   <a:txBody>
                     <a:bodyPr/>
@@ -24009,7 +24011,7 @@
                         <a:buNone/>
                       </a:pPr>
                       <a:r>
-                        <a:rPr lang="en-US" sz="1500" b="1" dirty="0">
+                        <a:rPr lang="en-US" sz="1300" b="1" dirty="0">
                           <a:solidFill>
                             <a:srgbClr val="FFFFFF"/>
                           </a:solidFill>
@@ -24019,7 +24021,7 @@
                         </a:rPr>
                         <a:t>P</a:t>
                       </a:r>
-                      <a:endParaRPr lang="en-US" sz="1500" dirty="0">
+                      <a:endParaRPr lang="en-US" sz="1300" dirty="0">
                         <a:latin typeface="Calibri" charset="0"/>
                         <a:ea typeface="Calibri" charset="0"/>
                         <a:cs typeface="Calibri" charset="0"/>
@@ -24077,7 +24079,7 @@
                         <a:buNone/>
                       </a:pPr>
                       <a:r>
-                        <a:rPr lang="en-US" sz="1500" b="1" dirty="0">
+                        <a:rPr lang="en-US" sz="1300" b="1" dirty="0">
                           <a:solidFill>
                             <a:srgbClr val="FFFFFF"/>
                           </a:solidFill>
@@ -24085,9 +24087,9 @@
                           <a:ea typeface="Calibri" pitchFamily="34" charset="-122"/>
                           <a:cs typeface="Calibri" pitchFamily="34" charset="-120"/>
                         </a:rPr>
-                        <a:t>LBG: Karp–Flatt</a:t>
+                        <a:t>LBG: KF</a:t>
                       </a:r>
-                      <a:endParaRPr lang="en-US" sz="1500" dirty="0">
+                      <a:endParaRPr lang="en-US" sz="1300" dirty="0">
                         <a:latin typeface="Calibri" charset="0"/>
                         <a:ea typeface="Calibri" charset="0"/>
                         <a:cs typeface="Calibri" charset="0"/>
@@ -24145,7 +24147,7 @@
                         <a:buNone/>
                       </a:pPr>
                       <a:r>
-                        <a:rPr lang="en-US" sz="1500" b="1" dirty="0">
+                        <a:rPr lang="en-US" sz="1300" b="1" dirty="0">
                           <a:solidFill>
                             <a:srgbClr val="FFFFFF"/>
                           </a:solidFill>
@@ -24153,9 +24155,9 @@
                           <a:ea typeface="Calibri" pitchFamily="34" charset="-122"/>
                           <a:cs typeface="Calibri" pitchFamily="34" charset="-120"/>
                         </a:rPr>
-                        <a:t>LBG: efficiency (%)</a:t>
+                        <a:t>LBG: Eff. (%)</a:t>
                       </a:r>
-                      <a:endParaRPr lang="en-US" sz="1500" dirty="0">
+                      <a:endParaRPr lang="en-US" sz="1300" dirty="0">
                         <a:latin typeface="Calibri" charset="0"/>
                         <a:ea typeface="Calibri" charset="0"/>
                         <a:cs typeface="Calibri" charset="0"/>
@@ -24213,7 +24215,7 @@
                         <a:buNone/>
                       </a:pPr>
                       <a:r>
-                        <a:rPr lang="en-US" sz="1500" b="1" dirty="0">
+                        <a:rPr lang="en-US" sz="1300" b="1" dirty="0">
                           <a:solidFill>
                             <a:srgbClr val="FFFFFF"/>
                           </a:solidFill>
@@ -24221,9 +24223,9 @@
                           <a:ea typeface="Calibri" pitchFamily="34" charset="-122"/>
                           <a:cs typeface="Calibri" pitchFamily="34" charset="-120"/>
                         </a:rPr>
-                        <a:t>Total: Karp–Flatt</a:t>
+                        <a:t>Total gray: KF</a:t>
                       </a:r>
-                      <a:endParaRPr lang="en-US" sz="1500" dirty="0">
+                      <a:endParaRPr lang="en-US" sz="1300" dirty="0">
                         <a:latin typeface="Calibri" charset="0"/>
                         <a:ea typeface="Calibri" charset="0"/>
                         <a:cs typeface="Calibri" charset="0"/>
@@ -24281,7 +24283,7 @@
                         <a:buNone/>
                       </a:pPr>
                       <a:r>
-                        <a:rPr lang="en-US" sz="1500" b="1" dirty="0">
+                        <a:rPr lang="en-US" sz="1300" b="1" dirty="0">
                           <a:solidFill>
                             <a:srgbClr val="FFFFFF"/>
                           </a:solidFill>
@@ -24289,9 +24291,9 @@
                           <a:ea typeface="Calibri" pitchFamily="34" charset="-122"/>
                           <a:cs typeface="Calibri" pitchFamily="34" charset="-120"/>
                         </a:rPr>
-                        <a:t>Total: efficiency (%)</a:t>
+                        <a:t>Total gray: Eff. (%)</a:t>
                       </a:r>
-                      <a:endParaRPr lang="en-US" sz="1500" dirty="0">
+                      <a:endParaRPr lang="en-US" sz="1300" dirty="0">
                         <a:latin typeface="Calibri" charset="0"/>
                         <a:ea typeface="Calibri" charset="0"/>
                         <a:cs typeface="Calibri" charset="0"/>
@@ -24340,8 +24342,6 @@
                     </a:solidFill>
                   </a:tcPr>
                 </a:tc>
-              </a:tr>
-              <a:tr h="502920">
                 <a:tc>
                   <a:txBody>
                     <a:bodyPr/>
@@ -24351,7 +24351,145 @@
                         <a:buNone/>
                       </a:pPr>
                       <a:r>
-                        <a:rPr lang="en-US" sz="1500" b="1" dirty="0">
+                        <a:rPr lang="en-US" sz="1300" b="1" dirty="0">
+                          <a:solidFill>
+                            <a:srgbClr val="FFFFFF"/>
+                          </a:solidFill>
+                          <a:latin typeface="Calibri" pitchFamily="34" charset="0"/>
+                          <a:ea typeface="Calibri" pitchFamily="34" charset="-122"/>
+                          <a:cs typeface="Calibri" pitchFamily="34" charset="-120"/>
+                        </a:rPr>
+                        <a:t>Total color: KF</a:t>
+                      </a:r>
+                      <a:endParaRPr lang="en-US" sz="1300" dirty="0">
+                        <a:latin typeface="Calibri" charset="0"/>
+                        <a:ea typeface="Calibri" charset="0"/>
+                        <a:cs typeface="Calibri" charset="0"/>
+                      </a:endParaRPr>
+                    </a:p>
+                  </a:txBody>
+                  <a:tcPr marL="91440" marR="91440" marT="45720" marB="45720" anchor="ctr">
+                    <a:lnL w="19050" cap="flat" cmpd="sng" algn="ctr">
+                      <a:solidFill>
+                        <a:srgbClr val="FFFFFF"/>
+                      </a:solidFill>
+                      <a:prstDash val="solid"/>
+                      <a:round/>
+                      <a:headEnd type="none" w="med" len="med"/>
+                      <a:tailEnd type="none" w="med" len="med"/>
+                    </a:lnL>
+                    <a:lnR w="19050" cap="flat" cmpd="sng" algn="ctr">
+                      <a:solidFill>
+                        <a:srgbClr val="FFFFFF"/>
+                      </a:solidFill>
+                      <a:prstDash val="solid"/>
+                      <a:round/>
+                      <a:headEnd type="none" w="med" len="med"/>
+                      <a:tailEnd type="none" w="med" len="med"/>
+                    </a:lnR>
+                    <a:lnT w="19050" cap="flat" cmpd="sng" algn="ctr">
+                      <a:solidFill>
+                        <a:srgbClr val="FFFFFF"/>
+                      </a:solidFill>
+                      <a:prstDash val="solid"/>
+                      <a:round/>
+                      <a:headEnd type="none" w="med" len="med"/>
+                      <a:tailEnd type="none" w="med" len="med"/>
+                    </a:lnT>
+                    <a:lnB w="19050" cap="flat" cmpd="sng" algn="ctr">
+                      <a:solidFill>
+                        <a:srgbClr val="FFFFFF"/>
+                      </a:solidFill>
+                      <a:prstDash val="solid"/>
+                      <a:round/>
+                      <a:headEnd type="none" w="med" len="med"/>
+                      <a:tailEnd type="none" w="med" len="med"/>
+                    </a:lnB>
+                    <a:solidFill>
+                      <a:srgbClr val="2A9D8F"/>
+                    </a:solidFill>
+                  </a:tcPr>
+                </a:tc>
+                <a:tc>
+                  <a:txBody>
+                    <a:bodyPr/>
+                    <a:lstStyle/>
+                    <a:p>
+                      <a:pPr algn="ctr" indent="0" marL="0">
+                        <a:buNone/>
+                      </a:pPr>
+                      <a:r>
+                        <a:rPr lang="en-US" sz="1300" b="1" dirty="0">
+                          <a:solidFill>
+                            <a:srgbClr val="FFFFFF"/>
+                          </a:solidFill>
+                          <a:latin typeface="Calibri" pitchFamily="34" charset="0"/>
+                          <a:ea typeface="Calibri" pitchFamily="34" charset="-122"/>
+                          <a:cs typeface="Calibri" pitchFamily="34" charset="-120"/>
+                        </a:rPr>
+                        <a:t>Total color: Eff. (%)</a:t>
+                      </a:r>
+                      <a:endParaRPr lang="en-US" sz="1300" dirty="0">
+                        <a:latin typeface="Calibri" charset="0"/>
+                        <a:ea typeface="Calibri" charset="0"/>
+                        <a:cs typeface="Calibri" charset="0"/>
+                      </a:endParaRPr>
+                    </a:p>
+                  </a:txBody>
+                  <a:tcPr marL="91440" marR="91440" marT="45720" marB="45720" anchor="ctr">
+                    <a:lnL w="19050" cap="flat" cmpd="sng" algn="ctr">
+                      <a:solidFill>
+                        <a:srgbClr val="FFFFFF"/>
+                      </a:solidFill>
+                      <a:prstDash val="solid"/>
+                      <a:round/>
+                      <a:headEnd type="none" w="med" len="med"/>
+                      <a:tailEnd type="none" w="med" len="med"/>
+                    </a:lnL>
+                    <a:lnR w="19050" cap="flat" cmpd="sng" algn="ctr">
+                      <a:solidFill>
+                        <a:srgbClr val="FFFFFF"/>
+                      </a:solidFill>
+                      <a:prstDash val="solid"/>
+                      <a:round/>
+                      <a:headEnd type="none" w="med" len="med"/>
+                      <a:tailEnd type="none" w="med" len="med"/>
+                    </a:lnR>
+                    <a:lnT w="19050" cap="flat" cmpd="sng" algn="ctr">
+                      <a:solidFill>
+                        <a:srgbClr val="FFFFFF"/>
+                      </a:solidFill>
+                      <a:prstDash val="solid"/>
+                      <a:round/>
+                      <a:headEnd type="none" w="med" len="med"/>
+                      <a:tailEnd type="none" w="med" len="med"/>
+                    </a:lnT>
+                    <a:lnB w="19050" cap="flat" cmpd="sng" algn="ctr">
+                      <a:solidFill>
+                        <a:srgbClr val="FFFFFF"/>
+                      </a:solidFill>
+                      <a:prstDash val="solid"/>
+                      <a:round/>
+                      <a:headEnd type="none" w="med" len="med"/>
+                      <a:tailEnd type="none" w="med" len="med"/>
+                    </a:lnB>
+                    <a:solidFill>
+                      <a:srgbClr val="2A9D8F"/>
+                    </a:solidFill>
+                  </a:tcPr>
+                </a:tc>
+              </a:tr>
+              <a:tr h="530352">
+                <a:tc>
+                  <a:txBody>
+                    <a:bodyPr/>
+                    <a:lstStyle/>
+                    <a:p>
+                      <a:pPr algn="ctr" indent="0" marL="0">
+                        <a:buNone/>
+                      </a:pPr>
+                      <a:r>
+                        <a:rPr lang="en-US" sz="1400" b="1" dirty="0">
                           <a:solidFill>
                             <a:srgbClr val="1F1A33"/>
                           </a:solidFill>
@@ -24361,7 +24499,7 @@
                         </a:rPr>
                         <a:t>2</a:t>
                       </a:r>
-                      <a:endParaRPr lang="en-US" sz="1500" dirty="0">
+                      <a:endParaRPr lang="en-US" sz="1400" dirty="0">
                         <a:latin typeface="Calibri" charset="0"/>
                         <a:ea typeface="Calibri" charset="0"/>
                         <a:cs typeface="Calibri" charset="0"/>
@@ -24419,7 +24557,7 @@
                         <a:buNone/>
                       </a:pPr>
                       <a:r>
-                        <a:rPr lang="en-US" sz="1500" b="1" dirty="0">
+                        <a:rPr lang="en-US" sz="1400" b="1" dirty="0">
                           <a:solidFill>
                             <a:srgbClr val="6B4FA3"/>
                           </a:solidFill>
@@ -24429,7 +24567,7 @@
                         </a:rPr>
                         <a:t>0.033</a:t>
                       </a:r>
-                      <a:endParaRPr lang="en-US" sz="1500" dirty="0">
+                      <a:endParaRPr lang="en-US" sz="1400" dirty="0">
                         <a:latin typeface="Calibri" charset="0"/>
                         <a:ea typeface="Calibri" charset="0"/>
                         <a:cs typeface="Calibri" charset="0"/>
@@ -24487,7 +24625,7 @@
                         <a:buNone/>
                       </a:pPr>
                       <a:r>
-                        <a:rPr lang="en-US" sz="1500" dirty="0">
+                        <a:rPr lang="en-US" sz="1400" dirty="0">
                           <a:solidFill>
                             <a:srgbClr val="1F1A33"/>
                           </a:solidFill>
@@ -24497,7 +24635,7 @@
                         </a:rPr>
                         <a:t>96.8</a:t>
                       </a:r>
-                      <a:endParaRPr lang="en-US" sz="1500" dirty="0">
+                      <a:endParaRPr lang="en-US" sz="1400" dirty="0">
                         <a:latin typeface="Calibri" charset="0"/>
                         <a:ea typeface="Calibri" charset="0"/>
                         <a:cs typeface="Calibri" charset="0"/>
@@ -24555,7 +24693,7 @@
                         <a:buNone/>
                       </a:pPr>
                       <a:r>
-                        <a:rPr lang="en-US" sz="1500" b="1" dirty="0">
+                        <a:rPr lang="en-US" sz="1400" b="1" dirty="0">
                           <a:solidFill>
                             <a:srgbClr val="E0457B"/>
                           </a:solidFill>
@@ -24563,9 +24701,9 @@
                           <a:ea typeface="Calibri" pitchFamily="34" charset="-122"/>
                           <a:cs typeface="Calibri" pitchFamily="34" charset="-120"/>
                         </a:rPr>
-                        <a:t>0.101</a:t>
+                        <a:t>0.132</a:t>
                       </a:r>
-                      <a:endParaRPr lang="en-US" sz="1500" dirty="0">
+                      <a:endParaRPr lang="en-US" sz="1400" dirty="0">
                         <a:latin typeface="Calibri" charset="0"/>
                         <a:ea typeface="Calibri" charset="0"/>
                         <a:cs typeface="Calibri" charset="0"/>
@@ -24623,7 +24761,7 @@
                         <a:buNone/>
                       </a:pPr>
                       <a:r>
-                        <a:rPr lang="en-US" sz="1500" dirty="0">
+                        <a:rPr lang="en-US" sz="1400" dirty="0">
                           <a:solidFill>
                             <a:srgbClr val="1F1A33"/>
                           </a:solidFill>
@@ -24631,9 +24769,9 @@
                           <a:ea typeface="Calibri" pitchFamily="34" charset="-122"/>
                           <a:cs typeface="Calibri" pitchFamily="34" charset="-120"/>
                         </a:rPr>
-                        <a:t>90.8</a:t>
+                        <a:t>88.4</a:t>
                       </a:r>
-                      <a:endParaRPr lang="en-US" sz="1500" dirty="0">
+                      <a:endParaRPr lang="en-US" sz="1400" dirty="0">
                         <a:latin typeface="Calibri" charset="0"/>
                         <a:ea typeface="Calibri" charset="0"/>
                         <a:cs typeface="Calibri" charset="0"/>
@@ -24682,8 +24820,6 @@
                     </a:solidFill>
                   </a:tcPr>
                 </a:tc>
-              </a:tr>
-              <a:tr h="502920">
                 <a:tc>
                   <a:txBody>
                     <a:bodyPr/>
@@ -24693,7 +24829,145 @@
                         <a:buNone/>
                       </a:pPr>
                       <a:r>
-                        <a:rPr lang="en-US" sz="1500" b="1" dirty="0">
+                        <a:rPr lang="en-US" sz="1400" b="1" dirty="0">
+                          <a:solidFill>
+                            <a:srgbClr val="E0457B"/>
+                          </a:solidFill>
+                          <a:latin typeface="Calibri" pitchFamily="34" charset="0"/>
+                          <a:ea typeface="Calibri" pitchFamily="34" charset="-122"/>
+                          <a:cs typeface="Calibri" pitchFamily="34" charset="-120"/>
+                        </a:rPr>
+                        <a:t>0.072</a:t>
+                      </a:r>
+                      <a:endParaRPr lang="en-US" sz="1400" dirty="0">
+                        <a:latin typeface="Calibri" charset="0"/>
+                        <a:ea typeface="Calibri" charset="0"/>
+                        <a:cs typeface="Calibri" charset="0"/>
+                      </a:endParaRPr>
+                    </a:p>
+                  </a:txBody>
+                  <a:tcPr marL="91440" marR="91440" marT="45720" marB="45720" anchor="ctr">
+                    <a:lnL w="19050" cap="flat" cmpd="sng" algn="ctr">
+                      <a:solidFill>
+                        <a:srgbClr val="FFFFFF"/>
+                      </a:solidFill>
+                      <a:prstDash val="solid"/>
+                      <a:round/>
+                      <a:headEnd type="none" w="med" len="med"/>
+                      <a:tailEnd type="none" w="med" len="med"/>
+                    </a:lnL>
+                    <a:lnR w="19050" cap="flat" cmpd="sng" algn="ctr">
+                      <a:solidFill>
+                        <a:srgbClr val="FFFFFF"/>
+                      </a:solidFill>
+                      <a:prstDash val="solid"/>
+                      <a:round/>
+                      <a:headEnd type="none" w="med" len="med"/>
+                      <a:tailEnd type="none" w="med" len="med"/>
+                    </a:lnR>
+                    <a:lnT w="19050" cap="flat" cmpd="sng" algn="ctr">
+                      <a:solidFill>
+                        <a:srgbClr val="FFFFFF"/>
+                      </a:solidFill>
+                      <a:prstDash val="solid"/>
+                      <a:round/>
+                      <a:headEnd type="none" w="med" len="med"/>
+                      <a:tailEnd type="none" w="med" len="med"/>
+                    </a:lnT>
+                    <a:lnB w="19050" cap="flat" cmpd="sng" algn="ctr">
+                      <a:solidFill>
+                        <a:srgbClr val="FFFFFF"/>
+                      </a:solidFill>
+                      <a:prstDash val="solid"/>
+                      <a:round/>
+                      <a:headEnd type="none" w="med" len="med"/>
+                      <a:tailEnd type="none" w="med" len="med"/>
+                    </a:lnB>
+                    <a:solidFill>
+                      <a:srgbClr val="EAF6F4"/>
+                    </a:solidFill>
+                  </a:tcPr>
+                </a:tc>
+                <a:tc>
+                  <a:txBody>
+                    <a:bodyPr/>
+                    <a:lstStyle/>
+                    <a:p>
+                      <a:pPr algn="ctr" indent="0" marL="0">
+                        <a:buNone/>
+                      </a:pPr>
+                      <a:r>
+                        <a:rPr lang="en-US" sz="1400" dirty="0">
+                          <a:solidFill>
+                            <a:srgbClr val="1F1A33"/>
+                          </a:solidFill>
+                          <a:latin typeface="Calibri" pitchFamily="34" charset="0"/>
+                          <a:ea typeface="Calibri" pitchFamily="34" charset="-122"/>
+                          <a:cs typeface="Calibri" pitchFamily="34" charset="-120"/>
+                        </a:rPr>
+                        <a:t>93.3</a:t>
+                      </a:r>
+                      <a:endParaRPr lang="en-US" sz="1400" dirty="0">
+                        <a:latin typeface="Calibri" charset="0"/>
+                        <a:ea typeface="Calibri" charset="0"/>
+                        <a:cs typeface="Calibri" charset="0"/>
+                      </a:endParaRPr>
+                    </a:p>
+                  </a:txBody>
+                  <a:tcPr marL="91440" marR="91440" marT="45720" marB="45720" anchor="ctr">
+                    <a:lnL w="19050" cap="flat" cmpd="sng" algn="ctr">
+                      <a:solidFill>
+                        <a:srgbClr val="FFFFFF"/>
+                      </a:solidFill>
+                      <a:prstDash val="solid"/>
+                      <a:round/>
+                      <a:headEnd type="none" w="med" len="med"/>
+                      <a:tailEnd type="none" w="med" len="med"/>
+                    </a:lnL>
+                    <a:lnR w="19050" cap="flat" cmpd="sng" algn="ctr">
+                      <a:solidFill>
+                        <a:srgbClr val="FFFFFF"/>
+                      </a:solidFill>
+                      <a:prstDash val="solid"/>
+                      <a:round/>
+                      <a:headEnd type="none" w="med" len="med"/>
+                      <a:tailEnd type="none" w="med" len="med"/>
+                    </a:lnR>
+                    <a:lnT w="19050" cap="flat" cmpd="sng" algn="ctr">
+                      <a:solidFill>
+                        <a:srgbClr val="FFFFFF"/>
+                      </a:solidFill>
+                      <a:prstDash val="solid"/>
+                      <a:round/>
+                      <a:headEnd type="none" w="med" len="med"/>
+                      <a:tailEnd type="none" w="med" len="med"/>
+                    </a:lnT>
+                    <a:lnB w="19050" cap="flat" cmpd="sng" algn="ctr">
+                      <a:solidFill>
+                        <a:srgbClr val="FFFFFF"/>
+                      </a:solidFill>
+                      <a:prstDash val="solid"/>
+                      <a:round/>
+                      <a:headEnd type="none" w="med" len="med"/>
+                      <a:tailEnd type="none" w="med" len="med"/>
+                    </a:lnB>
+                    <a:solidFill>
+                      <a:srgbClr val="EAF6F4"/>
+                    </a:solidFill>
+                  </a:tcPr>
+                </a:tc>
+              </a:tr>
+              <a:tr h="530352">
+                <a:tc>
+                  <a:txBody>
+                    <a:bodyPr/>
+                    <a:lstStyle/>
+                    <a:p>
+                      <a:pPr algn="ctr" indent="0" marL="0">
+                        <a:buNone/>
+                      </a:pPr>
+                      <a:r>
+                        <a:rPr lang="en-US" sz="1400" b="1" dirty="0">
                           <a:solidFill>
                             <a:srgbClr val="1F1A33"/>
                           </a:solidFill>
@@ -24703,7 +24977,7 @@
                         </a:rPr>
                         <a:t>4</a:t>
                       </a:r>
-                      <a:endParaRPr lang="en-US" sz="1500" dirty="0">
+                      <a:endParaRPr lang="en-US" sz="1400" dirty="0">
                         <a:latin typeface="Calibri" charset="0"/>
                         <a:ea typeface="Calibri" charset="0"/>
                         <a:cs typeface="Calibri" charset="0"/>
@@ -24761,7 +25035,7 @@
                         <a:buNone/>
                       </a:pPr>
                       <a:r>
-                        <a:rPr lang="en-US" sz="1500" b="1" dirty="0">
+                        <a:rPr lang="en-US" sz="1400" b="1" dirty="0">
                           <a:solidFill>
                             <a:srgbClr val="6B4FA3"/>
                           </a:solidFill>
@@ -24771,7 +25045,7 @@
                         </a:rPr>
                         <a:t>0.018</a:t>
                       </a:r>
-                      <a:endParaRPr lang="en-US" sz="1500" dirty="0">
+                      <a:endParaRPr lang="en-US" sz="1400" dirty="0">
                         <a:latin typeface="Calibri" charset="0"/>
                         <a:ea typeface="Calibri" charset="0"/>
                         <a:cs typeface="Calibri" charset="0"/>
@@ -24829,7 +25103,7 @@
                         <a:buNone/>
                       </a:pPr>
                       <a:r>
-                        <a:rPr lang="en-US" sz="1500" dirty="0">
+                        <a:rPr lang="en-US" sz="1400" dirty="0">
                           <a:solidFill>
                             <a:srgbClr val="1F1A33"/>
                           </a:solidFill>
@@ -24839,7 +25113,7 @@
                         </a:rPr>
                         <a:t>94.8</a:t>
                       </a:r>
-                      <a:endParaRPr lang="en-US" sz="1500" dirty="0">
+                      <a:endParaRPr lang="en-US" sz="1400" dirty="0">
                         <a:latin typeface="Calibri" charset="0"/>
                         <a:ea typeface="Calibri" charset="0"/>
                         <a:cs typeface="Calibri" charset="0"/>
@@ -24897,7 +25171,7 @@
                         <a:buNone/>
                       </a:pPr>
                       <a:r>
-                        <a:rPr lang="en-US" sz="1500" b="1" dirty="0">
+                        <a:rPr lang="en-US" sz="1400" b="1" dirty="0">
                           <a:solidFill>
                             <a:srgbClr val="E0457B"/>
                           </a:solidFill>
@@ -24905,9 +25179,9 @@
                           <a:ea typeface="Calibri" pitchFamily="34" charset="-122"/>
                           <a:cs typeface="Calibri" pitchFamily="34" charset="-120"/>
                         </a:rPr>
-                        <a:t>0.081</a:t>
+                        <a:t>0.112</a:t>
                       </a:r>
-                      <a:endParaRPr lang="en-US" sz="1500" dirty="0">
+                      <a:endParaRPr lang="en-US" sz="1400" dirty="0">
                         <a:latin typeface="Calibri" charset="0"/>
                         <a:ea typeface="Calibri" charset="0"/>
                         <a:cs typeface="Calibri" charset="0"/>
@@ -24965,7 +25239,7 @@
                         <a:buNone/>
                       </a:pPr>
                       <a:r>
-                        <a:rPr lang="en-US" sz="1500" dirty="0">
+                        <a:rPr lang="en-US" sz="1400" dirty="0">
                           <a:solidFill>
                             <a:srgbClr val="1F1A33"/>
                           </a:solidFill>
@@ -24973,9 +25247,9 @@
                           <a:ea typeface="Calibri" pitchFamily="34" charset="-122"/>
                           <a:cs typeface="Calibri" pitchFamily="34" charset="-120"/>
                         </a:rPr>
-                        <a:t>80.5</a:t>
+                        <a:t>74.8</a:t>
                       </a:r>
-                      <a:endParaRPr lang="en-US" sz="1500" dirty="0">
+                      <a:endParaRPr lang="en-US" sz="1400" dirty="0">
                         <a:latin typeface="Calibri" charset="0"/>
                         <a:ea typeface="Calibri" charset="0"/>
                         <a:cs typeface="Calibri" charset="0"/>
@@ -25024,8 +25298,6 @@
                     </a:solidFill>
                   </a:tcPr>
                 </a:tc>
-              </a:tr>
-              <a:tr h="502920">
                 <a:tc>
                   <a:txBody>
                     <a:bodyPr/>
@@ -25035,7 +25307,145 @@
                         <a:buNone/>
                       </a:pPr>
                       <a:r>
-                        <a:rPr lang="en-US" sz="1500" b="1" dirty="0">
+                        <a:rPr lang="en-US" sz="1400" b="1" dirty="0">
+                          <a:solidFill>
+                            <a:srgbClr val="E0457B"/>
+                          </a:solidFill>
+                          <a:latin typeface="Calibri" pitchFamily="34" charset="0"/>
+                          <a:ea typeface="Calibri" pitchFamily="34" charset="-122"/>
+                          <a:cs typeface="Calibri" pitchFamily="34" charset="-120"/>
+                        </a:rPr>
+                        <a:t>0.053</a:t>
+                      </a:r>
+                      <a:endParaRPr lang="en-US" sz="1400" dirty="0">
+                        <a:latin typeface="Calibri" charset="0"/>
+                        <a:ea typeface="Calibri" charset="0"/>
+                        <a:cs typeface="Calibri" charset="0"/>
+                      </a:endParaRPr>
+                    </a:p>
+                  </a:txBody>
+                  <a:tcPr marL="91440" marR="91440" marT="45720" marB="45720" anchor="ctr">
+                    <a:lnL w="19050" cap="flat" cmpd="sng" algn="ctr">
+                      <a:solidFill>
+                        <a:srgbClr val="FFFFFF"/>
+                      </a:solidFill>
+                      <a:prstDash val="solid"/>
+                      <a:round/>
+                      <a:headEnd type="none" w="med" len="med"/>
+                      <a:tailEnd type="none" w="med" len="med"/>
+                    </a:lnL>
+                    <a:lnR w="19050" cap="flat" cmpd="sng" algn="ctr">
+                      <a:solidFill>
+                        <a:srgbClr val="FFFFFF"/>
+                      </a:solidFill>
+                      <a:prstDash val="solid"/>
+                      <a:round/>
+                      <a:headEnd type="none" w="med" len="med"/>
+                      <a:tailEnd type="none" w="med" len="med"/>
+                    </a:lnR>
+                    <a:lnT w="19050" cap="flat" cmpd="sng" algn="ctr">
+                      <a:solidFill>
+                        <a:srgbClr val="FFFFFF"/>
+                      </a:solidFill>
+                      <a:prstDash val="solid"/>
+                      <a:round/>
+                      <a:headEnd type="none" w="med" len="med"/>
+                      <a:tailEnd type="none" w="med" len="med"/>
+                    </a:lnT>
+                    <a:lnB w="19050" cap="flat" cmpd="sng" algn="ctr">
+                      <a:solidFill>
+                        <a:srgbClr val="FFFFFF"/>
+                      </a:solidFill>
+                      <a:prstDash val="solid"/>
+                      <a:round/>
+                      <a:headEnd type="none" w="med" len="med"/>
+                      <a:tailEnd type="none" w="med" len="med"/>
+                    </a:lnB>
+                    <a:solidFill>
+                      <a:srgbClr val="FFFFFF"/>
+                    </a:solidFill>
+                  </a:tcPr>
+                </a:tc>
+                <a:tc>
+                  <a:txBody>
+                    <a:bodyPr/>
+                    <a:lstStyle/>
+                    <a:p>
+                      <a:pPr algn="ctr" indent="0" marL="0">
+                        <a:buNone/>
+                      </a:pPr>
+                      <a:r>
+                        <a:rPr lang="en-US" sz="1400" dirty="0">
+                          <a:solidFill>
+                            <a:srgbClr val="1F1A33"/>
+                          </a:solidFill>
+                          <a:latin typeface="Calibri" pitchFamily="34" charset="0"/>
+                          <a:ea typeface="Calibri" pitchFamily="34" charset="-122"/>
+                          <a:cs typeface="Calibri" pitchFamily="34" charset="-120"/>
+                        </a:rPr>
+                        <a:t>86.3</a:t>
+                      </a:r>
+                      <a:endParaRPr lang="en-US" sz="1400" dirty="0">
+                        <a:latin typeface="Calibri" charset="0"/>
+                        <a:ea typeface="Calibri" charset="0"/>
+                        <a:cs typeface="Calibri" charset="0"/>
+                      </a:endParaRPr>
+                    </a:p>
+                  </a:txBody>
+                  <a:tcPr marL="91440" marR="91440" marT="45720" marB="45720" anchor="ctr">
+                    <a:lnL w="19050" cap="flat" cmpd="sng" algn="ctr">
+                      <a:solidFill>
+                        <a:srgbClr val="FFFFFF"/>
+                      </a:solidFill>
+                      <a:prstDash val="solid"/>
+                      <a:round/>
+                      <a:headEnd type="none" w="med" len="med"/>
+                      <a:tailEnd type="none" w="med" len="med"/>
+                    </a:lnL>
+                    <a:lnR w="19050" cap="flat" cmpd="sng" algn="ctr">
+                      <a:solidFill>
+                        <a:srgbClr val="FFFFFF"/>
+                      </a:solidFill>
+                      <a:prstDash val="solid"/>
+                      <a:round/>
+                      <a:headEnd type="none" w="med" len="med"/>
+                      <a:tailEnd type="none" w="med" len="med"/>
+                    </a:lnR>
+                    <a:lnT w="19050" cap="flat" cmpd="sng" algn="ctr">
+                      <a:solidFill>
+                        <a:srgbClr val="FFFFFF"/>
+                      </a:solidFill>
+                      <a:prstDash val="solid"/>
+                      <a:round/>
+                      <a:headEnd type="none" w="med" len="med"/>
+                      <a:tailEnd type="none" w="med" len="med"/>
+                    </a:lnT>
+                    <a:lnB w="19050" cap="flat" cmpd="sng" algn="ctr">
+                      <a:solidFill>
+                        <a:srgbClr val="FFFFFF"/>
+                      </a:solidFill>
+                      <a:prstDash val="solid"/>
+                      <a:round/>
+                      <a:headEnd type="none" w="med" len="med"/>
+                      <a:tailEnd type="none" w="med" len="med"/>
+                    </a:lnB>
+                    <a:solidFill>
+                      <a:srgbClr val="FFFFFF"/>
+                    </a:solidFill>
+                  </a:tcPr>
+                </a:tc>
+              </a:tr>
+              <a:tr h="530352">
+                <a:tc>
+                  <a:txBody>
+                    <a:bodyPr/>
+                    <a:lstStyle/>
+                    <a:p>
+                      <a:pPr algn="ctr" indent="0" marL="0">
+                        <a:buNone/>
+                      </a:pPr>
+                      <a:r>
+                        <a:rPr lang="en-US" sz="1400" b="1" dirty="0">
                           <a:solidFill>
                             <a:srgbClr val="1F1A33"/>
                           </a:solidFill>
@@ -25045,7 +25455,7 @@
                         </a:rPr>
                         <a:t>6</a:t>
                       </a:r>
-                      <a:endParaRPr lang="en-US" sz="1500" dirty="0">
+                      <a:endParaRPr lang="en-US" sz="1400" dirty="0">
                         <a:latin typeface="Calibri" charset="0"/>
                         <a:ea typeface="Calibri" charset="0"/>
                         <a:cs typeface="Calibri" charset="0"/>
@@ -25103,7 +25513,7 @@
                         <a:buNone/>
                       </a:pPr>
                       <a:r>
-                        <a:rPr lang="en-US" sz="1500" b="1" dirty="0">
+                        <a:rPr lang="en-US" sz="1400" b="1" dirty="0">
                           <a:solidFill>
                             <a:srgbClr val="6B4FA3"/>
                           </a:solidFill>
@@ -25113,7 +25523,7 @@
                         </a:rPr>
                         <a:t>0.022</a:t>
                       </a:r>
-                      <a:endParaRPr lang="en-US" sz="1500" dirty="0">
+                      <a:endParaRPr lang="en-US" sz="1400" dirty="0">
                         <a:latin typeface="Calibri" charset="0"/>
                         <a:ea typeface="Calibri" charset="0"/>
                         <a:cs typeface="Calibri" charset="0"/>
@@ -25171,7 +25581,7 @@
                         <a:buNone/>
                       </a:pPr>
                       <a:r>
-                        <a:rPr lang="en-US" sz="1500" dirty="0">
+                        <a:rPr lang="en-US" sz="1400" dirty="0">
                           <a:solidFill>
                             <a:srgbClr val="1F1A33"/>
                           </a:solidFill>
@@ -25181,7 +25591,7 @@
                         </a:rPr>
                         <a:t>90.2</a:t>
                       </a:r>
-                      <a:endParaRPr lang="en-US" sz="1500" dirty="0">
+                      <a:endParaRPr lang="en-US" sz="1400" dirty="0">
                         <a:latin typeface="Calibri" charset="0"/>
                         <a:ea typeface="Calibri" charset="0"/>
                         <a:cs typeface="Calibri" charset="0"/>
@@ -25239,7 +25649,7 @@
                         <a:buNone/>
                       </a:pPr>
                       <a:r>
-                        <a:rPr lang="en-US" sz="1500" b="1" dirty="0">
+                        <a:rPr lang="en-US" sz="1400" b="1" dirty="0">
                           <a:solidFill>
                             <a:srgbClr val="E0457B"/>
                           </a:solidFill>
@@ -25247,9 +25657,9 @@
                           <a:ea typeface="Calibri" pitchFamily="34" charset="-122"/>
                           <a:cs typeface="Calibri" pitchFamily="34" charset="-120"/>
                         </a:rPr>
-                        <a:t>0.084</a:t>
+                        <a:t>0.117</a:t>
                       </a:r>
-                      <a:endParaRPr lang="en-US" sz="1500" dirty="0">
+                      <a:endParaRPr lang="en-US" sz="1400" dirty="0">
                         <a:latin typeface="Calibri" charset="0"/>
                         <a:ea typeface="Calibri" charset="0"/>
                         <a:cs typeface="Calibri" charset="0"/>
@@ -25307,7 +25717,7 @@
                         <a:buNone/>
                       </a:pPr>
                       <a:r>
-                        <a:rPr lang="en-US" sz="1500" dirty="0">
+                        <a:rPr lang="en-US" sz="1400" dirty="0">
                           <a:solidFill>
                             <a:srgbClr val="1F1A33"/>
                           </a:solidFill>
@@ -25315,9 +25725,9 @@
                           <a:ea typeface="Calibri" pitchFamily="34" charset="-122"/>
                           <a:cs typeface="Calibri" pitchFamily="34" charset="-120"/>
                         </a:rPr>
-                        <a:t>70.4</a:t>
+                        <a:t>63.2</a:t>
                       </a:r>
-                      <a:endParaRPr lang="en-US" sz="1500" dirty="0">
+                      <a:endParaRPr lang="en-US" sz="1400" dirty="0">
                         <a:latin typeface="Calibri" charset="0"/>
                         <a:ea typeface="Calibri" charset="0"/>
                         <a:cs typeface="Calibri" charset="0"/>
@@ -25366,8 +25776,6 @@
                     </a:solidFill>
                   </a:tcPr>
                 </a:tc>
-              </a:tr>
-              <a:tr h="502920">
                 <a:tc>
                   <a:txBody>
                     <a:bodyPr/>
@@ -25377,7 +25785,145 @@
                         <a:buNone/>
                       </a:pPr>
                       <a:r>
-                        <a:rPr lang="en-US" sz="1500" b="1" dirty="0">
+                        <a:rPr lang="en-US" sz="1400" b="1" dirty="0">
+                          <a:solidFill>
+                            <a:srgbClr val="E0457B"/>
+                          </a:solidFill>
+                          <a:latin typeface="Calibri" pitchFamily="34" charset="0"/>
+                          <a:ea typeface="Calibri" pitchFamily="34" charset="-122"/>
+                          <a:cs typeface="Calibri" pitchFamily="34" charset="-120"/>
+                        </a:rPr>
+                        <a:t>0.058</a:t>
+                      </a:r>
+                      <a:endParaRPr lang="en-US" sz="1400" dirty="0">
+                        <a:latin typeface="Calibri" charset="0"/>
+                        <a:ea typeface="Calibri" charset="0"/>
+                        <a:cs typeface="Calibri" charset="0"/>
+                      </a:endParaRPr>
+                    </a:p>
+                  </a:txBody>
+                  <a:tcPr marL="91440" marR="91440" marT="45720" marB="45720" anchor="ctr">
+                    <a:lnL w="19050" cap="flat" cmpd="sng" algn="ctr">
+                      <a:solidFill>
+                        <a:srgbClr val="FFFFFF"/>
+                      </a:solidFill>
+                      <a:prstDash val="solid"/>
+                      <a:round/>
+                      <a:headEnd type="none" w="med" len="med"/>
+                      <a:tailEnd type="none" w="med" len="med"/>
+                    </a:lnL>
+                    <a:lnR w="19050" cap="flat" cmpd="sng" algn="ctr">
+                      <a:solidFill>
+                        <a:srgbClr val="FFFFFF"/>
+                      </a:solidFill>
+                      <a:prstDash val="solid"/>
+                      <a:round/>
+                      <a:headEnd type="none" w="med" len="med"/>
+                      <a:tailEnd type="none" w="med" len="med"/>
+                    </a:lnR>
+                    <a:lnT w="19050" cap="flat" cmpd="sng" algn="ctr">
+                      <a:solidFill>
+                        <a:srgbClr val="FFFFFF"/>
+                      </a:solidFill>
+                      <a:prstDash val="solid"/>
+                      <a:round/>
+                      <a:headEnd type="none" w="med" len="med"/>
+                      <a:tailEnd type="none" w="med" len="med"/>
+                    </a:lnT>
+                    <a:lnB w="19050" cap="flat" cmpd="sng" algn="ctr">
+                      <a:solidFill>
+                        <a:srgbClr val="FFFFFF"/>
+                      </a:solidFill>
+                      <a:prstDash val="solid"/>
+                      <a:round/>
+                      <a:headEnd type="none" w="med" len="med"/>
+                      <a:tailEnd type="none" w="med" len="med"/>
+                    </a:lnB>
+                    <a:solidFill>
+                      <a:srgbClr val="EAF6F4"/>
+                    </a:solidFill>
+                  </a:tcPr>
+                </a:tc>
+                <a:tc>
+                  <a:txBody>
+                    <a:bodyPr/>
+                    <a:lstStyle/>
+                    <a:p>
+                      <a:pPr algn="ctr" indent="0" marL="0">
+                        <a:buNone/>
+                      </a:pPr>
+                      <a:r>
+                        <a:rPr lang="en-US" sz="1400" dirty="0">
+                          <a:solidFill>
+                            <a:srgbClr val="1F1A33"/>
+                          </a:solidFill>
+                          <a:latin typeface="Calibri" pitchFamily="34" charset="0"/>
+                          <a:ea typeface="Calibri" pitchFamily="34" charset="-122"/>
+                          <a:cs typeface="Calibri" pitchFamily="34" charset="-120"/>
+                        </a:rPr>
+                        <a:t>77.5</a:t>
+                      </a:r>
+                      <a:endParaRPr lang="en-US" sz="1400" dirty="0">
+                        <a:latin typeface="Calibri" charset="0"/>
+                        <a:ea typeface="Calibri" charset="0"/>
+                        <a:cs typeface="Calibri" charset="0"/>
+                      </a:endParaRPr>
+                    </a:p>
+                  </a:txBody>
+                  <a:tcPr marL="91440" marR="91440" marT="45720" marB="45720" anchor="ctr">
+                    <a:lnL w="19050" cap="flat" cmpd="sng" algn="ctr">
+                      <a:solidFill>
+                        <a:srgbClr val="FFFFFF"/>
+                      </a:solidFill>
+                      <a:prstDash val="solid"/>
+                      <a:round/>
+                      <a:headEnd type="none" w="med" len="med"/>
+                      <a:tailEnd type="none" w="med" len="med"/>
+                    </a:lnL>
+                    <a:lnR w="19050" cap="flat" cmpd="sng" algn="ctr">
+                      <a:solidFill>
+                        <a:srgbClr val="FFFFFF"/>
+                      </a:solidFill>
+                      <a:prstDash val="solid"/>
+                      <a:round/>
+                      <a:headEnd type="none" w="med" len="med"/>
+                      <a:tailEnd type="none" w="med" len="med"/>
+                    </a:lnR>
+                    <a:lnT w="19050" cap="flat" cmpd="sng" algn="ctr">
+                      <a:solidFill>
+                        <a:srgbClr val="FFFFFF"/>
+                      </a:solidFill>
+                      <a:prstDash val="solid"/>
+                      <a:round/>
+                      <a:headEnd type="none" w="med" len="med"/>
+                      <a:tailEnd type="none" w="med" len="med"/>
+                    </a:lnT>
+                    <a:lnB w="19050" cap="flat" cmpd="sng" algn="ctr">
+                      <a:solidFill>
+                        <a:srgbClr val="FFFFFF"/>
+                      </a:solidFill>
+                      <a:prstDash val="solid"/>
+                      <a:round/>
+                      <a:headEnd type="none" w="med" len="med"/>
+                      <a:tailEnd type="none" w="med" len="med"/>
+                    </a:lnB>
+                    <a:solidFill>
+                      <a:srgbClr val="EAF6F4"/>
+                    </a:solidFill>
+                  </a:tcPr>
+                </a:tc>
+              </a:tr>
+              <a:tr h="530352">
+                <a:tc>
+                  <a:txBody>
+                    <a:bodyPr/>
+                    <a:lstStyle/>
+                    <a:p>
+                      <a:pPr algn="ctr" indent="0" marL="0">
+                        <a:buNone/>
+                      </a:pPr>
+                      <a:r>
+                        <a:rPr lang="en-US" sz="1400" b="1" dirty="0">
                           <a:solidFill>
                             <a:srgbClr val="1F1A33"/>
                           </a:solidFill>
@@ -25387,7 +25933,7 @@
                         </a:rPr>
                         <a:t>8</a:t>
                       </a:r>
-                      <a:endParaRPr lang="en-US" sz="1500" dirty="0">
+                      <a:endParaRPr lang="en-US" sz="1400" dirty="0">
                         <a:latin typeface="Calibri" charset="0"/>
                         <a:ea typeface="Calibri" charset="0"/>
                         <a:cs typeface="Calibri" charset="0"/>
@@ -25445,7 +25991,7 @@
                         <a:buNone/>
                       </a:pPr>
                       <a:r>
-                        <a:rPr lang="en-US" sz="1500" b="1" dirty="0">
+                        <a:rPr lang="en-US" sz="1400" b="1" dirty="0">
                           <a:solidFill>
                             <a:srgbClr val="6B4FA3"/>
                           </a:solidFill>
@@ -25455,7 +26001,7 @@
                         </a:rPr>
                         <a:t>0.038</a:t>
                       </a:r>
-                      <a:endParaRPr lang="en-US" sz="1500" dirty="0">
+                      <a:endParaRPr lang="en-US" sz="1400" dirty="0">
                         <a:latin typeface="Calibri" charset="0"/>
                         <a:ea typeface="Calibri" charset="0"/>
                         <a:cs typeface="Calibri" charset="0"/>
@@ -25513,7 +26059,7 @@
                         <a:buNone/>
                       </a:pPr>
                       <a:r>
-                        <a:rPr lang="en-US" sz="1500" dirty="0">
+                        <a:rPr lang="en-US" sz="1400" dirty="0">
                           <a:solidFill>
                             <a:srgbClr val="1F1A33"/>
                           </a:solidFill>
@@ -25523,7 +26069,7 @@
                         </a:rPr>
                         <a:t>78.8</a:t>
                       </a:r>
-                      <a:endParaRPr lang="en-US" sz="1500" dirty="0">
+                      <a:endParaRPr lang="en-US" sz="1400" dirty="0">
                         <a:latin typeface="Calibri" charset="0"/>
                         <a:ea typeface="Calibri" charset="0"/>
                         <a:cs typeface="Calibri" charset="0"/>
@@ -25581,7 +26127,7 @@
                         <a:buNone/>
                       </a:pPr>
                       <a:r>
-                        <a:rPr lang="en-US" sz="1500" b="1" dirty="0">
+                        <a:rPr lang="en-US" sz="1400" b="1" dirty="0">
                           <a:solidFill>
                             <a:srgbClr val="E0457B"/>
                           </a:solidFill>
@@ -25589,9 +26135,9 @@
                           <a:ea typeface="Calibri" pitchFamily="34" charset="-122"/>
                           <a:cs typeface="Calibri" pitchFamily="34" charset="-120"/>
                         </a:rPr>
-                        <a:t>0.110</a:t>
+                        <a:t>0.143</a:t>
                       </a:r>
-                      <a:endParaRPr lang="en-US" sz="1500" dirty="0">
+                      <a:endParaRPr lang="en-US" sz="1400" dirty="0">
                         <a:latin typeface="Calibri" charset="0"/>
                         <a:ea typeface="Calibri" charset="0"/>
                         <a:cs typeface="Calibri" charset="0"/>
@@ -25649,7 +26195,7 @@
                         <a:buNone/>
                       </a:pPr>
                       <a:r>
-                        <a:rPr lang="en-US" sz="1500" dirty="0">
+                        <a:rPr lang="en-US" sz="1400" dirty="0">
                           <a:solidFill>
                             <a:srgbClr val="1F1A33"/>
                           </a:solidFill>
@@ -25657,9 +26203,9 @@
                           <a:ea typeface="Calibri" pitchFamily="34" charset="-122"/>
                           <a:cs typeface="Calibri" pitchFamily="34" charset="-120"/>
                         </a:rPr>
-                        <a:t>56.5</a:t>
+                        <a:t>50.1</a:t>
                       </a:r>
-                      <a:endParaRPr lang="en-US" sz="1500" dirty="0">
+                      <a:endParaRPr lang="en-US" sz="1400" dirty="0">
                         <a:latin typeface="Calibri" charset="0"/>
                         <a:ea typeface="Calibri" charset="0"/>
                         <a:cs typeface="Calibri" charset="0"/>
@@ -25708,8 +26254,6 @@
                     </a:solidFill>
                   </a:tcPr>
                 </a:tc>
-              </a:tr>
-              <a:tr h="502920">
                 <a:tc>
                   <a:txBody>
                     <a:bodyPr/>
@@ -25719,7 +26263,145 @@
                         <a:buNone/>
                       </a:pPr>
                       <a:r>
-                        <a:rPr lang="en-US" sz="1500" b="1" dirty="0">
+                        <a:rPr lang="en-US" sz="1400" b="1" dirty="0">
+                          <a:solidFill>
+                            <a:srgbClr val="E0457B"/>
+                          </a:solidFill>
+                          <a:latin typeface="Calibri" pitchFamily="34" charset="0"/>
+                          <a:ea typeface="Calibri" pitchFamily="34" charset="-122"/>
+                          <a:cs typeface="Calibri" pitchFamily="34" charset="-120"/>
+                        </a:rPr>
+                        <a:t>0.084</a:t>
+                      </a:r>
+                      <a:endParaRPr lang="en-US" sz="1400" dirty="0">
+                        <a:latin typeface="Calibri" charset="0"/>
+                        <a:ea typeface="Calibri" charset="0"/>
+                        <a:cs typeface="Calibri" charset="0"/>
+                      </a:endParaRPr>
+                    </a:p>
+                  </a:txBody>
+                  <a:tcPr marL="91440" marR="91440" marT="45720" marB="45720" anchor="ctr">
+                    <a:lnL w="19050" cap="flat" cmpd="sng" algn="ctr">
+                      <a:solidFill>
+                        <a:srgbClr val="FFFFFF"/>
+                      </a:solidFill>
+                      <a:prstDash val="solid"/>
+                      <a:round/>
+                      <a:headEnd type="none" w="med" len="med"/>
+                      <a:tailEnd type="none" w="med" len="med"/>
+                    </a:lnL>
+                    <a:lnR w="19050" cap="flat" cmpd="sng" algn="ctr">
+                      <a:solidFill>
+                        <a:srgbClr val="FFFFFF"/>
+                      </a:solidFill>
+                      <a:prstDash val="solid"/>
+                      <a:round/>
+                      <a:headEnd type="none" w="med" len="med"/>
+                      <a:tailEnd type="none" w="med" len="med"/>
+                    </a:lnR>
+                    <a:lnT w="19050" cap="flat" cmpd="sng" algn="ctr">
+                      <a:solidFill>
+                        <a:srgbClr val="FFFFFF"/>
+                      </a:solidFill>
+                      <a:prstDash val="solid"/>
+                      <a:round/>
+                      <a:headEnd type="none" w="med" len="med"/>
+                      <a:tailEnd type="none" w="med" len="med"/>
+                    </a:lnT>
+                    <a:lnB w="19050" cap="flat" cmpd="sng" algn="ctr">
+                      <a:solidFill>
+                        <a:srgbClr val="FFFFFF"/>
+                      </a:solidFill>
+                      <a:prstDash val="solid"/>
+                      <a:round/>
+                      <a:headEnd type="none" w="med" len="med"/>
+                      <a:tailEnd type="none" w="med" len="med"/>
+                    </a:lnB>
+                    <a:solidFill>
+                      <a:srgbClr val="FFFFFF"/>
+                    </a:solidFill>
+                  </a:tcPr>
+                </a:tc>
+                <a:tc>
+                  <a:txBody>
+                    <a:bodyPr/>
+                    <a:lstStyle/>
+                    <a:p>
+                      <a:pPr algn="ctr" indent="0" marL="0">
+                        <a:buNone/>
+                      </a:pPr>
+                      <a:r>
+                        <a:rPr lang="en-US" sz="1400" dirty="0">
+                          <a:solidFill>
+                            <a:srgbClr val="1F1A33"/>
+                          </a:solidFill>
+                          <a:latin typeface="Calibri" pitchFamily="34" charset="0"/>
+                          <a:ea typeface="Calibri" pitchFamily="34" charset="-122"/>
+                          <a:cs typeface="Calibri" pitchFamily="34" charset="-120"/>
+                        </a:rPr>
+                        <a:t>63.0</a:t>
+                      </a:r>
+                      <a:endParaRPr lang="en-US" sz="1400" dirty="0">
+                        <a:latin typeface="Calibri" charset="0"/>
+                        <a:ea typeface="Calibri" charset="0"/>
+                        <a:cs typeface="Calibri" charset="0"/>
+                      </a:endParaRPr>
+                    </a:p>
+                  </a:txBody>
+                  <a:tcPr marL="91440" marR="91440" marT="45720" marB="45720" anchor="ctr">
+                    <a:lnL w="19050" cap="flat" cmpd="sng" algn="ctr">
+                      <a:solidFill>
+                        <a:srgbClr val="FFFFFF"/>
+                      </a:solidFill>
+                      <a:prstDash val="solid"/>
+                      <a:round/>
+                      <a:headEnd type="none" w="med" len="med"/>
+                      <a:tailEnd type="none" w="med" len="med"/>
+                    </a:lnL>
+                    <a:lnR w="19050" cap="flat" cmpd="sng" algn="ctr">
+                      <a:solidFill>
+                        <a:srgbClr val="FFFFFF"/>
+                      </a:solidFill>
+                      <a:prstDash val="solid"/>
+                      <a:round/>
+                      <a:headEnd type="none" w="med" len="med"/>
+                      <a:tailEnd type="none" w="med" len="med"/>
+                    </a:lnR>
+                    <a:lnT w="19050" cap="flat" cmpd="sng" algn="ctr">
+                      <a:solidFill>
+                        <a:srgbClr val="FFFFFF"/>
+                      </a:solidFill>
+                      <a:prstDash val="solid"/>
+                      <a:round/>
+                      <a:headEnd type="none" w="med" len="med"/>
+                      <a:tailEnd type="none" w="med" len="med"/>
+                    </a:lnT>
+                    <a:lnB w="19050" cap="flat" cmpd="sng" algn="ctr">
+                      <a:solidFill>
+                        <a:srgbClr val="FFFFFF"/>
+                      </a:solidFill>
+                      <a:prstDash val="solid"/>
+                      <a:round/>
+                      <a:headEnd type="none" w="med" len="med"/>
+                      <a:tailEnd type="none" w="med" len="med"/>
+                    </a:lnB>
+                    <a:solidFill>
+                      <a:srgbClr val="FFFFFF"/>
+                    </a:solidFill>
+                  </a:tcPr>
+                </a:tc>
+              </a:tr>
+              <a:tr h="530352">
+                <a:tc>
+                  <a:txBody>
+                    <a:bodyPr/>
+                    <a:lstStyle/>
+                    <a:p>
+                      <a:pPr algn="ctr" indent="0" marL="0">
+                        <a:buNone/>
+                      </a:pPr>
+                      <a:r>
+                        <a:rPr lang="en-US" sz="1400" b="1" dirty="0">
                           <a:solidFill>
                             <a:srgbClr val="1F1A33"/>
                           </a:solidFill>
@@ -25729,7 +26411,7 @@
                         </a:rPr>
                         <a:t>10</a:t>
                       </a:r>
-                      <a:endParaRPr lang="en-US" sz="1500" dirty="0">
+                      <a:endParaRPr lang="en-US" sz="1400" dirty="0">
                         <a:latin typeface="Calibri" charset="0"/>
                         <a:ea typeface="Calibri" charset="0"/>
                         <a:cs typeface="Calibri" charset="0"/>
@@ -25787,7 +26469,7 @@
                         <a:buNone/>
                       </a:pPr>
                       <a:r>
-                        <a:rPr lang="en-US" sz="1500" b="1" dirty="0">
+                        <a:rPr lang="en-US" sz="1400" b="1" dirty="0">
                           <a:solidFill>
                             <a:srgbClr val="6B4FA3"/>
                           </a:solidFill>
@@ -25797,7 +26479,7 @@
                         </a:rPr>
                         <a:t>0.040</a:t>
                       </a:r>
-                      <a:endParaRPr lang="en-US" sz="1500" dirty="0">
+                      <a:endParaRPr lang="en-US" sz="1400" dirty="0">
                         <a:latin typeface="Calibri" charset="0"/>
                         <a:ea typeface="Calibri" charset="0"/>
                         <a:cs typeface="Calibri" charset="0"/>
@@ -25855,7 +26537,7 @@
                         <a:buNone/>
                       </a:pPr>
                       <a:r>
-                        <a:rPr lang="en-US" sz="1500" dirty="0">
+                        <a:rPr lang="en-US" sz="1400" dirty="0">
                           <a:solidFill>
                             <a:srgbClr val="1F1A33"/>
                           </a:solidFill>
@@ -25865,7 +26547,7 @@
                         </a:rPr>
                         <a:t>73.6</a:t>
                       </a:r>
-                      <a:endParaRPr lang="en-US" sz="1500" dirty="0">
+                      <a:endParaRPr lang="en-US" sz="1400" dirty="0">
                         <a:latin typeface="Calibri" charset="0"/>
                         <a:ea typeface="Calibri" charset="0"/>
                         <a:cs typeface="Calibri" charset="0"/>
@@ -25923,7 +26605,7 @@
                         <a:buNone/>
                       </a:pPr>
                       <a:r>
-                        <a:rPr lang="en-US" sz="1500" b="1" dirty="0">
+                        <a:rPr lang="en-US" sz="1400" b="1" dirty="0">
                           <a:solidFill>
                             <a:srgbClr val="E0457B"/>
                           </a:solidFill>
@@ -25931,9 +26613,9 @@
                           <a:ea typeface="Calibri" pitchFamily="34" charset="-122"/>
                           <a:cs typeface="Calibri" pitchFamily="34" charset="-120"/>
                         </a:rPr>
-                        <a:t>0.109</a:t>
+                        <a:t>0.142</a:t>
                       </a:r>
-                      <a:endParaRPr lang="en-US" sz="1500" dirty="0">
+                      <a:endParaRPr lang="en-US" sz="1400" dirty="0">
                         <a:latin typeface="Calibri" charset="0"/>
                         <a:ea typeface="Calibri" charset="0"/>
                         <a:cs typeface="Calibri" charset="0"/>
@@ -25991,7 +26673,7 @@
                         <a:buNone/>
                       </a:pPr>
                       <a:r>
-                        <a:rPr lang="en-US" sz="1500" dirty="0">
+                        <a:rPr lang="en-US" sz="1400" dirty="0">
                           <a:solidFill>
                             <a:srgbClr val="1F1A33"/>
                           </a:solidFill>
@@ -25999,9 +26681,9 @@
                           <a:ea typeface="Calibri" pitchFamily="34" charset="-122"/>
                           <a:cs typeface="Calibri" pitchFamily="34" charset="-120"/>
                         </a:rPr>
-                        <a:t>50.6</a:t>
+                        <a:t>43.9</a:t>
                       </a:r>
-                      <a:endParaRPr lang="en-US" sz="1500" dirty="0">
+                      <a:endParaRPr lang="en-US" sz="1400" dirty="0">
                         <a:latin typeface="Calibri" charset="0"/>
                         <a:ea typeface="Calibri" charset="0"/>
                         <a:cs typeface="Calibri" charset="0"/>
@@ -26050,8 +26732,6 @@
                     </a:solidFill>
                   </a:tcPr>
                 </a:tc>
-              </a:tr>
-              <a:tr h="502920">
                 <a:tc>
                   <a:txBody>
                     <a:bodyPr/>
@@ -26061,7 +26741,145 @@
                         <a:buNone/>
                       </a:pPr>
                       <a:r>
-                        <a:rPr lang="en-US" sz="1500" b="1" dirty="0">
+                        <a:rPr lang="en-US" sz="1400" b="1" dirty="0">
+                          <a:solidFill>
+                            <a:srgbClr val="E0457B"/>
+                          </a:solidFill>
+                          <a:latin typeface="Calibri" pitchFamily="34" charset="0"/>
+                          <a:ea typeface="Calibri" pitchFamily="34" charset="-122"/>
+                          <a:cs typeface="Calibri" pitchFamily="34" charset="-120"/>
+                        </a:rPr>
+                        <a:t>0.083</a:t>
+                      </a:r>
+                      <a:endParaRPr lang="en-US" sz="1400" dirty="0">
+                        <a:latin typeface="Calibri" charset="0"/>
+                        <a:ea typeface="Calibri" charset="0"/>
+                        <a:cs typeface="Calibri" charset="0"/>
+                      </a:endParaRPr>
+                    </a:p>
+                  </a:txBody>
+                  <a:tcPr marL="91440" marR="91440" marT="45720" marB="45720" anchor="ctr">
+                    <a:lnL w="19050" cap="flat" cmpd="sng" algn="ctr">
+                      <a:solidFill>
+                        <a:srgbClr val="FFFFFF"/>
+                      </a:solidFill>
+                      <a:prstDash val="solid"/>
+                      <a:round/>
+                      <a:headEnd type="none" w="med" len="med"/>
+                      <a:tailEnd type="none" w="med" len="med"/>
+                    </a:lnL>
+                    <a:lnR w="19050" cap="flat" cmpd="sng" algn="ctr">
+                      <a:solidFill>
+                        <a:srgbClr val="FFFFFF"/>
+                      </a:solidFill>
+                      <a:prstDash val="solid"/>
+                      <a:round/>
+                      <a:headEnd type="none" w="med" len="med"/>
+                      <a:tailEnd type="none" w="med" len="med"/>
+                    </a:lnR>
+                    <a:lnT w="19050" cap="flat" cmpd="sng" algn="ctr">
+                      <a:solidFill>
+                        <a:srgbClr val="FFFFFF"/>
+                      </a:solidFill>
+                      <a:prstDash val="solid"/>
+                      <a:round/>
+                      <a:headEnd type="none" w="med" len="med"/>
+                      <a:tailEnd type="none" w="med" len="med"/>
+                    </a:lnT>
+                    <a:lnB w="19050" cap="flat" cmpd="sng" algn="ctr">
+                      <a:solidFill>
+                        <a:srgbClr val="FFFFFF"/>
+                      </a:solidFill>
+                      <a:prstDash val="solid"/>
+                      <a:round/>
+                      <a:headEnd type="none" w="med" len="med"/>
+                      <a:tailEnd type="none" w="med" len="med"/>
+                    </a:lnB>
+                    <a:solidFill>
+                      <a:srgbClr val="EAF6F4"/>
+                    </a:solidFill>
+                  </a:tcPr>
+                </a:tc>
+                <a:tc>
+                  <a:txBody>
+                    <a:bodyPr/>
+                    <a:lstStyle/>
+                    <a:p>
+                      <a:pPr algn="ctr" indent="0" marL="0">
+                        <a:buNone/>
+                      </a:pPr>
+                      <a:r>
+                        <a:rPr lang="en-US" sz="1400" dirty="0">
+                          <a:solidFill>
+                            <a:srgbClr val="1F1A33"/>
+                          </a:solidFill>
+                          <a:latin typeface="Calibri" pitchFamily="34" charset="0"/>
+                          <a:ea typeface="Calibri" pitchFamily="34" charset="-122"/>
+                          <a:cs typeface="Calibri" pitchFamily="34" charset="-120"/>
+                        </a:rPr>
+                        <a:t>57.2</a:t>
+                      </a:r>
+                      <a:endParaRPr lang="en-US" sz="1400" dirty="0">
+                        <a:latin typeface="Calibri" charset="0"/>
+                        <a:ea typeface="Calibri" charset="0"/>
+                        <a:cs typeface="Calibri" charset="0"/>
+                      </a:endParaRPr>
+                    </a:p>
+                  </a:txBody>
+                  <a:tcPr marL="91440" marR="91440" marT="45720" marB="45720" anchor="ctr">
+                    <a:lnL w="19050" cap="flat" cmpd="sng" algn="ctr">
+                      <a:solidFill>
+                        <a:srgbClr val="FFFFFF"/>
+                      </a:solidFill>
+                      <a:prstDash val="solid"/>
+                      <a:round/>
+                      <a:headEnd type="none" w="med" len="med"/>
+                      <a:tailEnd type="none" w="med" len="med"/>
+                    </a:lnL>
+                    <a:lnR w="19050" cap="flat" cmpd="sng" algn="ctr">
+                      <a:solidFill>
+                        <a:srgbClr val="FFFFFF"/>
+                      </a:solidFill>
+                      <a:prstDash val="solid"/>
+                      <a:round/>
+                      <a:headEnd type="none" w="med" len="med"/>
+                      <a:tailEnd type="none" w="med" len="med"/>
+                    </a:lnR>
+                    <a:lnT w="19050" cap="flat" cmpd="sng" algn="ctr">
+                      <a:solidFill>
+                        <a:srgbClr val="FFFFFF"/>
+                      </a:solidFill>
+                      <a:prstDash val="solid"/>
+                      <a:round/>
+                      <a:headEnd type="none" w="med" len="med"/>
+                      <a:tailEnd type="none" w="med" len="med"/>
+                    </a:lnT>
+                    <a:lnB w="19050" cap="flat" cmpd="sng" algn="ctr">
+                      <a:solidFill>
+                        <a:srgbClr val="FFFFFF"/>
+                      </a:solidFill>
+                      <a:prstDash val="solid"/>
+                      <a:round/>
+                      <a:headEnd type="none" w="med" len="med"/>
+                      <a:tailEnd type="none" w="med" len="med"/>
+                    </a:lnB>
+                    <a:solidFill>
+                      <a:srgbClr val="EAF6F4"/>
+                    </a:solidFill>
+                  </a:tcPr>
+                </a:tc>
+              </a:tr>
+              <a:tr h="530352">
+                <a:tc>
+                  <a:txBody>
+                    <a:bodyPr/>
+                    <a:lstStyle/>
+                    <a:p>
+                      <a:pPr algn="ctr" indent="0" marL="0">
+                        <a:buNone/>
+                      </a:pPr>
+                      <a:r>
+                        <a:rPr lang="en-US" sz="1400" b="1" dirty="0">
                           <a:solidFill>
                             <a:srgbClr val="1F1A33"/>
                           </a:solidFill>
@@ -26071,7 +26889,7 @@
                         </a:rPr>
                         <a:t>12</a:t>
                       </a:r>
-                      <a:endParaRPr lang="en-US" sz="1500" dirty="0">
+                      <a:endParaRPr lang="en-US" sz="1400" dirty="0">
                         <a:latin typeface="Calibri" charset="0"/>
                         <a:ea typeface="Calibri" charset="0"/>
                         <a:cs typeface="Calibri" charset="0"/>
@@ -26129,7 +26947,7 @@
                         <a:buNone/>
                       </a:pPr>
                       <a:r>
-                        <a:rPr lang="en-US" sz="1500" b="1" dirty="0">
+                        <a:rPr lang="en-US" sz="1400" b="1" dirty="0">
                           <a:solidFill>
                             <a:srgbClr val="6B4FA3"/>
                           </a:solidFill>
@@ -26139,7 +26957,7 @@
                         </a:rPr>
                         <a:t>0.042</a:t>
                       </a:r>
-                      <a:endParaRPr lang="en-US" sz="1500" dirty="0">
+                      <a:endParaRPr lang="en-US" sz="1400" dirty="0">
                         <a:latin typeface="Calibri" charset="0"/>
                         <a:ea typeface="Calibri" charset="0"/>
                         <a:cs typeface="Calibri" charset="0"/>
@@ -26197,7 +27015,7 @@
                         <a:buNone/>
                       </a:pPr>
                       <a:r>
-                        <a:rPr lang="en-US" sz="1500" dirty="0">
+                        <a:rPr lang="en-US" sz="1400" dirty="0">
                           <a:solidFill>
                             <a:srgbClr val="1F1A33"/>
                           </a:solidFill>
@@ -26207,7 +27025,7 @@
                         </a:rPr>
                         <a:t>68.6</a:t>
                       </a:r>
-                      <a:endParaRPr lang="en-US" sz="1500" dirty="0">
+                      <a:endParaRPr lang="en-US" sz="1400" dirty="0">
                         <a:latin typeface="Calibri" charset="0"/>
                         <a:ea typeface="Calibri" charset="0"/>
                         <a:cs typeface="Calibri" charset="0"/>
@@ -26265,7 +27083,7 @@
                         <a:buNone/>
                       </a:pPr>
                       <a:r>
-                        <a:rPr lang="en-US" sz="1500" b="1" dirty="0">
+                        <a:rPr lang="en-US" sz="1400" b="1" dirty="0">
                           <a:solidFill>
                             <a:srgbClr val="E0457B"/>
                           </a:solidFill>
@@ -26273,9 +27091,9 @@
                           <a:ea typeface="Calibri" pitchFamily="34" charset="-122"/>
                           <a:cs typeface="Calibri" pitchFamily="34" charset="-120"/>
                         </a:rPr>
-                        <a:t>0.107</a:t>
+                        <a:t>0.140</a:t>
                       </a:r>
-                      <a:endParaRPr lang="en-US" sz="1500" dirty="0">
+                      <a:endParaRPr lang="en-US" sz="1400" dirty="0">
                         <a:latin typeface="Calibri" charset="0"/>
                         <a:ea typeface="Calibri" charset="0"/>
                         <a:cs typeface="Calibri" charset="0"/>
@@ -26333,7 +27151,7 @@
                         <a:buNone/>
                       </a:pPr>
                       <a:r>
-                        <a:rPr lang="en-US" sz="1500" dirty="0">
+                        <a:rPr lang="en-US" sz="1400" dirty="0">
                           <a:solidFill>
                             <a:srgbClr val="1F1A33"/>
                           </a:solidFill>
@@ -26341,9 +27159,9 @@
                           <a:ea typeface="Calibri" pitchFamily="34" charset="-122"/>
                           <a:cs typeface="Calibri" pitchFamily="34" charset="-120"/>
                         </a:rPr>
-                        <a:t>45.9</a:t>
+                        <a:t>39.3</a:t>
                       </a:r>
-                      <a:endParaRPr lang="en-US" sz="1500" dirty="0">
+                      <a:endParaRPr lang="en-US" sz="1400" dirty="0">
                         <a:latin typeface="Calibri" charset="0"/>
                         <a:ea typeface="Calibri" charset="0"/>
                         <a:cs typeface="Calibri" charset="0"/>
@@ -26392,8 +27210,6 @@
                     </a:solidFill>
                   </a:tcPr>
                 </a:tc>
-              </a:tr>
-              <a:tr h="502920">
                 <a:tc>
                   <a:txBody>
                     <a:bodyPr/>
@@ -26403,7 +27219,145 @@
                         <a:buNone/>
                       </a:pPr>
                       <a:r>
-                        <a:rPr lang="en-US" sz="1500" b="1" dirty="0">
+                        <a:rPr lang="en-US" sz="1400" b="1" dirty="0">
+                          <a:solidFill>
+                            <a:srgbClr val="E0457B"/>
+                          </a:solidFill>
+                          <a:latin typeface="Calibri" pitchFamily="34" charset="0"/>
+                          <a:ea typeface="Calibri" pitchFamily="34" charset="-122"/>
+                          <a:cs typeface="Calibri" pitchFamily="34" charset="-120"/>
+                        </a:rPr>
+                        <a:t>0.082</a:t>
+                      </a:r>
+                      <a:endParaRPr lang="en-US" sz="1400" dirty="0">
+                        <a:latin typeface="Calibri" charset="0"/>
+                        <a:ea typeface="Calibri" charset="0"/>
+                        <a:cs typeface="Calibri" charset="0"/>
+                      </a:endParaRPr>
+                    </a:p>
+                  </a:txBody>
+                  <a:tcPr marL="91440" marR="91440" marT="45720" marB="45720" anchor="ctr">
+                    <a:lnL w="19050" cap="flat" cmpd="sng" algn="ctr">
+                      <a:solidFill>
+                        <a:srgbClr val="FFFFFF"/>
+                      </a:solidFill>
+                      <a:prstDash val="solid"/>
+                      <a:round/>
+                      <a:headEnd type="none" w="med" len="med"/>
+                      <a:tailEnd type="none" w="med" len="med"/>
+                    </a:lnL>
+                    <a:lnR w="19050" cap="flat" cmpd="sng" algn="ctr">
+                      <a:solidFill>
+                        <a:srgbClr val="FFFFFF"/>
+                      </a:solidFill>
+                      <a:prstDash val="solid"/>
+                      <a:round/>
+                      <a:headEnd type="none" w="med" len="med"/>
+                      <a:tailEnd type="none" w="med" len="med"/>
+                    </a:lnR>
+                    <a:lnT w="19050" cap="flat" cmpd="sng" algn="ctr">
+                      <a:solidFill>
+                        <a:srgbClr val="FFFFFF"/>
+                      </a:solidFill>
+                      <a:prstDash val="solid"/>
+                      <a:round/>
+                      <a:headEnd type="none" w="med" len="med"/>
+                      <a:tailEnd type="none" w="med" len="med"/>
+                    </a:lnT>
+                    <a:lnB w="19050" cap="flat" cmpd="sng" algn="ctr">
+                      <a:solidFill>
+                        <a:srgbClr val="FFFFFF"/>
+                      </a:solidFill>
+                      <a:prstDash val="solid"/>
+                      <a:round/>
+                      <a:headEnd type="none" w="med" len="med"/>
+                      <a:tailEnd type="none" w="med" len="med"/>
+                    </a:lnB>
+                    <a:solidFill>
+                      <a:srgbClr val="FFFFFF"/>
+                    </a:solidFill>
+                  </a:tcPr>
+                </a:tc>
+                <a:tc>
+                  <a:txBody>
+                    <a:bodyPr/>
+                    <a:lstStyle/>
+                    <a:p>
+                      <a:pPr algn="ctr" indent="0" marL="0">
+                        <a:buNone/>
+                      </a:pPr>
+                      <a:r>
+                        <a:rPr lang="en-US" sz="1400" dirty="0">
+                          <a:solidFill>
+                            <a:srgbClr val="1F1A33"/>
+                          </a:solidFill>
+                          <a:latin typeface="Calibri" pitchFamily="34" charset="0"/>
+                          <a:ea typeface="Calibri" pitchFamily="34" charset="-122"/>
+                          <a:cs typeface="Calibri" pitchFamily="34" charset="-120"/>
+                        </a:rPr>
+                        <a:t>52.4</a:t>
+                      </a:r>
+                      <a:endParaRPr lang="en-US" sz="1400" dirty="0">
+                        <a:latin typeface="Calibri" charset="0"/>
+                        <a:ea typeface="Calibri" charset="0"/>
+                        <a:cs typeface="Calibri" charset="0"/>
+                      </a:endParaRPr>
+                    </a:p>
+                  </a:txBody>
+                  <a:tcPr marL="91440" marR="91440" marT="45720" marB="45720" anchor="ctr">
+                    <a:lnL w="19050" cap="flat" cmpd="sng" algn="ctr">
+                      <a:solidFill>
+                        <a:srgbClr val="FFFFFF"/>
+                      </a:solidFill>
+                      <a:prstDash val="solid"/>
+                      <a:round/>
+                      <a:headEnd type="none" w="med" len="med"/>
+                      <a:tailEnd type="none" w="med" len="med"/>
+                    </a:lnL>
+                    <a:lnR w="19050" cap="flat" cmpd="sng" algn="ctr">
+                      <a:solidFill>
+                        <a:srgbClr val="FFFFFF"/>
+                      </a:solidFill>
+                      <a:prstDash val="solid"/>
+                      <a:round/>
+                      <a:headEnd type="none" w="med" len="med"/>
+                      <a:tailEnd type="none" w="med" len="med"/>
+                    </a:lnR>
+                    <a:lnT w="19050" cap="flat" cmpd="sng" algn="ctr">
+                      <a:solidFill>
+                        <a:srgbClr val="FFFFFF"/>
+                      </a:solidFill>
+                      <a:prstDash val="solid"/>
+                      <a:round/>
+                      <a:headEnd type="none" w="med" len="med"/>
+                      <a:tailEnd type="none" w="med" len="med"/>
+                    </a:lnT>
+                    <a:lnB w="19050" cap="flat" cmpd="sng" algn="ctr">
+                      <a:solidFill>
+                        <a:srgbClr val="FFFFFF"/>
+                      </a:solidFill>
+                      <a:prstDash val="solid"/>
+                      <a:round/>
+                      <a:headEnd type="none" w="med" len="med"/>
+                      <a:tailEnd type="none" w="med" len="med"/>
+                    </a:lnB>
+                    <a:solidFill>
+                      <a:srgbClr val="FFFFFF"/>
+                    </a:solidFill>
+                  </a:tcPr>
+                </a:tc>
+              </a:tr>
+              <a:tr h="530352">
+                <a:tc>
+                  <a:txBody>
+                    <a:bodyPr/>
+                    <a:lstStyle/>
+                    <a:p>
+                      <a:pPr algn="ctr" indent="0" marL="0">
+                        <a:buNone/>
+                      </a:pPr>
+                      <a:r>
+                        <a:rPr lang="en-US" sz="1400" b="1" dirty="0">
                           <a:solidFill>
                             <a:srgbClr val="1F1A33"/>
                           </a:solidFill>
@@ -26413,7 +27367,7 @@
                         </a:rPr>
                         <a:t>14</a:t>
                       </a:r>
-                      <a:endParaRPr lang="en-US" sz="1500" dirty="0">
+                      <a:endParaRPr lang="en-US" sz="1400" dirty="0">
                         <a:latin typeface="Calibri" charset="0"/>
                         <a:ea typeface="Calibri" charset="0"/>
                         <a:cs typeface="Calibri" charset="0"/>
@@ -26471,7 +27425,7 @@
                         <a:buNone/>
                       </a:pPr>
                       <a:r>
-                        <a:rPr lang="en-US" sz="1500" b="1" dirty="0">
+                        <a:rPr lang="en-US" sz="1400" b="1" dirty="0">
                           <a:solidFill>
                             <a:srgbClr val="6B4FA3"/>
                           </a:solidFill>
@@ -26481,7 +27435,7 @@
                         </a:rPr>
                         <a:t>0.040</a:t>
                       </a:r>
-                      <a:endParaRPr lang="en-US" sz="1500" dirty="0">
+                      <a:endParaRPr lang="en-US" sz="1400" dirty="0">
                         <a:latin typeface="Calibri" charset="0"/>
                         <a:ea typeface="Calibri" charset="0"/>
                         <a:cs typeface="Calibri" charset="0"/>
@@ -26539,7 +27493,7 @@
                         <a:buNone/>
                       </a:pPr>
                       <a:r>
-                        <a:rPr lang="en-US" sz="1500" dirty="0">
+                        <a:rPr lang="en-US" sz="1400" dirty="0">
                           <a:solidFill>
                             <a:srgbClr val="1F1A33"/>
                           </a:solidFill>
@@ -26549,7 +27503,7 @@
                         </a:rPr>
                         <a:t>65.7</a:t>
                       </a:r>
-                      <a:endParaRPr lang="en-US" sz="1500" dirty="0">
+                      <a:endParaRPr lang="en-US" sz="1400" dirty="0">
                         <a:latin typeface="Calibri" charset="0"/>
                         <a:ea typeface="Calibri" charset="0"/>
                         <a:cs typeface="Calibri" charset="0"/>
@@ -26607,7 +27561,7 @@
                         <a:buNone/>
                       </a:pPr>
                       <a:r>
-                        <a:rPr lang="en-US" sz="1500" b="1" dirty="0">
+                        <a:rPr lang="en-US" sz="1400" b="1" dirty="0">
                           <a:solidFill>
                             <a:srgbClr val="E0457B"/>
                           </a:solidFill>
@@ -26615,9 +27569,9 @@
                           <a:ea typeface="Calibri" pitchFamily="34" charset="-122"/>
                           <a:cs typeface="Calibri" pitchFamily="34" charset="-120"/>
                         </a:rPr>
-                        <a:t>0.105</a:t>
+                        <a:t>0.138</a:t>
                       </a:r>
-                      <a:endParaRPr lang="en-US" sz="1500" dirty="0">
+                      <a:endParaRPr lang="en-US" sz="1400" dirty="0">
                         <a:latin typeface="Calibri" charset="0"/>
                         <a:ea typeface="Calibri" charset="0"/>
                         <a:cs typeface="Calibri" charset="0"/>
@@ -26675,7 +27629,7 @@
                         <a:buNone/>
                       </a:pPr>
                       <a:r>
-                        <a:rPr lang="en-US" sz="1500" dirty="0">
+                        <a:rPr lang="en-US" sz="1400" dirty="0">
                           <a:solidFill>
                             <a:srgbClr val="1F1A33"/>
                           </a:solidFill>
@@ -26683,9 +27637,145 @@
                           <a:ea typeface="Calibri" pitchFamily="34" charset="-122"/>
                           <a:cs typeface="Calibri" pitchFamily="34" charset="-120"/>
                         </a:rPr>
-                        <a:t>42.3</a:t>
+                        <a:t>35.7</a:t>
                       </a:r>
-                      <a:endParaRPr lang="en-US" sz="1500" dirty="0">
+                      <a:endParaRPr lang="en-US" sz="1400" dirty="0">
+                        <a:latin typeface="Calibri" charset="0"/>
+                        <a:ea typeface="Calibri" charset="0"/>
+                        <a:cs typeface="Calibri" charset="0"/>
+                      </a:endParaRPr>
+                    </a:p>
+                  </a:txBody>
+                  <a:tcPr marL="91440" marR="91440" marT="45720" marB="45720" anchor="ctr">
+                    <a:lnL w="19050" cap="flat" cmpd="sng" algn="ctr">
+                      <a:solidFill>
+                        <a:srgbClr val="FFFFFF"/>
+                      </a:solidFill>
+                      <a:prstDash val="solid"/>
+                      <a:round/>
+                      <a:headEnd type="none" w="med" len="med"/>
+                      <a:tailEnd type="none" w="med" len="med"/>
+                    </a:lnL>
+                    <a:lnR w="19050" cap="flat" cmpd="sng" algn="ctr">
+                      <a:solidFill>
+                        <a:srgbClr val="FFFFFF"/>
+                      </a:solidFill>
+                      <a:prstDash val="solid"/>
+                      <a:round/>
+                      <a:headEnd type="none" w="med" len="med"/>
+                      <a:tailEnd type="none" w="med" len="med"/>
+                    </a:lnR>
+                    <a:lnT w="19050" cap="flat" cmpd="sng" algn="ctr">
+                      <a:solidFill>
+                        <a:srgbClr val="FFFFFF"/>
+                      </a:solidFill>
+                      <a:prstDash val="solid"/>
+                      <a:round/>
+                      <a:headEnd type="none" w="med" len="med"/>
+                      <a:tailEnd type="none" w="med" len="med"/>
+                    </a:lnT>
+                    <a:lnB w="19050" cap="flat" cmpd="sng" algn="ctr">
+                      <a:solidFill>
+                        <a:srgbClr val="FFFFFF"/>
+                      </a:solidFill>
+                      <a:prstDash val="solid"/>
+                      <a:round/>
+                      <a:headEnd type="none" w="med" len="med"/>
+                      <a:tailEnd type="none" w="med" len="med"/>
+                    </a:lnB>
+                    <a:solidFill>
+                      <a:srgbClr val="EAF6F4"/>
+                    </a:solidFill>
+                  </a:tcPr>
+                </a:tc>
+                <a:tc>
+                  <a:txBody>
+                    <a:bodyPr/>
+                    <a:lstStyle/>
+                    <a:p>
+                      <a:pPr algn="ctr" indent="0" marL="0">
+                        <a:buNone/>
+                      </a:pPr>
+                      <a:r>
+                        <a:rPr lang="en-US" sz="1400" b="1" dirty="0">
+                          <a:solidFill>
+                            <a:srgbClr val="E0457B"/>
+                          </a:solidFill>
+                          <a:latin typeface="Calibri" pitchFamily="34" charset="0"/>
+                          <a:ea typeface="Calibri" pitchFamily="34" charset="-122"/>
+                          <a:cs typeface="Calibri" pitchFamily="34" charset="-120"/>
+                        </a:rPr>
+                        <a:t>0.080</a:t>
+                      </a:r>
+                      <a:endParaRPr lang="en-US" sz="1400" dirty="0">
+                        <a:latin typeface="Calibri" charset="0"/>
+                        <a:ea typeface="Calibri" charset="0"/>
+                        <a:cs typeface="Calibri" charset="0"/>
+                      </a:endParaRPr>
+                    </a:p>
+                  </a:txBody>
+                  <a:tcPr marL="91440" marR="91440" marT="45720" marB="45720" anchor="ctr">
+                    <a:lnL w="19050" cap="flat" cmpd="sng" algn="ctr">
+                      <a:solidFill>
+                        <a:srgbClr val="FFFFFF"/>
+                      </a:solidFill>
+                      <a:prstDash val="solid"/>
+                      <a:round/>
+                      <a:headEnd type="none" w="med" len="med"/>
+                      <a:tailEnd type="none" w="med" len="med"/>
+                    </a:lnL>
+                    <a:lnR w="19050" cap="flat" cmpd="sng" algn="ctr">
+                      <a:solidFill>
+                        <a:srgbClr val="FFFFFF"/>
+                      </a:solidFill>
+                      <a:prstDash val="solid"/>
+                      <a:round/>
+                      <a:headEnd type="none" w="med" len="med"/>
+                      <a:tailEnd type="none" w="med" len="med"/>
+                    </a:lnR>
+                    <a:lnT w="19050" cap="flat" cmpd="sng" algn="ctr">
+                      <a:solidFill>
+                        <a:srgbClr val="FFFFFF"/>
+                      </a:solidFill>
+                      <a:prstDash val="solid"/>
+                      <a:round/>
+                      <a:headEnd type="none" w="med" len="med"/>
+                      <a:tailEnd type="none" w="med" len="med"/>
+                    </a:lnT>
+                    <a:lnB w="19050" cap="flat" cmpd="sng" algn="ctr">
+                      <a:solidFill>
+                        <a:srgbClr val="FFFFFF"/>
+                      </a:solidFill>
+                      <a:prstDash val="solid"/>
+                      <a:round/>
+                      <a:headEnd type="none" w="med" len="med"/>
+                      <a:tailEnd type="none" w="med" len="med"/>
+                    </a:lnB>
+                    <a:solidFill>
+                      <a:srgbClr val="EAF6F4"/>
+                    </a:solidFill>
+                  </a:tcPr>
+                </a:tc>
+                <a:tc>
+                  <a:txBody>
+                    <a:bodyPr/>
+                    <a:lstStyle/>
+                    <a:p>
+                      <a:pPr algn="ctr" indent="0" marL="0">
+                        <a:buNone/>
+                      </a:pPr>
+                      <a:r>
+                        <a:rPr lang="en-US" sz="1400" dirty="0">
+                          <a:solidFill>
+                            <a:srgbClr val="1F1A33"/>
+                          </a:solidFill>
+                          <a:latin typeface="Calibri" pitchFamily="34" charset="0"/>
+                          <a:ea typeface="Calibri" pitchFamily="34" charset="-122"/>
+                          <a:cs typeface="Calibri" pitchFamily="34" charset="-120"/>
+                        </a:rPr>
+                        <a:t>48.9</a:t>
+                      </a:r>
+                      <a:endParaRPr lang="en-US" sz="1400" dirty="0">
                         <a:latin typeface="Calibri" charset="0"/>
                         <a:ea typeface="Calibri" charset="0"/>
                         <a:cs typeface="Calibri" charset="0"/>
@@ -26748,7 +27838,7 @@
         <p:spPr>
           <a:xfrm>
             <a:off x="457200" y="5577840"/>
-            <a:ext cx="7223760" cy="274320"/>
+            <a:ext cx="7772400" cy="548640"/>
           </a:xfrm>
           <a:prstGeom prst="rect">
             <a:avLst/>
@@ -26772,7 +27862,7 @@
                 <a:ea typeface="Calibri" pitchFamily="34" charset="-122"/>
                 <a:cs typeface="Calibri" pitchFamily="34" charset="-120"/>
               </a:rPr>
-              <a:t>Mean of all 8 images.</a:t>
+              <a:t>LBG: mean of the 8 images. Total: mean of the 4 grayscale and of the 4 color images, separately. KF = Karp–Flatt, Eff. = efficiency.</a:t>
             </a:r>
             <a:endParaRPr lang="en-US" sz="1200" dirty="0"/>
           </a:p>
@@ -26786,12 +27876,12 @@
         </p:nvSpPr>
         <p:spPr>
           <a:xfrm>
-            <a:off x="7909560" y="1280160"/>
-            <a:ext cx="3840480" cy="4572000"/>
+            <a:off x="8458200" y="1280160"/>
+            <a:ext cx="3291840" cy="4846320"/>
           </a:xfrm>
           <a:prstGeom prst="roundRect">
             <a:avLst>
-              <a:gd name="adj" fmla="val 1905"/>
+              <a:gd name="adj" fmla="val 2222"/>
             </a:avLst>
           </a:prstGeom>
           <a:solidFill>
@@ -26813,8 +27903,8 @@
         </p:nvSpPr>
         <p:spPr>
           <a:xfrm>
-            <a:off x="8001000" y="1371600"/>
-            <a:ext cx="3657600" cy="4389120"/>
+            <a:off x="8549640" y="1371600"/>
+            <a:ext cx="3108960" cy="4663440"/>
           </a:xfrm>
           <a:prstGeom prst="rect">
             <a:avLst/>
@@ -26834,7 +27924,7 @@
               <a:buChar char="■"/>
             </a:pPr>
             <a:r>
-              <a:rPr lang="en-US" sz="1500" dirty="0">
+              <a:rPr lang="en-US" sz="1400" dirty="0">
                 <a:solidFill>
                   <a:srgbClr val="1F1A33"/>
                 </a:solidFill>
@@ -26844,7 +27934,7 @@
               </a:rPr>
               <a:t>Karp–Flatt estimates the serial fraction of the program from the measured speedup.</a:t>
             </a:r>
-            <a:endParaRPr lang="en-US" sz="1500" dirty="0"/>
+            <a:endParaRPr lang="en-US" sz="1400" dirty="0"/>
           </a:p>
           <a:p>
             <a:pPr marL="342900" indent="-342900">
@@ -26855,7 +27945,7 @@
               <a:buChar char="■"/>
             </a:pPr>
             <a:r>
-              <a:rPr lang="en-US" sz="1500" dirty="0">
+              <a:rPr lang="en-US" sz="1400" dirty="0">
                 <a:solidFill>
                   <a:srgbClr val="1F1A33"/>
                 </a:solidFill>
@@ -26865,7 +27955,7 @@
               </a:rPr>
               <a:t>LBG: about 0.04 for P ≥ 8; the serial fraction stays small and does not grow with P.</a:t>
             </a:r>
-            <a:endParaRPr lang="en-US" sz="1500" dirty="0"/>
+            <a:endParaRPr lang="en-US" sz="1400" dirty="0"/>
           </a:p>
           <a:p>
             <a:pPr marL="342900" indent="-342900">
@@ -26876,7 +27966,7 @@
               <a:buChar char="■"/>
             </a:pPr>
             <a:r>
-              <a:rPr lang="en-US" sz="1500" dirty="0">
+              <a:rPr lang="en-US" sz="1400" dirty="0">
                 <a:solidFill>
                   <a:srgbClr val="1F1A33"/>
                 </a:solidFill>
@@ -26884,9 +27974,9 @@
                 <a:ea typeface="Calibri" pitchFamily="34" charset="-122"/>
                 <a:cs typeface="Calibri" pitchFamily="34" charset="-120"/>
               </a:rPr>
-              <a:t>Total: about 0.105 (gray ≈ 0.14, color ≈ 0.08); the sequential coding and reconstruction stages dominate.</a:t>
-            </a:r>
-            <a:endParaRPr lang="en-US" sz="1500" dirty="0"/>
+              <a:t>Total: about 0.14 (gray) and 0.08 (color); the sequential coding and reconstruction stages dominate.</a:t>
+            </a:r>
+            <a:endParaRPr lang="en-US" sz="1400" dirty="0"/>
           </a:p>
           <a:p>
             <a:pPr marL="342900" indent="-342900">
@@ -26897,7 +27987,7 @@
               <a:buChar char="■"/>
             </a:pPr>
             <a:r>
-              <a:rPr lang="en-US" sz="1500" dirty="0">
+              <a:rPr lang="en-US" sz="1400" dirty="0">
                 <a:solidFill>
                   <a:srgbClr val="1F1A33"/>
                 </a:solidFill>
@@ -26905,9 +27995,9 @@
                 <a:ea typeface="Calibri" pitchFamily="34" charset="-122"/>
                 <a:cs typeface="Calibri" pitchFamily="34" charset="-120"/>
               </a:rPr>
-              <a:t>This explains why the total speedup (5.00× gray, 6.84× color) is lower than the LBG speedup (9.19×).</a:t>
-            </a:r>
-            <a:endParaRPr lang="en-US" sz="1500" dirty="0"/>
+              <a:t>Color is lower because LBG is a larger share of its time (81% against 77%).</a:t>
+            </a:r>
+            <a:endParaRPr lang="en-US" sz="1400" dirty="0"/>
           </a:p>
         </p:txBody>
       </p:sp>

</xml_diff>

<commit_message>
Seminar v3 audit fixes: LBG share wording, epsilon notation, test-image layout, adaptive run footnote
Co-Authored-By: Claude Sonnet 5.5 <noreply@anthropic.com>
Claude-Session: https://claude.ai/code/session_01T6gEewJ8YaCdmnsfS34RJd
</commit_message>
<xml_diff>
--- a/results/seminar/figs/Seminar_Ibtihal_v3.pptx
+++ b/results/seminar/figs/Seminar_Ibtihal_v3.pptx
@@ -7313,7 +7313,7 @@
                 <a:ea typeface="Calibri" pitchFamily="34" charset="-122"/>
                 <a:cs typeface="Calibri" pitchFamily="34" charset="-120"/>
               </a:rPr>
-              <a:t>Nearest-codeword assignment is local: about 77% of the sequential time (gray).</a:t>
+              <a:t>Nearest-codeword assignment is local and is the main cost of LBG, which takes about 77% of the sequential time (gray).</a:t>
             </a:r>
             <a:endParaRPr lang="en-US" sz="1400" dirty="0"/>
           </a:p>
@@ -9952,7 +9952,7 @@
                 <a:ea typeface="Calibri" pitchFamily="34" charset="-122"/>
                 <a:cs typeface="Calibri" pitchFamily="34" charset="-120"/>
               </a:rPr>
-              <a:t>4 × 4 blocks, K = 64 codewords, δ = 0.01, ε = 10⁻⁴ (relative improvement in distortion), at most 100 iterations per level.</a:t>
+              <a:t>4 × 4 blocks, K = 64 codewords, δ = 0.01, ε = 0.0001 (relative improvement in distortion), at most 100 iterations per level.</a:t>
             </a:r>
             <a:endParaRPr lang="en-US" sz="2000" dirty="0"/>
           </a:p>
@@ -13321,8 +13321,8 @@
         </p:nvSpPr>
         <p:spPr>
           <a:xfrm>
-            <a:off x="457200" y="1143000"/>
-            <a:ext cx="5486400" cy="320040"/>
+            <a:off x="457200" y="1097280"/>
+            <a:ext cx="5486400" cy="292608"/>
           </a:xfrm>
           <a:prstGeom prst="rect">
             <a:avLst/>
@@ -13360,8 +13360,8 @@
         </p:nvSpPr>
         <p:spPr>
           <a:xfrm>
-            <a:off x="457200" y="1508760"/>
-            <a:ext cx="2286000" cy="2286000"/>
+            <a:off x="457200" y="1417320"/>
+            <a:ext cx="2103120" cy="2103120"/>
           </a:xfrm>
           <a:prstGeom prst="rect">
             <a:avLst/>
@@ -13385,8 +13385,8 @@
         </p:nvSpPr>
         <p:spPr>
           <a:xfrm>
-            <a:off x="457200" y="1508760"/>
-            <a:ext cx="2286000" cy="2286000"/>
+            <a:off x="457200" y="1417320"/>
+            <a:ext cx="2103120" cy="2103120"/>
           </a:xfrm>
           <a:prstGeom prst="rect">
             <a:avLst/>
@@ -13424,8 +13424,8 @@
         </p:nvSpPr>
         <p:spPr>
           <a:xfrm>
-            <a:off x="457200" y="3813048"/>
-            <a:ext cx="2286000" cy="274320"/>
+            <a:off x="457200" y="3547872"/>
+            <a:ext cx="2103120" cy="274320"/>
           </a:xfrm>
           <a:prstGeom prst="rect">
             <a:avLst/>
@@ -13463,8 +13463,8 @@
         </p:nvSpPr>
         <p:spPr>
           <a:xfrm>
-            <a:off x="3291840" y="1508760"/>
-            <a:ext cx="2286000" cy="2286000"/>
+            <a:off x="3291840" y="1417320"/>
+            <a:ext cx="2103120" cy="2103120"/>
           </a:xfrm>
           <a:prstGeom prst="rect">
             <a:avLst/>
@@ -13488,8 +13488,8 @@
         </p:nvSpPr>
         <p:spPr>
           <a:xfrm>
-            <a:off x="3291840" y="1508760"/>
-            <a:ext cx="2286000" cy="2286000"/>
+            <a:off x="3291840" y="1417320"/>
+            <a:ext cx="2103120" cy="2103120"/>
           </a:xfrm>
           <a:prstGeom prst="rect">
             <a:avLst/>
@@ -13527,8 +13527,8 @@
         </p:nvSpPr>
         <p:spPr>
           <a:xfrm>
-            <a:off x="3291840" y="3813048"/>
-            <a:ext cx="2286000" cy="274320"/>
+            <a:off x="3291840" y="3547872"/>
+            <a:ext cx="2103120" cy="274320"/>
           </a:xfrm>
           <a:prstGeom prst="rect">
             <a:avLst/>
@@ -13566,8 +13566,8 @@
         </p:nvSpPr>
         <p:spPr>
           <a:xfrm>
-            <a:off x="6126480" y="1508760"/>
-            <a:ext cx="2286000" cy="2286000"/>
+            <a:off x="6126480" y="1417320"/>
+            <a:ext cx="2103120" cy="2103120"/>
           </a:xfrm>
           <a:prstGeom prst="rect">
             <a:avLst/>
@@ -13591,8 +13591,8 @@
         </p:nvSpPr>
         <p:spPr>
           <a:xfrm>
-            <a:off x="6126480" y="1508760"/>
-            <a:ext cx="2286000" cy="2286000"/>
+            <a:off x="6126480" y="1417320"/>
+            <a:ext cx="2103120" cy="2103120"/>
           </a:xfrm>
           <a:prstGeom prst="rect">
             <a:avLst/>
@@ -13630,8 +13630,8 @@
         </p:nvSpPr>
         <p:spPr>
           <a:xfrm>
-            <a:off x="6126480" y="3813048"/>
-            <a:ext cx="2286000" cy="274320"/>
+            <a:off x="6126480" y="3547872"/>
+            <a:ext cx="2103120" cy="274320"/>
           </a:xfrm>
           <a:prstGeom prst="rect">
             <a:avLst/>
@@ -13669,8 +13669,8 @@
         </p:nvSpPr>
         <p:spPr>
           <a:xfrm>
-            <a:off x="8961120" y="1508760"/>
-            <a:ext cx="2286000" cy="2286000"/>
+            <a:off x="8961120" y="1417320"/>
+            <a:ext cx="2103120" cy="2103120"/>
           </a:xfrm>
           <a:prstGeom prst="rect">
             <a:avLst/>
@@ -13694,8 +13694,8 @@
         </p:nvSpPr>
         <p:spPr>
           <a:xfrm>
-            <a:off x="8961120" y="1508760"/>
-            <a:ext cx="2286000" cy="2286000"/>
+            <a:off x="8961120" y="1417320"/>
+            <a:ext cx="2103120" cy="2103120"/>
           </a:xfrm>
           <a:prstGeom prst="rect">
             <a:avLst/>
@@ -13733,8 +13733,8 @@
         </p:nvSpPr>
         <p:spPr>
           <a:xfrm>
-            <a:off x="8961120" y="3813048"/>
-            <a:ext cx="2286000" cy="274320"/>
+            <a:off x="8961120" y="3547872"/>
+            <a:ext cx="2103120" cy="274320"/>
           </a:xfrm>
           <a:prstGeom prst="rect">
             <a:avLst/>
@@ -13773,7 +13773,7 @@
         <p:spPr>
           <a:xfrm>
             <a:off x="457200" y="3886200"/>
-            <a:ext cx="5486400" cy="320040"/>
+            <a:ext cx="5486400" cy="292608"/>
           </a:xfrm>
           <a:prstGeom prst="rect">
             <a:avLst/>
@@ -13811,8 +13811,8 @@
         </p:nvSpPr>
         <p:spPr>
           <a:xfrm>
-            <a:off x="457200" y="4251960"/>
-            <a:ext cx="2286000" cy="2286000"/>
+            <a:off x="457200" y="4206240"/>
+            <a:ext cx="2103120" cy="2103120"/>
           </a:xfrm>
           <a:prstGeom prst="rect">
             <a:avLst/>
@@ -13836,8 +13836,8 @@
         </p:nvSpPr>
         <p:spPr>
           <a:xfrm>
-            <a:off x="457200" y="4251960"/>
-            <a:ext cx="2286000" cy="2286000"/>
+            <a:off x="457200" y="4206240"/>
+            <a:ext cx="2103120" cy="2103120"/>
           </a:xfrm>
           <a:prstGeom prst="rect">
             <a:avLst/>
@@ -13875,8 +13875,8 @@
         </p:nvSpPr>
         <p:spPr>
           <a:xfrm>
-            <a:off x="457200" y="6556248"/>
-            <a:ext cx="2286000" cy="274320"/>
+            <a:off x="457200" y="6336792"/>
+            <a:ext cx="2103120" cy="274320"/>
           </a:xfrm>
           <a:prstGeom prst="rect">
             <a:avLst/>
@@ -13914,8 +13914,8 @@
         </p:nvSpPr>
         <p:spPr>
           <a:xfrm>
-            <a:off x="3291840" y="4251960"/>
-            <a:ext cx="2286000" cy="2286000"/>
+            <a:off x="3291840" y="4206240"/>
+            <a:ext cx="2103120" cy="2103120"/>
           </a:xfrm>
           <a:prstGeom prst="rect">
             <a:avLst/>
@@ -13939,8 +13939,8 @@
         </p:nvSpPr>
         <p:spPr>
           <a:xfrm>
-            <a:off x="3291840" y="4251960"/>
-            <a:ext cx="2286000" cy="2286000"/>
+            <a:off x="3291840" y="4206240"/>
+            <a:ext cx="2103120" cy="2103120"/>
           </a:xfrm>
           <a:prstGeom prst="rect">
             <a:avLst/>
@@ -13978,8 +13978,8 @@
         </p:nvSpPr>
         <p:spPr>
           <a:xfrm>
-            <a:off x="3291840" y="6556248"/>
-            <a:ext cx="2286000" cy="274320"/>
+            <a:off x="3291840" y="6336792"/>
+            <a:ext cx="2103120" cy="274320"/>
           </a:xfrm>
           <a:prstGeom prst="rect">
             <a:avLst/>
@@ -14017,8 +14017,8 @@
         </p:nvSpPr>
         <p:spPr>
           <a:xfrm>
-            <a:off x="6126480" y="4251960"/>
-            <a:ext cx="2286000" cy="2286000"/>
+            <a:off x="6126480" y="4206240"/>
+            <a:ext cx="2103120" cy="2103120"/>
           </a:xfrm>
           <a:prstGeom prst="rect">
             <a:avLst/>
@@ -14042,8 +14042,8 @@
         </p:nvSpPr>
         <p:spPr>
           <a:xfrm>
-            <a:off x="6126480" y="4251960"/>
-            <a:ext cx="2286000" cy="2286000"/>
+            <a:off x="6126480" y="4206240"/>
+            <a:ext cx="2103120" cy="2103120"/>
           </a:xfrm>
           <a:prstGeom prst="rect">
             <a:avLst/>
@@ -14081,8 +14081,8 @@
         </p:nvSpPr>
         <p:spPr>
           <a:xfrm>
-            <a:off x="6126480" y="6556248"/>
-            <a:ext cx="2286000" cy="274320"/>
+            <a:off x="6126480" y="6336792"/>
+            <a:ext cx="2103120" cy="274320"/>
           </a:xfrm>
           <a:prstGeom prst="rect">
             <a:avLst/>
@@ -14120,8 +14120,8 @@
         </p:nvSpPr>
         <p:spPr>
           <a:xfrm>
-            <a:off x="8961120" y="4251960"/>
-            <a:ext cx="2286000" cy="2286000"/>
+            <a:off x="8961120" y="4206240"/>
+            <a:ext cx="2103120" cy="2103120"/>
           </a:xfrm>
           <a:prstGeom prst="rect">
             <a:avLst/>
@@ -14145,8 +14145,8 @@
         </p:nvSpPr>
         <p:spPr>
           <a:xfrm>
-            <a:off x="8961120" y="4251960"/>
-            <a:ext cx="2286000" cy="2286000"/>
+            <a:off x="8961120" y="4206240"/>
+            <a:ext cx="2103120" cy="2103120"/>
           </a:xfrm>
           <a:prstGeom prst="rect">
             <a:avLst/>
@@ -14184,8 +14184,8 @@
         </p:nvSpPr>
         <p:spPr>
           <a:xfrm>
-            <a:off x="8961120" y="6556248"/>
-            <a:ext cx="2286000" cy="274320"/>
+            <a:off x="8961120" y="6336792"/>
+            <a:ext cx="2103120" cy="274320"/>
           </a:xfrm>
           <a:prstGeom prst="rect">
             <a:avLst/>
@@ -14402,7 +14402,7 @@
               <a:buNone/>
             </a:pPr>
             <a:r>
-              <a:rPr lang="en-US" sz="1500" b="1" dirty="0">
+              <a:rPr lang="en-US" sz="1400" b="1" dirty="0">
                 <a:solidFill>
                   <a:srgbClr val="2E2055"/>
                 </a:solidFill>
@@ -14412,7 +14412,7 @@
               </a:rPr>
               <a:t>Original</a:t>
             </a:r>
-            <a:endParaRPr lang="en-US" sz="1500" dirty="0"/>
+            <a:endParaRPr lang="en-US" sz="1400" dirty="0"/>
           </a:p>
         </p:txBody>
       </p:sp>
@@ -14424,8 +14424,8 @@
         </p:nvSpPr>
         <p:spPr>
           <a:xfrm>
-            <a:off x="411480" y="3840480"/>
-            <a:ext cx="1097280" cy="2331720"/>
+            <a:off x="320040" y="3840480"/>
+            <a:ext cx="1234440" cy="2331720"/>
           </a:xfrm>
           <a:prstGeom prst="rect">
             <a:avLst/>
@@ -14441,7 +14441,7 @@
               <a:buNone/>
             </a:pPr>
             <a:r>
-              <a:rPr lang="en-US" sz="1500" b="1" dirty="0">
+              <a:rPr lang="en-US" sz="1300" b="1" dirty="0">
                 <a:solidFill>
                   <a:srgbClr val="2E2055"/>
                 </a:solidFill>
@@ -14451,7 +14451,7 @@
               </a:rPr>
               <a:t>Reconstructed</a:t>
             </a:r>
-            <a:endParaRPr lang="en-US" sz="1500" dirty="0"/>
+            <a:endParaRPr lang="en-US" sz="1300" dirty="0"/>
           </a:p>
         </p:txBody>
       </p:sp>
@@ -15534,7 +15534,7 @@
               <a:buNone/>
             </a:pPr>
             <a:r>
-              <a:rPr lang="en-US" sz="1500" b="1" dirty="0">
+              <a:rPr lang="en-US" sz="1400" b="1" dirty="0">
                 <a:solidFill>
                   <a:srgbClr val="2E2055"/>
                 </a:solidFill>
@@ -15544,7 +15544,7 @@
               </a:rPr>
               <a:t>Original</a:t>
             </a:r>
-            <a:endParaRPr lang="en-US" sz="1500" dirty="0"/>
+            <a:endParaRPr lang="en-US" sz="1400" dirty="0"/>
           </a:p>
         </p:txBody>
       </p:sp>
@@ -15556,8 +15556,8 @@
         </p:nvSpPr>
         <p:spPr>
           <a:xfrm>
-            <a:off x="411480" y="3840480"/>
-            <a:ext cx="1097280" cy="2331720"/>
+            <a:off x="320040" y="3840480"/>
+            <a:ext cx="1234440" cy="2331720"/>
           </a:xfrm>
           <a:prstGeom prst="rect">
             <a:avLst/>
@@ -15573,7 +15573,7 @@
               <a:buNone/>
             </a:pPr>
             <a:r>
-              <a:rPr lang="en-US" sz="1500" b="1" dirty="0">
+              <a:rPr lang="en-US" sz="1300" b="1" dirty="0">
                 <a:solidFill>
                   <a:srgbClr val="2E2055"/>
                 </a:solidFill>
@@ -15583,7 +15583,7 @@
               </a:rPr>
               <a:t>Reconstructed</a:t>
             </a:r>
-            <a:endParaRPr lang="en-US" sz="1500" dirty="0"/>
+            <a:endParaRPr lang="en-US" sz="1300" dirty="0"/>
           </a:p>
         </p:txBody>
       </p:sp>
@@ -23005,7 +23005,7 @@
                 <a:ea typeface="Calibri" pitchFamily="34" charset="-122"/>
                 <a:cs typeface="Calibri" pitchFamily="34" charset="-120"/>
               </a:rPr>
-              <a:t>It is lower than the LBG speedup (9.19×) because delta coding, Huffman coding and reconstruction remain sequential.</a:t>
+              <a:t>It is lower than the LBG speedup (9.19×) because the other stages (image reading, delta and Huffman coding, reconstruction) remain sequential.</a:t>
             </a:r>
             <a:endParaRPr lang="en-US" sz="1500" dirty="0"/>
           </a:p>
@@ -23047,7 +23047,7 @@
                 <a:ea typeface="Calibri" pitchFamily="34" charset="-122"/>
                 <a:cs typeface="Calibri" pitchFamily="34" charset="-120"/>
               </a:rPr>
-              <a:t>Total time includes all compression stages; the shaded bands show the minimum to maximum over the images of each type.</a:t>
+              <a:t>Total time is the whole program execution; the shaded bands show the minimum to maximum over the images of each type.</a:t>
             </a:r>
             <a:endParaRPr lang="en-US" sz="1500" dirty="0"/>
           </a:p>
@@ -23436,6 +23436,27 @@
                 <a:cs typeface="Calibri" pitchFamily="34" charset="-120"/>
               </a:rPr>
               <a:t>The reconstructed images are identical in both cases.</a:t>
+            </a:r>
+            <a:endParaRPr lang="en-US" sz="1500" dirty="0"/>
+          </a:p>
+          <a:p>
+            <a:pPr marL="342900" indent="-342900">
+              <a:spcAft>
+                <a:spcPts val="800"/>
+              </a:spcAft>
+              <a:buSzPct val="100000"/>
+              <a:buChar char="■"/>
+            </a:pPr>
+            <a:r>
+              <a:rPr lang="en-US" sz="1500" dirty="0">
+                <a:solidFill>
+                  <a:srgbClr val="1F1A33"/>
+                </a:solidFill>
+                <a:latin typeface="Calibri" pitchFamily="34" charset="0"/>
+                <a:ea typeface="Calibri" pitchFamily="34" charset="-122"/>
+                <a:cs typeface="Calibri" pitchFamily="34" charset="-120"/>
+              </a:rPr>
+              <a:t>Adaptive values here come from the Equal-vs-Adaptive runs, so they can differ by up to 0.02× from the main speedup runs.</a:t>
             </a:r>
             <a:endParaRPr lang="en-US" sz="1500" dirty="0"/>
           </a:p>

</xml_diff>